<commit_message>
new file:   draft_welcome/images/tall.jpg 	new file:   draft_welcome/images/wide.jpg 	new file:   draft_welcome/index.htm 	modified:   place_items/index.htm 	modified:   slideshow/CDashSlideshow_20230109.pptx
</commit_message>
<xml_diff>
--- a/slideshow/CDashSlideshow_20230109.pptx
+++ b/slideshow/CDashSlideshow_20230109.pptx
@@ -4812,7 +4812,7 @@
                 </a:solidFill>
                 <a:latin typeface="Calibri"/>
               </a:rPr>
-              <a:t>1/9/2023</a:t>
+              <a:t>4/17/2023</a:t>
             </a:fld>
             <a:endParaRPr lang="en-US" sz="1200" b="0" strike="noStrike" spc="-1">
               <a:latin typeface="Times New Roman"/>
@@ -5684,7 +5684,7 @@
                 </a:solidFill>
                 <a:latin typeface="Calibri"/>
               </a:rPr>
-              <a:t>1/9/2023</a:t>
+              <a:t>4/17/2023</a:t>
             </a:fld>
             <a:endParaRPr lang="en-US" sz="1200" b="0" strike="noStrike" spc="-1">
               <a:latin typeface="Times New Roman"/>
@@ -6182,7 +6182,7 @@
                 </a:solidFill>
                 <a:latin typeface="Calibri"/>
               </a:rPr>
-              <a:t>1/9/2023</a:t>
+              <a:t>4/17/2023</a:t>
             </a:fld>
             <a:endParaRPr lang="en-US" sz="1200" b="0" strike="noStrike" spc="-1">
               <a:latin typeface="Times New Roman"/>
@@ -7205,7 +7205,7 @@
                 </a:solidFill>
                 <a:latin typeface="Calibri"/>
               </a:rPr>
-              <a:t>1/9/2023</a:t>
+              <a:t>4/17/2023</a:t>
             </a:fld>
             <a:endParaRPr lang="en-US" sz="1200" b="0" strike="noStrike" spc="-1">
               <a:latin typeface="Times New Roman"/>
@@ -8339,7 +8339,7 @@
                 </a:solidFill>
                 <a:latin typeface="Calibri"/>
               </a:rPr>
-              <a:t>1/9/2023</a:t>
+              <a:t>4/17/2023</a:t>
             </a:fld>
             <a:endParaRPr lang="en-US" sz="1200" b="0" strike="noStrike" spc="-1">
               <a:latin typeface="Times New Roman"/>
@@ -9317,7 +9317,7 @@
                 </a:solidFill>
                 <a:latin typeface="Calibri"/>
               </a:rPr>
-              <a:t>1/9/2023</a:t>
+              <a:t>4/17/2023</a:t>
             </a:fld>
             <a:endParaRPr lang="en-US" sz="1200" b="0" strike="noStrike" spc="-1">
               <a:latin typeface="Times New Roman"/>
@@ -12373,7 +12373,7 @@
                 </a:solidFill>
                 <a:latin typeface="Calibri"/>
               </a:rPr>
-              <a:t>1/9/2023</a:t>
+              <a:t>4/17/2023</a:t>
             </a:fld>
             <a:endParaRPr lang="en-US" sz="1200" b="0" strike="noStrike" spc="-1">
               <a:latin typeface="Times New Roman"/>
@@ -12779,7 +12779,7 @@
                 </a:solidFill>
                 <a:latin typeface="Calibri"/>
               </a:rPr>
-              <a:t>A CDASH Document Item Accession Package</a:t>
+              <a:t>A CDASH Document Item Accession Package (Batch) </a:t>
             </a:r>
             <a:endParaRPr lang="en-US" sz="2400" b="0" strike="noStrike" spc="-1" dirty="0">
               <a:solidFill>
@@ -15089,7 +15089,7 @@
                 </a:solidFill>
                 <a:latin typeface="Calibri"/>
               </a:rPr>
-              <a:t>1/9/2023</a:t>
+              <a:t>4/17/2023</a:t>
             </a:fld>
             <a:endParaRPr lang="en-US" sz="1200" b="0" strike="noStrike" spc="-1">
               <a:latin typeface="Times New Roman"/>
@@ -15151,7 +15151,7 @@
 </file>
 
 <file path=ppt/slides/slide21.xml><?xml version="1.0" encoding="utf-8"?>
-<p:sld xmlns:a="http://schemas.openxmlformats.org/drawingml/2006/main" xmlns:r="http://schemas.openxmlformats.org/officeDocument/2006/relationships" xmlns:p="http://schemas.openxmlformats.org/presentationml/2006/main">
+<p:sld xmlns:a="http://schemas.openxmlformats.org/drawingml/2006/main" xmlns:r="http://schemas.openxmlformats.org/officeDocument/2006/relationships" xmlns:p="http://schemas.openxmlformats.org/presentationml/2006/main" show="0">
   <p:cSld>
     <p:spTree>
       <p:nvGrpSpPr>
@@ -16293,7 +16293,7 @@
                 </a:solidFill>
                 <a:latin typeface="Calibri"/>
               </a:rPr>
-              <a:t>1/9/2023</a:t>
+              <a:t>4/17/2023</a:t>
             </a:fld>
             <a:endParaRPr lang="en-US" sz="1200" b="0" strike="noStrike" spc="-1">
               <a:latin typeface="Times New Roman"/>
@@ -17160,7 +17160,7 @@
                 </a:solidFill>
                 <a:latin typeface="Calibri"/>
               </a:rPr>
-              <a:t>1/9/2023</a:t>
+              <a:t>4/17/2023</a:t>
             </a:fld>
             <a:endParaRPr lang="en-US" sz="1200" b="0" strike="noStrike" spc="-1">
               <a:latin typeface="Times New Roman"/>
@@ -18929,7 +18929,7 @@
                 </a:solidFill>
                 <a:latin typeface="Calibri"/>
               </a:rPr>
-              <a:t>1/9/2023</a:t>
+              <a:t>4/17/2023</a:t>
             </a:fld>
             <a:endParaRPr lang="en-US" sz="1200" b="0" strike="noStrike" spc="-1">
               <a:latin typeface="Times New Roman"/>
@@ -20812,7 +20812,7 @@
                 </a:solidFill>
                 <a:latin typeface="Calibri"/>
               </a:rPr>
-              <a:t>1/9/2023</a:t>
+              <a:t>4/17/2023</a:t>
             </a:fld>
             <a:endParaRPr lang="en-US" sz="1200" b="0" strike="noStrike" spc="-1">
               <a:latin typeface="Times New Roman"/>
@@ -24094,7 +24094,7 @@
                 </a:solidFill>
                 <a:latin typeface="Calibri"/>
               </a:rPr>
-              <a:t>1/9/2023</a:t>
+              <a:t>4/17/2023</a:t>
             </a:fld>
             <a:endParaRPr lang="en-US" sz="1200" b="0" strike="noStrike" spc="-1">
               <a:latin typeface="Times New Roman"/>
@@ -24538,15 +24538,33 @@
               </a:spcAft>
             </a:pPr>
             <a:r>
-              <a:rPr lang="en-US" sz="1800" b="1" strike="noStrike" spc="-1">
+              <a:rPr lang="en-US" sz="1800" b="1" strike="noStrike" spc="-1" dirty="0">
                 <a:solidFill>
                   <a:srgbClr val="2F5597"/>
                 </a:solidFill>
                 <a:latin typeface="Agency FB"/>
               </a:rPr>
-              <a:t>CHC Omeka Owner: (Emily?  Charlie?) </a:t>
-            </a:r>
-            <a:endParaRPr lang="en-US" sz="1800" b="0" strike="noStrike" spc="-1">
+              <a:t>CHC Omeka Owner: (</a:t>
+            </a:r>
+            <a:r>
+              <a:rPr lang="en-US" b="1" spc="-1" dirty="0">
+                <a:solidFill>
+                  <a:srgbClr val="2F5597"/>
+                </a:solidFill>
+                <a:latin typeface="Agency FB"/>
+              </a:rPr>
+              <a:t>Viv</a:t>
+            </a:r>
+            <a:r>
+              <a:rPr lang="en-US" sz="1800" b="1" strike="noStrike" spc="-1" dirty="0">
+                <a:solidFill>
+                  <a:srgbClr val="2F5597"/>
+                </a:solidFill>
+                <a:latin typeface="Agency FB"/>
+              </a:rPr>
+              <a:t>?  Charlie?) </a:t>
+            </a:r>
+            <a:endParaRPr lang="en-US" sz="1800" b="0" strike="noStrike" spc="-1" dirty="0">
               <a:solidFill>
                 <a:srgbClr val="000000"/>
               </a:solidFill>
@@ -24563,7 +24581,7 @@
               </a:spcAft>
             </a:pPr>
             <a:r>
-              <a:rPr lang="en-US" sz="1800" b="1" strike="noStrike" spc="-1">
+              <a:rPr lang="en-US" sz="1800" b="1" strike="noStrike" spc="-1" dirty="0">
                 <a:solidFill>
                   <a:srgbClr val="595959"/>
                 </a:solidFill>
@@ -24571,7 +24589,7 @@
               </a:rPr>
               <a:t>Is responsible for the long term viability of the Omeka installation.</a:t>
             </a:r>
-            <a:endParaRPr lang="en-US" sz="1800" b="0" strike="noStrike" spc="-1">
+            <a:endParaRPr lang="en-US" sz="1800" b="0" strike="noStrike" spc="-1" dirty="0">
               <a:solidFill>
                 <a:srgbClr val="000000"/>
               </a:solidFill>
@@ -24588,7 +24606,7 @@
               </a:spcAft>
             </a:pPr>
             <a:r>
-              <a:rPr lang="en-US" sz="1800" b="1" strike="noStrike" spc="-1">
+              <a:rPr lang="en-US" sz="1800" b="1" strike="noStrike" spc="-1" dirty="0">
                 <a:solidFill>
                   <a:srgbClr val="595959"/>
                 </a:solidFill>
@@ -24596,7 +24614,7 @@
               </a:rPr>
               <a:t>Makes and maintains agreements with the IT department. </a:t>
             </a:r>
-            <a:endParaRPr lang="en-US" sz="1800" b="0" strike="noStrike" spc="-1">
+            <a:endParaRPr lang="en-US" sz="1800" b="0" strike="noStrike" spc="-1" dirty="0">
               <a:solidFill>
                 <a:srgbClr val="000000"/>
               </a:solidFill>
@@ -24613,7 +24631,7 @@
               </a:spcAft>
             </a:pPr>
             <a:r>
-              <a:rPr lang="en-US" sz="1800" b="1" strike="noStrike" spc="-1">
+              <a:rPr lang="en-US" sz="1800" b="1" strike="noStrike" spc="-1" dirty="0">
                 <a:solidFill>
                   <a:srgbClr val="595959"/>
                 </a:solidFill>
@@ -24621,7 +24639,7 @@
               </a:rPr>
               <a:t>Understands executive view of file management, backup and recovery. </a:t>
             </a:r>
-            <a:endParaRPr lang="en-US" sz="1800" b="0" strike="noStrike" spc="-1">
+            <a:endParaRPr lang="en-US" sz="1800" b="0" strike="noStrike" spc="-1" dirty="0">
               <a:solidFill>
                 <a:srgbClr val="000000"/>
               </a:solidFill>
@@ -24643,7 +24661,7 @@
               <a:buChar char="•"/>
             </a:pPr>
             <a:r>
-              <a:rPr lang="en-US" sz="1800" b="1" strike="noStrike" spc="-1">
+              <a:rPr lang="en-US" sz="1800" b="1" strike="noStrike" spc="-1" dirty="0">
                 <a:solidFill>
                   <a:srgbClr val="595959"/>
                 </a:solidFill>
@@ -24651,7 +24669,7 @@
               </a:rPr>
               <a:t>Receives reports of routine snapshot activity </a:t>
             </a:r>
-            <a:endParaRPr lang="en-US" sz="1800" b="0" strike="noStrike" spc="-1">
+            <a:endParaRPr lang="en-US" sz="1800" b="0" strike="noStrike" spc="-1" dirty="0">
               <a:solidFill>
                 <a:srgbClr val="000000"/>
               </a:solidFill>
@@ -24665,7 +24683,7 @@
               </a:lnSpc>
             </a:pPr>
             <a:r>
-              <a:rPr lang="en-US" sz="1800" b="1" strike="noStrike" spc="-1">
+              <a:rPr lang="en-US" sz="1800" b="1" strike="noStrike" spc="-1" dirty="0">
                 <a:solidFill>
                   <a:srgbClr val="2F5597"/>
                 </a:solidFill>
@@ -24673,7 +24691,7 @@
               </a:rPr>
               <a:t>CHC CDASH Administrator (Meta)</a:t>
             </a:r>
-            <a:endParaRPr lang="en-US" sz="1800" b="0" strike="noStrike" spc="-1">
+            <a:endParaRPr lang="en-US" sz="1800" b="0" strike="noStrike" spc="-1" dirty="0">
               <a:solidFill>
                 <a:srgbClr val="000000"/>
               </a:solidFill>
@@ -24687,7 +24705,7 @@
               </a:lnSpc>
             </a:pPr>
             <a:r>
-              <a:rPr lang="en-US" sz="1800" b="1" strike="noStrike" spc="-1">
+              <a:rPr lang="en-US" sz="1800" b="1" strike="noStrike" spc="-1" dirty="0">
                 <a:solidFill>
                   <a:srgbClr val="595959"/>
                 </a:solidFill>
@@ -24695,7 +24713,7 @@
               </a:rPr>
               <a:t>Directs ongoing development of resources</a:t>
             </a:r>
-            <a:endParaRPr lang="en-US" sz="1800" b="0" strike="noStrike" spc="-1">
+            <a:endParaRPr lang="en-US" sz="1800" b="0" strike="noStrike" spc="-1" dirty="0">
               <a:solidFill>
                 <a:srgbClr val="000000"/>
               </a:solidFill>
@@ -24714,7 +24732,7 @@
               <a:buChar char="•"/>
             </a:pPr>
             <a:r>
-              <a:rPr lang="en-US" sz="1800" b="1" strike="noStrike" spc="-1">
+              <a:rPr lang="en-US" sz="1800" b="1" strike="noStrike" spc="-1" dirty="0">
                 <a:solidFill>
                   <a:srgbClr val="595959"/>
                 </a:solidFill>
@@ -24722,7 +24740,7 @@
               </a:rPr>
               <a:t>Create new Omeka accounts </a:t>
             </a:r>
-            <a:endParaRPr lang="en-US" sz="1800" b="0" strike="noStrike" spc="-1">
+            <a:endParaRPr lang="en-US" sz="1800" b="0" strike="noStrike" spc="-1" dirty="0">
               <a:solidFill>
                 <a:srgbClr val="000000"/>
               </a:solidFill>
@@ -24741,15 +24759,33 @@
               <a:buChar char="•"/>
             </a:pPr>
             <a:r>
-              <a:rPr lang="en-US" sz="1800" b="1" strike="noStrike" spc="-1">
+              <a:rPr lang="en-US" sz="1800" b="1" strike="noStrike" spc="-1" dirty="0">
                 <a:solidFill>
                   <a:srgbClr val="595959"/>
                 </a:solidFill>
                 <a:latin typeface="Agency FB"/>
               </a:rPr>
-              <a:t>Understands how to do bulk inports and Routine item import</a:t>
-            </a:r>
-            <a:endParaRPr lang="en-US" sz="1800" b="0" strike="noStrike" spc="-1">
+              <a:t>Understands how to do bulk </a:t>
+            </a:r>
+            <a:r>
+              <a:rPr lang="en-US" sz="1800" b="1" strike="noStrike" spc="-1" dirty="0" err="1">
+                <a:solidFill>
+                  <a:srgbClr val="595959"/>
+                </a:solidFill>
+                <a:latin typeface="Agency FB"/>
+              </a:rPr>
+              <a:t>inports</a:t>
+            </a:r>
+            <a:r>
+              <a:rPr lang="en-US" sz="1800" b="1" strike="noStrike" spc="-1" dirty="0">
+                <a:solidFill>
+                  <a:srgbClr val="595959"/>
+                </a:solidFill>
+                <a:latin typeface="Agency FB"/>
+              </a:rPr>
+              <a:t> and Routine item import</a:t>
+            </a:r>
+            <a:endParaRPr lang="en-US" sz="1800" b="0" strike="noStrike" spc="-1" dirty="0">
               <a:solidFill>
                 <a:srgbClr val="000000"/>
               </a:solidFill>
@@ -24763,7 +24799,7 @@
               </a:lnSpc>
             </a:pPr>
             <a:r>
-              <a:rPr lang="en-US" sz="1800" b="1" strike="noStrike" spc="-1">
+              <a:rPr lang="en-US" sz="1800" b="1" strike="noStrike" spc="-1" dirty="0">
                 <a:solidFill>
                   <a:srgbClr val="595959"/>
                 </a:solidFill>
@@ -24771,7 +24807,7 @@
               </a:rPr>
               <a:t>Delegates design and development </a:t>
             </a:r>
-            <a:endParaRPr lang="en-US" sz="1800" b="0" strike="noStrike" spc="-1">
+            <a:endParaRPr lang="en-US" sz="1800" b="0" strike="noStrike" spc="-1" dirty="0">
               <a:solidFill>
                 <a:srgbClr val="000000"/>
               </a:solidFill>
@@ -24790,7 +24826,7 @@
               <a:buChar char="•"/>
             </a:pPr>
             <a:r>
-              <a:rPr lang="en-US" sz="1800" b="1" strike="noStrike" spc="-1">
+              <a:rPr lang="en-US" sz="1800" b="1" strike="noStrike" spc="-1" dirty="0">
                 <a:solidFill>
                   <a:srgbClr val="595959"/>
                 </a:solidFill>
@@ -24798,7 +24834,7 @@
               </a:rPr>
               <a:t>metadata templates</a:t>
             </a:r>
-            <a:endParaRPr lang="en-US" sz="1800" b="0" strike="noStrike" spc="-1">
+            <a:endParaRPr lang="en-US" sz="1800" b="0" strike="noStrike" spc="-1" dirty="0">
               <a:solidFill>
                 <a:srgbClr val="000000"/>
               </a:solidFill>
@@ -24817,7 +24853,7 @@
               <a:buChar char="•"/>
             </a:pPr>
             <a:r>
-              <a:rPr lang="en-US" sz="1800" b="1" strike="noStrike" spc="-1">
+              <a:rPr lang="en-US" sz="1800" b="1" strike="noStrike" spc="-1" dirty="0">
                 <a:solidFill>
                   <a:srgbClr val="595959"/>
                 </a:solidFill>
@@ -24825,7 +24861,7 @@
               </a:rPr>
               <a:t>Exhibits</a:t>
             </a:r>
-            <a:endParaRPr lang="en-US" sz="1800" b="0" strike="noStrike" spc="-1">
+            <a:endParaRPr lang="en-US" sz="1800" b="0" strike="noStrike" spc="-1" dirty="0">
               <a:solidFill>
                 <a:srgbClr val="000000"/>
               </a:solidFill>
@@ -24844,7 +24880,7 @@
               <a:buChar char="•"/>
             </a:pPr>
             <a:r>
-              <a:rPr lang="en-US" sz="1800" b="1" strike="noStrike" spc="-1">
+              <a:rPr lang="en-US" sz="1800" b="1" strike="noStrike" spc="-1" dirty="0">
                 <a:solidFill>
                   <a:srgbClr val="595959"/>
                 </a:solidFill>
@@ -24852,7 +24888,7 @@
               </a:rPr>
               <a:t>Create and improve Item Metadata and linking.</a:t>
             </a:r>
-            <a:endParaRPr lang="en-US" sz="1800" b="0" strike="noStrike" spc="-1">
+            <a:endParaRPr lang="en-US" sz="1800" b="0" strike="noStrike" spc="-1" dirty="0">
               <a:solidFill>
                 <a:srgbClr val="000000"/>
               </a:solidFill>
@@ -24865,7 +24901,7 @@
                 <a:spcPct val="100000"/>
               </a:lnSpc>
             </a:pPr>
-            <a:endParaRPr lang="en-US" sz="1800" b="0" strike="noStrike" spc="-1">
+            <a:endParaRPr lang="en-US" sz="1800" b="0" strike="noStrike" spc="-1" dirty="0">
               <a:solidFill>
                 <a:srgbClr val="000000"/>
               </a:solidFill>
@@ -24920,7 +24956,7 @@
               </a:spcAft>
             </a:pPr>
             <a:r>
-              <a:rPr lang="en-US" sz="1800" b="1" strike="noStrike" spc="-1">
+              <a:rPr lang="en-US" sz="1800" b="1" strike="noStrike" spc="-1" dirty="0">
                 <a:solidFill>
                   <a:srgbClr val="2F5597"/>
                 </a:solidFill>
@@ -24928,7 +24964,7 @@
               </a:rPr>
               <a:t>Azure Owner (Cambridge IT)</a:t>
             </a:r>
-            <a:endParaRPr lang="en-US" sz="1800" b="0" strike="noStrike" spc="-1">
+            <a:endParaRPr lang="en-US" sz="1800" b="0" strike="noStrike" spc="-1" dirty="0">
               <a:solidFill>
                 <a:srgbClr val="000000"/>
               </a:solidFill>
@@ -24945,7 +24981,7 @@
               </a:spcAft>
             </a:pPr>
             <a:r>
-              <a:rPr lang="en-US" sz="1800" b="1" strike="noStrike" spc="-1">
+              <a:rPr lang="en-US" sz="1800" b="1" strike="noStrike" spc="-1" dirty="0">
                 <a:solidFill>
                   <a:srgbClr val="595959"/>
                 </a:solidFill>
@@ -24953,7 +24989,7 @@
               </a:rPr>
               <a:t>Pays monthly Azure bills</a:t>
             </a:r>
-            <a:endParaRPr lang="en-US" sz="1800" b="0" strike="noStrike" spc="-1">
+            <a:endParaRPr lang="en-US" sz="1800" b="0" strike="noStrike" spc="-1" dirty="0">
               <a:solidFill>
                 <a:srgbClr val="000000"/>
               </a:solidFill>
@@ -24970,7 +25006,7 @@
               </a:spcAft>
             </a:pPr>
             <a:r>
-              <a:rPr lang="en-US" sz="1800" b="1" strike="noStrike" spc="-1">
+              <a:rPr lang="en-US" sz="1800" b="1" strike="noStrike" spc="-1" dirty="0">
                 <a:solidFill>
                   <a:srgbClr val="595959"/>
                 </a:solidFill>
@@ -24978,7 +25014,7 @@
               </a:rPr>
               <a:t>Holds full rights to delegate anything on Azure resources</a:t>
             </a:r>
-            <a:endParaRPr lang="en-US" sz="1800" b="0" strike="noStrike" spc="-1">
+            <a:endParaRPr lang="en-US" sz="1800" b="0" strike="noStrike" spc="-1" dirty="0">
               <a:solidFill>
                 <a:srgbClr val="000000"/>
               </a:solidFill>
@@ -24995,7 +25031,7 @@
               </a:spcAft>
             </a:pPr>
             <a:r>
-              <a:rPr lang="en-US" sz="1800" b="1" strike="noStrike" spc="-1">
+              <a:rPr lang="en-US" sz="1800" b="1" strike="noStrike" spc="-1" dirty="0">
                 <a:solidFill>
                   <a:srgbClr val="595959"/>
                 </a:solidFill>
@@ -25003,7 +25039,7 @@
               </a:rPr>
               <a:t>Evaluates and has last word on system design.</a:t>
             </a:r>
-            <a:endParaRPr lang="en-US" sz="1800" b="0" strike="noStrike" spc="-1">
+            <a:endParaRPr lang="en-US" sz="1800" b="0" strike="noStrike" spc="-1" dirty="0">
               <a:solidFill>
                 <a:srgbClr val="000000"/>
               </a:solidFill>
@@ -25020,7 +25056,7 @@
               </a:spcAft>
             </a:pPr>
             <a:r>
-              <a:rPr lang="en-US" sz="1800" b="1" strike="noStrike" spc="-1">
+              <a:rPr lang="en-US" sz="1800" b="1" strike="noStrike" spc="-1" dirty="0">
                 <a:solidFill>
                   <a:srgbClr val="595959"/>
                 </a:solidFill>
@@ -25028,7 +25064,7 @@
               </a:rPr>
               <a:t>Understands enough about the architecture, rebuild scripts, passwords and  documentation to delegate full system control to new Omeka/Azure Developer in case of emergency. </a:t>
             </a:r>
-            <a:endParaRPr lang="en-US" sz="1800" b="0" strike="noStrike" spc="-1">
+            <a:endParaRPr lang="en-US" sz="1800" b="0" strike="noStrike" spc="-1" dirty="0">
               <a:solidFill>
                 <a:srgbClr val="000000"/>
               </a:solidFill>
@@ -25552,7 +25588,7 @@
                 </a:solidFill>
                 <a:latin typeface="Calibri"/>
               </a:rPr>
-              <a:t>1/9/2023</a:t>
+              <a:t>4/17/2023</a:t>
             </a:fld>
             <a:endParaRPr lang="en-US" sz="1200" b="0" strike="noStrike" spc="-1">
               <a:latin typeface="Times New Roman"/>
@@ -26112,7 +26148,7 @@
                 </a:solidFill>
                 <a:latin typeface="Calibri"/>
               </a:rPr>
-              <a:t>1/9/2023</a:t>
+              <a:t>4/17/2023</a:t>
             </a:fld>
             <a:endParaRPr lang="en-US" sz="1200" b="0" strike="noStrike" spc="-1">
               <a:latin typeface="Times New Roman"/>
@@ -26899,7 +26935,7 @@
                 </a:solidFill>
                 <a:latin typeface="Calibri"/>
               </a:rPr>
-              <a:t>1/9/2023</a:t>
+              <a:t>4/17/2023</a:t>
             </a:fld>
             <a:endParaRPr lang="en-US" sz="1200" b="0" strike="noStrike" spc="-1">
               <a:latin typeface="Times New Roman"/>
@@ -27331,7 +27367,7 @@
                 </a:solidFill>
                 <a:latin typeface="Calibri"/>
               </a:rPr>
-              <a:t>1/9/2023</a:t>
+              <a:t>4/17/2023</a:t>
             </a:fld>
             <a:endParaRPr lang="en-US" sz="1200" b="0" strike="noStrike" spc="-1">
               <a:latin typeface="Times New Roman"/>
@@ -29284,7 +29320,7 @@
                 </a:solidFill>
                 <a:latin typeface="Calibri"/>
               </a:rPr>
-              <a:t>1/9/2023</a:t>
+              <a:t>4/17/2023</a:t>
             </a:fld>
             <a:endParaRPr lang="en-US" sz="1200" b="0" strike="noStrike" spc="-1">
               <a:latin typeface="Times New Roman"/>
@@ -29758,7 +29794,7 @@
                 </a:solidFill>
                 <a:latin typeface="Calibri"/>
               </a:rPr>
-              <a:t>1/9/2023</a:t>
+              <a:t>4/17/2023</a:t>
             </a:fld>
             <a:endParaRPr lang="en-US" sz="1200" b="0" strike="noStrike" spc="-1">
               <a:latin typeface="Times New Roman"/>
@@ -31572,7 +31608,7 @@
                 </a:solidFill>
                 <a:latin typeface="Calibri"/>
               </a:rPr>
-              <a:t>1/9/2023</a:t>
+              <a:t>4/17/2023</a:t>
             </a:fld>
             <a:endParaRPr lang="en-US" sz="1200" b="0" strike="noStrike" spc="-1">
               <a:latin typeface="Times New Roman"/>

</xml_diff>

<commit_message>
modified:   docker/index.htm 	modified:   resources/cdash_includes.js 	modified:   slideshow/CDashSlideshow_20230109.pptx 	modified:   template/index.htm
</commit_message>
<xml_diff>
--- a/slideshow/CDashSlideshow_20230109.pptx
+++ b/slideshow/CDashSlideshow_20230109.pptx
@@ -4812,7 +4812,7 @@
                 </a:solidFill>
                 <a:latin typeface="Calibri"/>
               </a:rPr>
-              <a:t>9/1/2023</a:t>
+              <a:t>1/3/2024</a:t>
             </a:fld>
             <a:endParaRPr lang="en-US" sz="1200" b="0" strike="noStrike" spc="-1">
               <a:latin typeface="Times New Roman"/>
@@ -5684,7 +5684,7 @@
                 </a:solidFill>
                 <a:latin typeface="Calibri"/>
               </a:rPr>
-              <a:t>9/1/2023</a:t>
+              <a:t>1/3/2024</a:t>
             </a:fld>
             <a:endParaRPr lang="en-US" sz="1200" b="0" strike="noStrike" spc="-1">
               <a:latin typeface="Times New Roman"/>
@@ -6182,7 +6182,7 @@
                 </a:solidFill>
                 <a:latin typeface="Calibri"/>
               </a:rPr>
-              <a:t>9/1/2023</a:t>
+              <a:t>1/3/2024</a:t>
             </a:fld>
             <a:endParaRPr lang="en-US" sz="1200" b="0" strike="noStrike" spc="-1">
               <a:latin typeface="Times New Roman"/>
@@ -7205,7 +7205,7 @@
                 </a:solidFill>
                 <a:latin typeface="Calibri"/>
               </a:rPr>
-              <a:t>9/1/2023</a:t>
+              <a:t>1/3/2024</a:t>
             </a:fld>
             <a:endParaRPr lang="en-US" sz="1200" b="0" strike="noStrike" spc="-1">
               <a:latin typeface="Times New Roman"/>
@@ -10532,7 +10532,7 @@
                 </a:solidFill>
                 <a:latin typeface="Calibri"/>
               </a:rPr>
-              <a:t>9/1/2023</a:t>
+              <a:t>1/3/2024</a:t>
             </a:fld>
             <a:endParaRPr lang="en-US" sz="1200" b="0" strike="noStrike" spc="-1">
               <a:latin typeface="Times New Roman"/>
@@ -11645,7 +11645,7 @@
                 </a:solidFill>
                 <a:latin typeface="Agency FB"/>
               </a:rPr>
-              <a:t>. Ten file cabinets with 16,000 folders of clippings documentation related buildings, and other places in the city. </a:t>
+              <a:t>. Ten file cabinets with 16,000 folders of clippings and other documentation related to buildings, and other places in the city. </a:t>
             </a:r>
           </a:p>
         </p:txBody>
@@ -13255,7 +13255,7 @@
                 </a:solidFill>
                 <a:latin typeface="Calibri"/>
               </a:rPr>
-              <a:t>9/1/2023</a:t>
+              <a:t>1/3/2024</a:t>
             </a:fld>
             <a:endParaRPr lang="en-US" sz="1200" b="0" strike="noStrike" spc="-1">
               <a:latin typeface="Times New Roman"/>
@@ -14494,7 +14494,7 @@
                 </a:solidFill>
                 <a:latin typeface="Calibri"/>
               </a:rPr>
-              <a:t>9/1/2023</a:t>
+              <a:t>1/3/2024</a:t>
             </a:fld>
             <a:endParaRPr lang="en-US" sz="1200" b="0" strike="noStrike" spc="-1">
               <a:latin typeface="Times New Roman"/>
@@ -15361,7 +15361,7 @@
                 </a:solidFill>
                 <a:latin typeface="Calibri"/>
               </a:rPr>
-              <a:t>9/1/2023</a:t>
+              <a:t>1/3/2024</a:t>
             </a:fld>
             <a:endParaRPr lang="en-US" sz="1200" b="0" strike="noStrike" spc="-1">
               <a:latin typeface="Times New Roman"/>
@@ -17172,7 +17172,7 @@
                 </a:solidFill>
                 <a:latin typeface="Calibri"/>
               </a:rPr>
-              <a:t>9/1/2023</a:t>
+              <a:t>1/3/2024</a:t>
             </a:fld>
             <a:endParaRPr lang="en-US" sz="1200" b="0" strike="noStrike" spc="-1">
               <a:latin typeface="Times New Roman"/>
@@ -19125,7 +19125,7 @@
                 </a:solidFill>
                 <a:latin typeface="Calibri"/>
               </a:rPr>
-              <a:t>9/1/2023</a:t>
+              <a:t>1/3/2024</a:t>
             </a:fld>
             <a:endParaRPr lang="en-US" sz="1200" b="0" strike="noStrike" spc="-1">
               <a:latin typeface="Times New Roman"/>
@@ -19340,30 +19340,211 @@
           <a:chExt cx="0" cy="0"/>
         </a:xfrm>
       </p:grpSpPr>
-      <p:sp>
-        <p:nvSpPr>
-          <p:cNvPr id="357" name="CustomShape 1"/>
+      <p:grpSp>
+        <p:nvGrpSpPr>
+          <p:cNvPr id="7" name="Group 6">
+            <a:extLst>
+              <a:ext uri="{FF2B5EF4-FFF2-40B4-BE49-F238E27FC236}">
+                <a16:creationId xmlns:a16="http://schemas.microsoft.com/office/drawing/2014/main" id="{3F864590-EF54-0D3C-7B88-FE5AD84BE8B9}"/>
+              </a:ext>
+            </a:extLst>
+          </p:cNvPr>
+          <p:cNvGrpSpPr/>
+          <p:nvPr/>
+        </p:nvGrpSpPr>
+        <p:grpSpPr>
+          <a:xfrm>
+            <a:off x="-13367" y="718560"/>
+            <a:ext cx="12303419" cy="5839200"/>
+            <a:chOff x="-13367" y="718560"/>
+            <a:chExt cx="12303419" cy="5839200"/>
+          </a:xfrm>
+        </p:grpSpPr>
+        <p:sp>
+          <p:nvSpPr>
+            <p:cNvPr id="358" name="CustomShape 2"/>
+            <p:cNvSpPr/>
+            <p:nvPr/>
+          </p:nvSpPr>
+          <p:spPr>
+            <a:xfrm>
+              <a:off x="199080" y="718560"/>
+              <a:ext cx="11793600" cy="1928880"/>
+            </a:xfrm>
+            <a:prstGeom prst="roundRect">
+              <a:avLst>
+                <a:gd name="adj" fmla="val 16667"/>
+              </a:avLst>
+            </a:prstGeom>
+            <a:solidFill>
+              <a:schemeClr val="accent4">
+                <a:lumMod val="20000"/>
+                <a:lumOff val="80000"/>
+              </a:schemeClr>
+            </a:solidFill>
+            <a:ln>
+              <a:noFill/>
+            </a:ln>
+          </p:spPr>
+          <p:style>
+            <a:lnRef idx="2">
+              <a:schemeClr val="accent1">
+                <a:shade val="50000"/>
+              </a:schemeClr>
+            </a:lnRef>
+            <a:fillRef idx="1">
+              <a:schemeClr val="accent1"/>
+            </a:fillRef>
+            <a:effectRef idx="0">
+              <a:schemeClr val="accent1"/>
+            </a:effectRef>
+            <a:fontRef idx="minor"/>
+          </p:style>
+          <p:txBody>
+            <a:bodyPr/>
+            <a:lstStyle/>
+            <a:p>
+              <a:endParaRPr lang="en-US"/>
+            </a:p>
+          </p:txBody>
+        </p:sp>
+        <p:sp>
+          <p:nvSpPr>
+            <p:cNvPr id="357" name="CustomShape 1"/>
+            <p:cNvSpPr/>
+            <p:nvPr/>
+          </p:nvSpPr>
+          <p:spPr>
+            <a:xfrm>
+              <a:off x="199080" y="3615120"/>
+              <a:ext cx="11793600" cy="2942640"/>
+            </a:xfrm>
+            <a:prstGeom prst="roundRect">
+              <a:avLst>
+                <a:gd name="adj" fmla="val 16667"/>
+              </a:avLst>
+            </a:prstGeom>
+            <a:solidFill>
+              <a:schemeClr val="accent4">
+                <a:lumMod val="20000"/>
+                <a:lumOff val="80000"/>
+              </a:schemeClr>
+            </a:solidFill>
+            <a:ln>
+              <a:noFill/>
+            </a:ln>
+          </p:spPr>
+          <p:style>
+            <a:lnRef idx="2">
+              <a:schemeClr val="accent1">
+                <a:shade val="50000"/>
+              </a:schemeClr>
+            </a:lnRef>
+            <a:fillRef idx="1">
+              <a:schemeClr val="accent1"/>
+            </a:fillRef>
+            <a:effectRef idx="0">
+              <a:schemeClr val="accent1"/>
+            </a:effectRef>
+            <a:fontRef idx="minor"/>
+          </p:style>
+          <p:txBody>
+            <a:bodyPr/>
+            <a:lstStyle/>
+            <a:p>
+              <a:endParaRPr lang="en-US"/>
+            </a:p>
+          </p:txBody>
+        </p:sp>
+        <p:sp>
+          <p:nvSpPr>
+            <p:cNvPr id="359" name="CustomShape 3"/>
+            <p:cNvSpPr/>
+            <p:nvPr/>
+          </p:nvSpPr>
+          <p:spPr>
+            <a:xfrm rot="306055">
+              <a:off x="-13367" y="1987623"/>
+              <a:ext cx="12303419" cy="3008160"/>
+            </a:xfrm>
+            <a:prstGeom prst="cloud">
+              <a:avLst/>
+            </a:prstGeom>
+            <a:solidFill>
+              <a:schemeClr val="accent1">
+                <a:lumMod val="20000"/>
+                <a:lumOff val="80000"/>
+              </a:schemeClr>
+            </a:solidFill>
+            <a:ln w="69840">
+              <a:solidFill>
+                <a:schemeClr val="accent1">
+                  <a:lumMod val="60000"/>
+                  <a:lumOff val="40000"/>
+                </a:schemeClr>
+              </a:solidFill>
+            </a:ln>
+          </p:spPr>
+          <p:style>
+            <a:lnRef idx="2">
+              <a:schemeClr val="accent1">
+                <a:shade val="50000"/>
+              </a:schemeClr>
+            </a:lnRef>
+            <a:fillRef idx="1">
+              <a:schemeClr val="accent1"/>
+            </a:fillRef>
+            <a:effectRef idx="0">
+              <a:schemeClr val="accent1"/>
+            </a:effectRef>
+            <a:fontRef idx="minor"/>
+          </p:style>
+          <p:txBody>
+            <a:bodyPr lIns="90000" tIns="45000" rIns="90000" bIns="45000" anchor="ctr">
+              <a:noAutofit/>
+            </a:bodyPr>
+            <a:lstStyle/>
+            <a:p>
+              <a:pPr algn="ctr">
+                <a:lnSpc>
+                  <a:spcPct val="100000"/>
+                </a:lnSpc>
+              </a:pPr>
+              <a:endParaRPr lang="en-US" sz="1800" b="0" strike="noStrike" spc="-1" dirty="0">
+                <a:solidFill>
+                  <a:srgbClr val="000000"/>
+                </a:solidFill>
+                <a:latin typeface="Arial"/>
+              </a:endParaRPr>
+            </a:p>
+          </p:txBody>
+        </p:sp>
+      </p:grpSp>
+      <p:sp>
+        <p:nvSpPr>
+          <p:cNvPr id="379" name="CustomShape 18"/>
           <p:cNvSpPr/>
           <p:nvPr/>
         </p:nvSpPr>
         <p:spPr>
           <a:xfrm>
-            <a:off x="199080" y="3615120"/>
-            <a:ext cx="11793600" cy="2942640"/>
-          </a:xfrm>
-          <a:prstGeom prst="roundRect">
-            <a:avLst>
-              <a:gd name="adj" fmla="val 16667"/>
-            </a:avLst>
+            <a:off x="9362417" y="-1706933"/>
+            <a:ext cx="1174685" cy="1364400"/>
+          </a:xfrm>
+          <a:prstGeom prst="flowChartMagneticDisk">
+            <a:avLst/>
           </a:prstGeom>
           <a:solidFill>
-            <a:schemeClr val="accent4">
-              <a:lumMod val="20000"/>
-              <a:lumOff val="80000"/>
+            <a:schemeClr val="bg1">
+              <a:lumMod val="95000"/>
             </a:schemeClr>
           </a:solidFill>
-          <a:ln>
-            <a:noFill/>
+          <a:ln w="44280">
+            <a:solidFill>
+              <a:schemeClr val="bg1">
+                <a:lumMod val="75000"/>
+              </a:schemeClr>
+            </a:solidFill>
           </a:ln>
         </p:spPr>
         <p:style>
@@ -19388,337 +19569,29 @@
           </a:p>
         </p:txBody>
       </p:sp>
-      <p:sp>
-        <p:nvSpPr>
-          <p:cNvPr id="358" name="CustomShape 2"/>
-          <p:cNvSpPr/>
-          <p:nvPr/>
-        </p:nvSpPr>
-        <p:spPr>
-          <a:xfrm>
-            <a:off x="199080" y="718560"/>
-            <a:ext cx="11793600" cy="1928880"/>
-          </a:xfrm>
-          <a:prstGeom prst="roundRect">
-            <a:avLst>
-              <a:gd name="adj" fmla="val 16667"/>
-            </a:avLst>
-          </a:prstGeom>
-          <a:solidFill>
-            <a:schemeClr val="accent4">
-              <a:lumMod val="20000"/>
-              <a:lumOff val="80000"/>
-            </a:schemeClr>
-          </a:solidFill>
-          <a:ln>
-            <a:noFill/>
-          </a:ln>
-        </p:spPr>
-        <p:style>
-          <a:lnRef idx="2">
-            <a:schemeClr val="accent1">
-              <a:shade val="50000"/>
-            </a:schemeClr>
-          </a:lnRef>
-          <a:fillRef idx="1">
-            <a:schemeClr val="accent1"/>
-          </a:fillRef>
-          <a:effectRef idx="0">
-            <a:schemeClr val="accent1"/>
-          </a:effectRef>
-          <a:fontRef idx="minor"/>
-        </p:style>
-        <p:txBody>
-          <a:bodyPr/>
-          <a:lstStyle/>
-          <a:p>
-            <a:endParaRPr lang="en-US"/>
-          </a:p>
-        </p:txBody>
-      </p:sp>
-      <p:sp>
-        <p:nvSpPr>
-          <p:cNvPr id="359" name="CustomShape 3"/>
-          <p:cNvSpPr/>
-          <p:nvPr/>
-        </p:nvSpPr>
-        <p:spPr>
-          <a:xfrm rot="220200">
-            <a:off x="-1205640" y="2032200"/>
-            <a:ext cx="16077960" cy="3008160"/>
-          </a:xfrm>
-          <a:prstGeom prst="cloud">
-            <a:avLst/>
-          </a:prstGeom>
-          <a:solidFill>
-            <a:schemeClr val="accent1">
-              <a:lumMod val="20000"/>
-              <a:lumOff val="80000"/>
-            </a:schemeClr>
-          </a:solidFill>
-          <a:ln w="69840">
-            <a:solidFill>
-              <a:schemeClr val="accent1">
-                <a:lumMod val="60000"/>
-                <a:lumOff val="40000"/>
-              </a:schemeClr>
-            </a:solidFill>
-          </a:ln>
-        </p:spPr>
-        <p:style>
-          <a:lnRef idx="2">
-            <a:schemeClr val="accent1">
-              <a:shade val="50000"/>
-            </a:schemeClr>
-          </a:lnRef>
-          <a:fillRef idx="1">
-            <a:schemeClr val="accent1"/>
-          </a:fillRef>
-          <a:effectRef idx="0">
-            <a:schemeClr val="accent1"/>
-          </a:effectRef>
-          <a:fontRef idx="minor"/>
-        </p:style>
-        <p:txBody>
-          <a:bodyPr lIns="90000" tIns="45000" rIns="90000" bIns="45000" anchor="ctr">
-            <a:noAutofit/>
-          </a:bodyPr>
-          <a:lstStyle/>
-          <a:p>
-            <a:pPr algn="ctr">
-              <a:lnSpc>
-                <a:spcPct val="100000"/>
-              </a:lnSpc>
-            </a:pPr>
-            <a:r>
-              <a:rPr lang="en-US" sz="1800" b="0" strike="noStrike" spc="-1">
-                <a:solidFill>
-                  <a:srgbClr val="FFFFFF"/>
-                </a:solidFill>
-                <a:latin typeface="Calibri"/>
-              </a:rPr>
-              <a:t>CHC</a:t>
-            </a:r>
-            <a:endParaRPr lang="en-US" sz="1800" b="0" strike="noStrike" spc="-1">
-              <a:solidFill>
-                <a:srgbClr val="000000"/>
-              </a:solidFill>
-              <a:latin typeface="Arial"/>
-            </a:endParaRPr>
-          </a:p>
-        </p:txBody>
-      </p:sp>
-      <p:sp>
-        <p:nvSpPr>
-          <p:cNvPr id="360" name="CustomShape 4"/>
-          <p:cNvSpPr/>
-          <p:nvPr/>
-        </p:nvSpPr>
-        <p:spPr>
-          <a:xfrm>
-            <a:off x="1948680" y="1782000"/>
-            <a:ext cx="1553760" cy="646920"/>
-          </a:xfrm>
-          <a:prstGeom prst="rect">
-            <a:avLst/>
-          </a:prstGeom>
-          <a:solidFill>
-            <a:srgbClr val="DEDCE6"/>
-          </a:solidFill>
-          <a:ln w="9000">
-            <a:solidFill>
-              <a:srgbClr val="FFD74C"/>
-            </a:solidFill>
-            <a:round/>
-          </a:ln>
-        </p:spPr>
-        <p:style>
-          <a:lnRef idx="0">
-            <a:scrgbClr r="0" g="0" b="0"/>
-          </a:lnRef>
-          <a:fillRef idx="0">
-            <a:scrgbClr r="0" g="0" b="0"/>
-          </a:fillRef>
-          <a:effectRef idx="0">
-            <a:scrgbClr r="0" g="0" b="0"/>
-          </a:effectRef>
-          <a:fontRef idx="minor"/>
-        </p:style>
-        <p:txBody>
-          <a:bodyPr wrap="none" lIns="94320" tIns="49320" rIns="94320" bIns="49320">
-            <a:spAutoFit/>
-          </a:bodyPr>
-          <a:lstStyle/>
-          <a:p>
-            <a:pPr algn="ctr"/>
-            <a:r>
-              <a:rPr lang="en-US" sz="1800" b="0" strike="noStrike" spc="-1">
-                <a:solidFill>
-                  <a:srgbClr val="000000"/>
-                </a:solidFill>
-                <a:latin typeface="Arial"/>
-              </a:rPr>
-              <a:t>Web Browser</a:t>
-            </a:r>
-            <a:endParaRPr lang="en-US" sz="1800" b="0" strike="noStrike" spc="-1">
-              <a:solidFill>
-                <a:srgbClr val="000000"/>
-              </a:solidFill>
-              <a:latin typeface="Arial"/>
-              <a:ea typeface="Microsoft YaHei"/>
-            </a:endParaRPr>
-          </a:p>
-          <a:p>
-            <a:pPr algn="ctr">
-              <a:lnSpc>
-                <a:spcPct val="100000"/>
-              </a:lnSpc>
-            </a:pPr>
-            <a:r>
-              <a:rPr lang="en-US" sz="1800" b="0" strike="noStrike" spc="-1">
-                <a:solidFill>
-                  <a:srgbClr val="000000"/>
-                </a:solidFill>
-                <a:latin typeface="Arial"/>
-              </a:rPr>
-              <a:t>HTTPS</a:t>
-            </a:r>
-            <a:endParaRPr lang="en-US" sz="1800" b="0" strike="noStrike" spc="-1">
-              <a:solidFill>
-                <a:srgbClr val="000000"/>
-              </a:solidFill>
-              <a:latin typeface="Arial"/>
-              <a:ea typeface="Microsoft YaHei"/>
-            </a:endParaRPr>
-          </a:p>
-        </p:txBody>
-      </p:sp>
-      <p:sp>
-        <p:nvSpPr>
-          <p:cNvPr id="361" name="CustomShape 5"/>
-          <p:cNvSpPr/>
-          <p:nvPr/>
-        </p:nvSpPr>
-        <p:spPr>
-          <a:xfrm>
-            <a:off x="4755240" y="2526840"/>
-            <a:ext cx="7029000" cy="1517760"/>
-          </a:xfrm>
-          <a:prstGeom prst="flowChartMagneticDisk">
-            <a:avLst/>
-          </a:prstGeom>
-          <a:solidFill>
-            <a:schemeClr val="bg1">
-              <a:lumMod val="95000"/>
-            </a:schemeClr>
-          </a:solidFill>
-          <a:ln w="44280">
-            <a:solidFill>
-              <a:schemeClr val="bg1">
-                <a:lumMod val="75000"/>
-              </a:schemeClr>
-            </a:solidFill>
-          </a:ln>
-        </p:spPr>
-        <p:style>
-          <a:lnRef idx="2">
-            <a:schemeClr val="accent1">
-              <a:shade val="50000"/>
-            </a:schemeClr>
-          </a:lnRef>
-          <a:fillRef idx="1">
-            <a:schemeClr val="accent1"/>
-          </a:fillRef>
-          <a:effectRef idx="0">
-            <a:schemeClr val="accent1"/>
-          </a:effectRef>
-          <a:fontRef idx="minor"/>
-        </p:style>
-        <p:txBody>
-          <a:bodyPr/>
-          <a:lstStyle/>
-          <a:p>
-            <a:endParaRPr lang="en-US"/>
-          </a:p>
-        </p:txBody>
-      </p:sp>
-      <p:sp>
-        <p:nvSpPr>
-          <p:cNvPr id="362" name="CustomShape 6"/>
-          <p:cNvSpPr/>
-          <p:nvPr/>
-        </p:nvSpPr>
-        <p:spPr>
-          <a:xfrm>
-            <a:off x="509760" y="155520"/>
-            <a:ext cx="10285200" cy="456120"/>
-          </a:xfrm>
-          <a:prstGeom prst="rect">
-            <a:avLst/>
-          </a:prstGeom>
-          <a:noFill/>
-          <a:ln>
-            <a:noFill/>
-          </a:ln>
-        </p:spPr>
-        <p:style>
-          <a:lnRef idx="0">
-            <a:scrgbClr r="0" g="0" b="0"/>
-          </a:lnRef>
-          <a:fillRef idx="0">
-            <a:scrgbClr r="0" g="0" b="0"/>
-          </a:fillRef>
-          <a:effectRef idx="0">
-            <a:scrgbClr r="0" g="0" b="0"/>
-          </a:effectRef>
-          <a:fontRef idx="minor"/>
-        </p:style>
-        <p:txBody>
-          <a:bodyPr lIns="90000" tIns="45000" rIns="90000" bIns="45000">
-            <a:spAutoFit/>
-          </a:bodyPr>
-          <a:lstStyle/>
-          <a:p>
-            <a:pPr marL="285840" indent="-285480">
-              <a:lnSpc>
-                <a:spcPct val="100000"/>
-              </a:lnSpc>
-            </a:pPr>
-            <a:r>
-              <a:rPr lang="en-US" sz="2400" b="1" strike="noStrike" spc="-1">
-                <a:solidFill>
-                  <a:srgbClr val="2E75B6"/>
-                </a:solidFill>
-                <a:latin typeface="Calibri"/>
-              </a:rPr>
-              <a:t>Omeka in Azure Cloud (detail)</a:t>
-            </a:r>
-            <a:endParaRPr lang="en-US" sz="2400" b="0" strike="noStrike" spc="-1">
-              <a:solidFill>
-                <a:srgbClr val="000000"/>
-              </a:solidFill>
-              <a:latin typeface="Arial"/>
-            </a:endParaRPr>
-          </a:p>
-        </p:txBody>
-      </p:sp>
       <p:grpSp>
         <p:nvGrpSpPr>
-          <p:cNvPr id="363" name="Group 7"/>
+          <p:cNvPr id="4" name="Group 3">
+            <a:extLst>
+              <a:ext uri="{FF2B5EF4-FFF2-40B4-BE49-F238E27FC236}">
+                <a16:creationId xmlns:a16="http://schemas.microsoft.com/office/drawing/2014/main" id="{3C31ACFE-EF97-6104-3DAA-3E1DF1A3A95C}"/>
+              </a:ext>
+            </a:extLst>
+          </p:cNvPr>
           <p:cNvGrpSpPr/>
           <p:nvPr/>
         </p:nvGrpSpPr>
         <p:grpSpPr>
           <a:xfrm>
-            <a:off x="6495120" y="3057120"/>
-            <a:ext cx="1163160" cy="742680"/>
-            <a:chOff x="6495120" y="3057120"/>
-            <a:chExt cx="1163160" cy="742680"/>
+            <a:off x="3073444" y="2599215"/>
+            <a:ext cx="1687363" cy="1450080"/>
+            <a:chOff x="1904776" y="2527920"/>
+            <a:chExt cx="1687363" cy="1450080"/>
           </a:xfrm>
         </p:grpSpPr>
         <p:pic>
           <p:nvPicPr>
-            <p:cNvPr id="364" name="Picture 2" descr="Image result for folder"/>
+            <p:cNvPr id="373" name="Picture 2"/>
             <p:cNvPicPr/>
             <p:nvPr/>
           </p:nvPicPr>
@@ -19728,8 +19601,8 @@
           </p:blipFill>
           <p:spPr>
             <a:xfrm>
-              <a:off x="6495120" y="3057120"/>
-              <a:ext cx="1163160" cy="724680"/>
+              <a:off x="1924200" y="2527920"/>
+              <a:ext cx="1602720" cy="1450080"/>
             </a:xfrm>
             <a:prstGeom prst="rect">
               <a:avLst/>
@@ -19737,18 +19610,191 @@
             <a:ln>
               <a:noFill/>
             </a:ln>
+            <a:effectLst>
+              <a:softEdge rad="63500"/>
+            </a:effectLst>
           </p:spPr>
         </p:pic>
         <p:sp>
           <p:nvSpPr>
-            <p:cNvPr id="365" name="CustomShape 8"/>
+            <p:cNvPr id="374" name="CustomShape 14"/>
             <p:cNvSpPr/>
             <p:nvPr/>
           </p:nvSpPr>
           <p:spPr>
             <a:xfrm>
-              <a:off x="6688800" y="3161520"/>
-              <a:ext cx="831960" cy="638280"/>
+              <a:off x="2020698" y="2902289"/>
+              <a:ext cx="1436204" cy="1014209"/>
+            </a:xfrm>
+            <a:prstGeom prst="rect">
+              <a:avLst/>
+            </a:prstGeom>
+            <a:noFill/>
+            <a:ln>
+              <a:noFill/>
+            </a:ln>
+            <a:effectLst>
+              <a:glow rad="228600">
+                <a:schemeClr val="accent1">
+                  <a:satMod val="175000"/>
+                  <a:alpha val="91000"/>
+                </a:schemeClr>
+              </a:glow>
+            </a:effectLst>
+          </p:spPr>
+          <p:style>
+            <a:lnRef idx="0">
+              <a:scrgbClr r="0" g="0" b="0"/>
+            </a:lnRef>
+            <a:fillRef idx="0">
+              <a:scrgbClr r="0" g="0" b="0"/>
+            </a:fillRef>
+            <a:effectRef idx="0">
+              <a:scrgbClr r="0" g="0" b="0"/>
+            </a:effectRef>
+            <a:fontRef idx="minor"/>
+          </p:style>
+          <p:txBody>
+            <a:bodyPr wrap="none" lIns="90000" tIns="45000" rIns="90000" bIns="45000">
+              <a:spAutoFit/>
+            </a:bodyPr>
+            <a:lstStyle/>
+            <a:p>
+              <a:pPr algn="ctr">
+                <a:lnSpc>
+                  <a:spcPct val="100000"/>
+                </a:lnSpc>
+              </a:pPr>
+              <a:r>
+                <a:rPr lang="en-US" sz="1400" b="1" spc="-1" dirty="0">
+                  <a:effectLst>
+                    <a:glow rad="304800">
+                      <a:schemeClr val="bg1">
+                        <a:alpha val="97000"/>
+                      </a:schemeClr>
+                    </a:glow>
+                  </a:effectLst>
+                  <a:latin typeface="Calibri"/>
+                </a:rPr>
+                <a:t>Linux</a:t>
+              </a:r>
+              <a:r>
+                <a:rPr lang="en-US" sz="1800" b="1" strike="noStrike" spc="-1" dirty="0">
+                  <a:effectLst>
+                    <a:glow rad="304800">
+                      <a:schemeClr val="bg1">
+                        <a:alpha val="97000"/>
+                      </a:schemeClr>
+                    </a:glow>
+                  </a:effectLst>
+                  <a:latin typeface="Calibri"/>
+                </a:rPr>
+                <a:t> </a:t>
+              </a:r>
+              <a:br>
+                <a:rPr b="1" dirty="0">
+                  <a:effectLst>
+                    <a:glow rad="304800">
+                      <a:schemeClr val="bg1">
+                        <a:alpha val="97000"/>
+                      </a:schemeClr>
+                    </a:glow>
+                  </a:effectLst>
+                </a:rPr>
+              </a:br>
+              <a:r>
+                <a:rPr lang="en-US" sz="1400" b="1" strike="noStrike" spc="-1" dirty="0">
+                  <a:effectLst>
+                    <a:glow rad="304800">
+                      <a:schemeClr val="bg1">
+                        <a:alpha val="97000"/>
+                      </a:schemeClr>
+                    </a:glow>
+                  </a:effectLst>
+                  <a:latin typeface="Calibri"/>
+                </a:rPr>
+                <a:t>Apache/P</a:t>
+              </a:r>
+              <a:r>
+                <a:rPr lang="en-US" sz="1400" b="1" spc="-1" dirty="0">
+                  <a:effectLst>
+                    <a:glow rad="304800">
+                      <a:schemeClr val="bg1">
+                        <a:alpha val="97000"/>
+                      </a:schemeClr>
+                    </a:glow>
+                  </a:effectLst>
+                  <a:latin typeface="Calibri"/>
+                </a:rPr>
+                <a:t>HP</a:t>
+              </a:r>
+              <a:br>
+                <a:rPr b="1" dirty="0">
+                  <a:effectLst>
+                    <a:glow rad="304800">
+                      <a:schemeClr val="bg1">
+                        <a:alpha val="97000"/>
+                      </a:schemeClr>
+                    </a:glow>
+                  </a:effectLst>
+                </a:rPr>
+              </a:br>
+              <a:r>
+                <a:rPr lang="en-US" sz="1400" b="1" strike="noStrike" spc="-1" dirty="0">
+                  <a:effectLst>
+                    <a:glow rad="304800">
+                      <a:schemeClr val="bg1">
+                        <a:alpha val="97000"/>
+                      </a:schemeClr>
+                    </a:glow>
+                  </a:effectLst>
+                  <a:latin typeface="Calibri"/>
+                </a:rPr>
+                <a:t>Omeka</a:t>
+              </a:r>
+            </a:p>
+            <a:p>
+              <a:pPr algn="ctr">
+                <a:lnSpc>
+                  <a:spcPct val="100000"/>
+                </a:lnSpc>
+              </a:pPr>
+              <a:r>
+                <a:rPr lang="en-US" sz="1400" b="1" spc="-1" dirty="0">
+                  <a:effectLst>
+                    <a:glow rad="304800">
+                      <a:schemeClr val="bg1">
+                        <a:alpha val="97000"/>
+                      </a:schemeClr>
+                    </a:glow>
+                  </a:effectLst>
+                  <a:latin typeface="Calibri"/>
+                </a:rPr>
+                <a:t>Custom Modules</a:t>
+              </a:r>
+              <a:endParaRPr lang="en-US" sz="1400" b="1" strike="noStrike" spc="-1" dirty="0">
+                <a:effectLst>
+                  <a:glow rad="304800">
+                    <a:schemeClr val="bg1">
+                      <a:alpha val="97000"/>
+                    </a:schemeClr>
+                  </a:glow>
+                </a:effectLst>
+                <a:latin typeface="Arial"/>
+              </a:endParaRPr>
+            </a:p>
+          </p:txBody>
+        </p:sp>
+        <p:sp>
+          <p:nvSpPr>
+            <p:cNvPr id="404" name="CustomShape 40"/>
+            <p:cNvSpPr/>
+            <p:nvPr/>
+          </p:nvSpPr>
+          <p:spPr>
+            <a:xfrm>
+              <a:off x="1904776" y="2630807"/>
+              <a:ext cx="1687363" cy="367878"/>
             </a:xfrm>
             <a:prstGeom prst="rect">
               <a:avLst/>
@@ -19782,74 +19828,159 @@
                 </a:lnSpc>
               </a:pPr>
               <a:r>
-                <a:rPr lang="en-US" sz="1800" b="1" strike="noStrike" spc="-1">
+                <a:rPr lang="en-US" b="1" spc="-1" dirty="0" err="1">
                   <a:solidFill>
-                    <a:srgbClr val="000000"/>
+                    <a:srgbClr val="333333"/>
                   </a:solidFill>
+                  <a:effectLst>
+                    <a:glow rad="228600">
+                      <a:schemeClr val="bg1">
+                        <a:alpha val="79000"/>
+                      </a:schemeClr>
+                    </a:glow>
+                  </a:effectLst>
                   <a:latin typeface="Calibri"/>
                 </a:rPr>
-                <a:t>Theme</a:t>
+                <a:t>CHCO</a:t>
               </a:r>
-              <a:endParaRPr lang="en-US" sz="1800" b="0" strike="noStrike" spc="-1">
-                <a:solidFill>
-                  <a:srgbClr val="000000"/>
-                </a:solidFill>
-                <a:latin typeface="Arial"/>
-              </a:endParaRPr>
-            </a:p>
-            <a:p>
-              <a:pPr algn="ctr">
-                <a:lnSpc>
-                  <a:spcPct val="100000"/>
-                </a:lnSpc>
-              </a:pPr>
               <a:r>
-                <a:rPr lang="en-US" sz="1800" b="1" strike="noStrike" spc="-1">
+                <a:rPr lang="en-US" sz="1800" b="1" strike="noStrike" spc="-1" dirty="0" err="1">
                   <a:solidFill>
-                    <a:srgbClr val="000000"/>
+                    <a:srgbClr val="333333"/>
                   </a:solidFill>
+                  <a:effectLst>
+                    <a:glow rad="228600">
+                      <a:schemeClr val="bg1">
+                        <a:alpha val="79000"/>
+                      </a:schemeClr>
+                    </a:glow>
+                  </a:effectLst>
                   <a:latin typeface="Calibri"/>
                 </a:rPr>
-                <a:t>Styling</a:t>
+                <a:t>meka</a:t>
               </a:r>
-              <a:endParaRPr lang="en-US" sz="1800" b="0" strike="noStrike" spc="-1">
-                <a:solidFill>
-                  <a:srgbClr val="000000"/>
-                </a:solidFill>
+              <a:r>
+                <a:rPr lang="en-US" sz="1800" b="1" strike="noStrike" spc="-1" dirty="0">
+                  <a:solidFill>
+                    <a:srgbClr val="333333"/>
+                  </a:solidFill>
+                  <a:effectLst>
+                    <a:glow rad="228600">
+                      <a:schemeClr val="bg1">
+                        <a:alpha val="79000"/>
+                      </a:schemeClr>
+                    </a:glow>
+                  </a:effectLst>
+                  <a:latin typeface="Calibri"/>
+                </a:rPr>
+                <a:t> App</a:t>
+              </a:r>
+              <a:endParaRPr lang="en-US" sz="1800" b="0" strike="noStrike" spc="-1" dirty="0">
+                <a:solidFill>
+                  <a:srgbClr val="333333"/>
+                </a:solidFill>
+                <a:effectLst>
+                  <a:glow rad="228600">
+                    <a:schemeClr val="bg1">
+                      <a:alpha val="79000"/>
+                    </a:schemeClr>
+                  </a:glow>
+                </a:effectLst>
                 <a:latin typeface="Arial"/>
               </a:endParaRPr>
             </a:p>
           </p:txBody>
         </p:sp>
       </p:grpSp>
+      <p:sp>
+        <p:nvSpPr>
+          <p:cNvPr id="362" name="CustomShape 6"/>
+          <p:cNvSpPr/>
+          <p:nvPr/>
+        </p:nvSpPr>
+        <p:spPr>
+          <a:xfrm>
+            <a:off x="509760" y="155520"/>
+            <a:ext cx="10285200" cy="456120"/>
+          </a:xfrm>
+          <a:prstGeom prst="rect">
+            <a:avLst/>
+          </a:prstGeom>
+          <a:noFill/>
+          <a:ln>
+            <a:noFill/>
+          </a:ln>
+        </p:spPr>
+        <p:style>
+          <a:lnRef idx="0">
+            <a:scrgbClr r="0" g="0" b="0"/>
+          </a:lnRef>
+          <a:fillRef idx="0">
+            <a:scrgbClr r="0" g="0" b="0"/>
+          </a:fillRef>
+          <a:effectRef idx="0">
+            <a:scrgbClr r="0" g="0" b="0"/>
+          </a:effectRef>
+          <a:fontRef idx="minor"/>
+        </p:style>
+        <p:txBody>
+          <a:bodyPr lIns="90000" tIns="45000" rIns="90000" bIns="45000">
+            <a:spAutoFit/>
+          </a:bodyPr>
+          <a:lstStyle/>
+          <a:p>
+            <a:pPr marL="285840" indent="-285480">
+              <a:lnSpc>
+                <a:spcPct val="100000"/>
+              </a:lnSpc>
+            </a:pPr>
+            <a:r>
+              <a:rPr lang="en-US" sz="2400" b="1" strike="noStrike" spc="-1">
+                <a:solidFill>
+                  <a:srgbClr val="2E75B6"/>
+                </a:solidFill>
+                <a:latin typeface="Calibri"/>
+              </a:rPr>
+              <a:t>Omeka in Azure Cloud (detail)</a:t>
+            </a:r>
+            <a:endParaRPr lang="en-US" sz="2400" b="0" strike="noStrike" spc="-1">
+              <a:solidFill>
+                <a:srgbClr val="000000"/>
+              </a:solidFill>
+              <a:latin typeface="Arial"/>
+            </a:endParaRPr>
+          </a:p>
+        </p:txBody>
+      </p:sp>
       <p:grpSp>
         <p:nvGrpSpPr>
-          <p:cNvPr id="366" name="Group 9"/>
+          <p:cNvPr id="380" name="Group 19"/>
           <p:cNvGrpSpPr/>
           <p:nvPr/>
         </p:nvGrpSpPr>
         <p:grpSpPr>
           <a:xfrm>
-            <a:off x="7730640" y="3023280"/>
-            <a:ext cx="1163160" cy="794160"/>
-            <a:chOff x="7730640" y="3023280"/>
-            <a:chExt cx="1163160" cy="794160"/>
+            <a:off x="998017" y="2751840"/>
+            <a:ext cx="1399271" cy="1088280"/>
+            <a:chOff x="420505" y="2751840"/>
+            <a:chExt cx="1399271" cy="1088280"/>
           </a:xfrm>
         </p:grpSpPr>
         <p:pic>
           <p:nvPicPr>
-            <p:cNvPr id="367" name="Picture 2" descr="Image result for folder"/>
+            <p:cNvPr id="381" name="Picture 2" descr="Image result for azure docker registry"/>
             <p:cNvPicPr/>
             <p:nvPr/>
           </p:nvPicPr>
           <p:blipFill>
-            <a:blip r:embed="rId2"/>
+            <a:blip r:embed="rId3"/>
+            <a:srcRect l="44436" t="8029" r="40888" b="33535"/>
             <a:stretch/>
           </p:blipFill>
           <p:spPr>
             <a:xfrm>
-              <a:off x="7730640" y="3023280"/>
-              <a:ext cx="1163160" cy="786600"/>
+              <a:off x="512280" y="2751840"/>
+              <a:ext cx="1188720" cy="1088280"/>
             </a:xfrm>
             <a:prstGeom prst="rect">
               <a:avLst/>
@@ -19861,14 +19992,241 @@
         </p:pic>
         <p:sp>
           <p:nvSpPr>
-            <p:cNvPr id="368" name="CustomShape 10"/>
+            <p:cNvPr id="382" name="CustomShape 20"/>
             <p:cNvSpPr/>
             <p:nvPr/>
           </p:nvSpPr>
           <p:spPr>
             <a:xfrm>
-              <a:off x="7802280" y="3179160"/>
-              <a:ext cx="1010160" cy="638280"/>
+              <a:off x="420505" y="2889000"/>
+              <a:ext cx="1399271" cy="921876"/>
+            </a:xfrm>
+            <a:prstGeom prst="rect">
+              <a:avLst/>
+            </a:prstGeom>
+            <a:noFill/>
+            <a:ln>
+              <a:noFill/>
+            </a:ln>
+          </p:spPr>
+          <p:style>
+            <a:lnRef idx="0">
+              <a:scrgbClr r="0" g="0" b="0"/>
+            </a:lnRef>
+            <a:fillRef idx="0">
+              <a:scrgbClr r="0" g="0" b="0"/>
+            </a:fillRef>
+            <a:effectRef idx="0">
+              <a:scrgbClr r="0" g="0" b="0"/>
+            </a:effectRef>
+            <a:fontRef idx="minor"/>
+          </p:style>
+          <p:txBody>
+            <a:bodyPr wrap="none" lIns="90000" tIns="45000" rIns="90000" bIns="45000">
+              <a:spAutoFit/>
+            </a:bodyPr>
+            <a:lstStyle/>
+            <a:p>
+              <a:pPr algn="ctr"/>
+              <a:r>
+                <a:rPr lang="en-US" sz="1800" b="1" strike="noStrike" spc="-1" dirty="0" err="1">
+                  <a:solidFill>
+                    <a:srgbClr val="333333"/>
+                  </a:solidFill>
+                  <a:effectLst>
+                    <a:glow rad="228600">
+                      <a:schemeClr val="bg1">
+                        <a:alpha val="91000"/>
+                      </a:schemeClr>
+                    </a:glow>
+                  </a:effectLst>
+                  <a:latin typeface="Calibri"/>
+                </a:rPr>
+                <a:t>AzurePrivate</a:t>
+              </a:r>
+              <a:br>
+                <a:rPr dirty="0">
+                  <a:effectLst>
+                    <a:glow rad="228600">
+                      <a:schemeClr val="bg1">
+                        <a:alpha val="91000"/>
+                      </a:schemeClr>
+                    </a:glow>
+                  </a:effectLst>
+                </a:rPr>
+              </a:br>
+              <a:r>
+                <a:rPr lang="en-US" sz="1800" b="1" strike="noStrike" spc="-1" dirty="0">
+                  <a:solidFill>
+                    <a:srgbClr val="333333"/>
+                  </a:solidFill>
+                  <a:effectLst>
+                    <a:glow rad="228600">
+                      <a:schemeClr val="bg1">
+                        <a:alpha val="91000"/>
+                      </a:schemeClr>
+                    </a:glow>
+                  </a:effectLst>
+                  <a:latin typeface="Calibri"/>
+                </a:rPr>
+                <a:t>Docker</a:t>
+              </a:r>
+              <a:br>
+                <a:rPr dirty="0">
+                  <a:effectLst>
+                    <a:glow rad="228600">
+                      <a:schemeClr val="bg1">
+                        <a:alpha val="91000"/>
+                      </a:schemeClr>
+                    </a:glow>
+                  </a:effectLst>
+                </a:rPr>
+              </a:br>
+              <a:r>
+                <a:rPr lang="en-US" sz="1800" b="1" strike="noStrike" spc="-1" dirty="0">
+                  <a:solidFill>
+                    <a:srgbClr val="333333"/>
+                  </a:solidFill>
+                  <a:effectLst>
+                    <a:glow rad="228600">
+                      <a:schemeClr val="bg1">
+                        <a:alpha val="91000"/>
+                      </a:schemeClr>
+                    </a:glow>
+                  </a:effectLst>
+                  <a:latin typeface="Calibri"/>
+                </a:rPr>
+                <a:t>Registry</a:t>
+              </a:r>
+              <a:r>
+                <a:rPr lang="en-US" sz="1800" b="1" strike="noStrike" spc="-1" dirty="0">
+                  <a:solidFill>
+                    <a:srgbClr val="000000"/>
+                  </a:solidFill>
+                  <a:effectLst>
+                    <a:glow rad="228600">
+                      <a:schemeClr val="bg1">
+                        <a:alpha val="91000"/>
+                      </a:schemeClr>
+                    </a:glow>
+                  </a:effectLst>
+                  <a:latin typeface="Calibri"/>
+                </a:rPr>
+                <a:t> </a:t>
+              </a:r>
+              <a:endParaRPr lang="en-US" sz="1800" b="0" strike="noStrike" spc="-1" dirty="0">
+                <a:solidFill>
+                  <a:srgbClr val="000000"/>
+                </a:solidFill>
+                <a:effectLst>
+                  <a:glow rad="228600">
+                    <a:schemeClr val="bg1">
+                      <a:alpha val="91000"/>
+                    </a:schemeClr>
+                  </a:glow>
+                </a:effectLst>
+                <a:latin typeface="Arial"/>
+              </a:endParaRPr>
+            </a:p>
+          </p:txBody>
+        </p:sp>
+      </p:grpSp>
+      <p:sp>
+        <p:nvSpPr>
+          <p:cNvPr id="361" name="CustomShape 5"/>
+          <p:cNvSpPr/>
+          <p:nvPr/>
+        </p:nvSpPr>
+        <p:spPr>
+          <a:xfrm>
+            <a:off x="6435168" y="2564227"/>
+            <a:ext cx="4516104" cy="1517760"/>
+          </a:xfrm>
+          <a:prstGeom prst="flowChartMagneticDisk">
+            <a:avLst/>
+          </a:prstGeom>
+          <a:solidFill>
+            <a:schemeClr val="bg1">
+              <a:lumMod val="95000"/>
+            </a:schemeClr>
+          </a:solidFill>
+          <a:ln w="44280">
+            <a:solidFill>
+              <a:schemeClr val="bg1">
+                <a:lumMod val="75000"/>
+              </a:schemeClr>
+            </a:solidFill>
+          </a:ln>
+        </p:spPr>
+        <p:style>
+          <a:lnRef idx="2">
+            <a:schemeClr val="accent1">
+              <a:shade val="50000"/>
+            </a:schemeClr>
+          </a:lnRef>
+          <a:fillRef idx="1">
+            <a:schemeClr val="accent1"/>
+          </a:fillRef>
+          <a:effectRef idx="0">
+            <a:schemeClr val="accent1"/>
+          </a:effectRef>
+          <a:fontRef idx="minor"/>
+        </p:style>
+        <p:txBody>
+          <a:bodyPr/>
+          <a:lstStyle/>
+          <a:p>
+            <a:endParaRPr lang="en-US"/>
+          </a:p>
+        </p:txBody>
+      </p:sp>
+      <p:grpSp>
+        <p:nvGrpSpPr>
+          <p:cNvPr id="363" name="Group 7"/>
+          <p:cNvGrpSpPr/>
+          <p:nvPr/>
+        </p:nvGrpSpPr>
+        <p:grpSpPr>
+          <a:xfrm>
+            <a:off x="9511405" y="3086234"/>
+            <a:ext cx="1163160" cy="749277"/>
+            <a:chOff x="6495120" y="3057120"/>
+            <a:chExt cx="1163160" cy="749277"/>
+          </a:xfrm>
+        </p:grpSpPr>
+        <p:pic>
+          <p:nvPicPr>
+            <p:cNvPr id="364" name="Picture 2" descr="Image result for folder"/>
+            <p:cNvPicPr/>
+            <p:nvPr/>
+          </p:nvPicPr>
+          <p:blipFill>
+            <a:blip r:embed="rId4"/>
+            <a:stretch/>
+          </p:blipFill>
+          <p:spPr>
+            <a:xfrm>
+              <a:off x="6495120" y="3057120"/>
+              <a:ext cx="1163160" cy="724680"/>
+            </a:xfrm>
+            <a:prstGeom prst="rect">
+              <a:avLst/>
+            </a:prstGeom>
+            <a:ln>
+              <a:noFill/>
+            </a:ln>
+          </p:spPr>
+        </p:pic>
+        <p:sp>
+          <p:nvSpPr>
+            <p:cNvPr id="365" name="CustomShape 8"/>
+            <p:cNvSpPr/>
+            <p:nvPr/>
+          </p:nvSpPr>
+          <p:spPr>
+            <a:xfrm>
+              <a:off x="6686408" y="3161520"/>
+              <a:ext cx="836744" cy="644877"/>
             </a:xfrm>
             <a:prstGeom prst="rect">
               <a:avLst/>
@@ -19902,25 +20260,31 @@
                 </a:lnSpc>
               </a:pPr>
               <a:r>
-                <a:rPr lang="en-US" sz="1800" b="1" strike="noStrike" spc="-1">
+                <a:rPr lang="en-US" sz="1800" b="1" strike="noStrike" spc="-1" dirty="0">
                   <a:solidFill>
                     <a:srgbClr val="000000"/>
                   </a:solidFill>
                   <a:latin typeface="Calibri"/>
                 </a:rPr>
-                <a:t>Plugin</a:t>
+                <a:t>CDASH</a:t>
               </a:r>
-              <a:br/>
+            </a:p>
+            <a:p>
+              <a:pPr algn="ctr">
+                <a:lnSpc>
+                  <a:spcPct val="100000"/>
+                </a:lnSpc>
+              </a:pPr>
               <a:r>
-                <a:rPr lang="en-US" sz="1800" b="1" strike="noStrike" spc="-1">
+                <a:rPr lang="en-US" sz="1800" b="1" strike="noStrike" spc="-1" dirty="0">
                   <a:solidFill>
                     <a:srgbClr val="000000"/>
                   </a:solidFill>
                   <a:latin typeface="Calibri"/>
                 </a:rPr>
-                <a:t>Modules</a:t>
+                <a:t>Theme</a:t>
               </a:r>
-              <a:endParaRPr lang="en-US" sz="1800" b="0" strike="noStrike" spc="-1">
+              <a:endParaRPr lang="en-US" sz="1800" b="0" strike="noStrike" spc="-1" dirty="0">
                 <a:solidFill>
                   <a:srgbClr val="000000"/>
                 </a:solidFill>
@@ -19938,10 +20302,10 @@
         </p:nvGrpSpPr>
         <p:grpSpPr>
           <a:xfrm>
-            <a:off x="8996040" y="3045960"/>
-            <a:ext cx="1163160" cy="816120"/>
-            <a:chOff x="8996040" y="3045960"/>
-            <a:chExt cx="1163160" cy="816120"/>
+            <a:off x="6724968" y="3026689"/>
+            <a:ext cx="1163160" cy="820526"/>
+            <a:chOff x="5194440" y="3008712"/>
+            <a:chExt cx="1163160" cy="820526"/>
           </a:xfrm>
         </p:grpSpPr>
         <p:pic>
@@ -19951,12 +20315,12 @@
             <p:nvPr/>
           </p:nvPicPr>
           <p:blipFill>
-            <a:blip r:embed="rId2"/>
+            <a:blip r:embed="rId4"/>
             <a:stretch/>
           </p:blipFill>
           <p:spPr>
             <a:xfrm>
-              <a:off x="8996040" y="3045960"/>
+              <a:off x="5194440" y="3008712"/>
               <a:ext cx="1163160" cy="786600"/>
             </a:xfrm>
             <a:prstGeom prst="rect">
@@ -19975,8 +20339,8 @@
           </p:nvSpPr>
           <p:spPr>
             <a:xfrm>
-              <a:off x="9020160" y="3223080"/>
-              <a:ext cx="1119960" cy="639000"/>
+              <a:off x="5302080" y="3184361"/>
+              <a:ext cx="844632" cy="644877"/>
             </a:xfrm>
             <a:prstGeom prst="rect">
               <a:avLst/>
@@ -20010,107 +20374,15 @@
                 </a:lnSpc>
               </a:pPr>
               <a:r>
-                <a:rPr lang="en-US" sz="1800" b="1" strike="noStrike" spc="-1">
+                <a:rPr lang="en-US" sz="1800" b="1" strike="noStrike" spc="-1" dirty="0">
                   <a:solidFill>
                     <a:srgbClr val="000000"/>
                   </a:solidFill>
                   <a:latin typeface="Calibri"/>
                 </a:rPr>
-                <a:t>Imported </a:t>
+                <a:t> Media</a:t>
               </a:r>
-              <a:br/>
-              <a:r>
-                <a:rPr lang="en-US" sz="1800" b="1" strike="noStrike" spc="-1">
-                  <a:solidFill>
-                    <a:srgbClr val="000000"/>
-                  </a:solidFill>
-                  <a:latin typeface="Calibri"/>
-                </a:rPr>
-                <a:t>Media</a:t>
-              </a:r>
-              <a:endParaRPr lang="en-US" sz="1800" b="0" strike="noStrike" spc="-1">
-                <a:solidFill>
-                  <a:srgbClr val="000000"/>
-                </a:solidFill>
-                <a:latin typeface="Arial"/>
-              </a:endParaRPr>
             </a:p>
-          </p:txBody>
-        </p:sp>
-      </p:grpSp>
-      <p:grpSp>
-        <p:nvGrpSpPr>
-          <p:cNvPr id="372" name="Group 13"/>
-          <p:cNvGrpSpPr/>
-          <p:nvPr/>
-        </p:nvGrpSpPr>
-        <p:grpSpPr>
-          <a:xfrm>
-            <a:off x="1924200" y="2527920"/>
-            <a:ext cx="1602720" cy="1623240"/>
-            <a:chOff x="1924200" y="2527920"/>
-            <a:chExt cx="1602720" cy="1623240"/>
-          </a:xfrm>
-        </p:grpSpPr>
-        <p:pic>
-          <p:nvPicPr>
-            <p:cNvPr id="373" name="Picture 2"/>
-            <p:cNvPicPr/>
-            <p:nvPr/>
-          </p:nvPicPr>
-          <p:blipFill>
-            <a:blip r:embed="rId3"/>
-            <a:stretch/>
-          </p:blipFill>
-          <p:spPr>
-            <a:xfrm>
-              <a:off x="1924200" y="2527920"/>
-              <a:ext cx="1602720" cy="1450080"/>
-            </a:xfrm>
-            <a:prstGeom prst="rect">
-              <a:avLst/>
-            </a:prstGeom>
-            <a:ln>
-              <a:noFill/>
-            </a:ln>
-          </p:spPr>
-        </p:pic>
-        <p:sp>
-          <p:nvSpPr>
-            <p:cNvPr id="374" name="CustomShape 14"/>
-            <p:cNvSpPr/>
-            <p:nvPr/>
-          </p:nvSpPr>
-          <p:spPr>
-            <a:xfrm>
-              <a:off x="2176920" y="3086640"/>
-              <a:ext cx="1096920" cy="1064520"/>
-            </a:xfrm>
-            <a:prstGeom prst="rect">
-              <a:avLst/>
-            </a:prstGeom>
-            <a:noFill/>
-            <a:ln>
-              <a:noFill/>
-            </a:ln>
-          </p:spPr>
-          <p:style>
-            <a:lnRef idx="0">
-              <a:scrgbClr r="0" g="0" b="0"/>
-            </a:lnRef>
-            <a:fillRef idx="0">
-              <a:scrgbClr r="0" g="0" b="0"/>
-            </a:fillRef>
-            <a:effectRef idx="0">
-              <a:scrgbClr r="0" g="0" b="0"/>
-            </a:effectRef>
-            <a:fontRef idx="minor"/>
-          </p:style>
-          <p:txBody>
-            <a:bodyPr wrap="none" lIns="90000" tIns="45000" rIns="90000" bIns="45000">
-              <a:spAutoFit/>
-            </a:bodyPr>
-            <a:lstStyle/>
             <a:p>
               <a:pPr algn="ctr">
                 <a:lnSpc>
@@ -20118,57 +20390,15 @@
                 </a:lnSpc>
               </a:pPr>
               <a:r>
-                <a:rPr lang="en-US" sz="1400" b="1" strike="noStrike" spc="-1">
+                <a:rPr lang="en-US" b="1" spc="-1" dirty="0">
                   <a:solidFill>
-                    <a:srgbClr val="333333"/>
+                    <a:srgbClr val="000000"/>
                   </a:solidFill>
                   <a:latin typeface="Calibri"/>
                 </a:rPr>
-                <a:t>Container</a:t>
+                <a:t>Files</a:t>
               </a:r>
-              <a:r>
-                <a:rPr lang="en-US" sz="1800" b="1" strike="noStrike" spc="-1">
-                  <a:solidFill>
-                    <a:srgbClr val="333333"/>
-                  </a:solidFill>
-                  <a:latin typeface="Calibri"/>
-                </a:rPr>
-                <a:t> </a:t>
-              </a:r>
-              <a:br/>
-              <a:r>
-                <a:rPr lang="en-US" sz="1400" b="1" strike="noStrike" spc="-1">
-                  <a:solidFill>
-                    <a:srgbClr val="333333"/>
-                  </a:solidFill>
-                  <a:latin typeface="Calibri"/>
-                </a:rPr>
-                <a:t>Apache/php</a:t>
-              </a:r>
-              <a:br/>
-              <a:r>
-                <a:rPr lang="en-US" sz="1400" b="1" strike="noStrike" spc="-1">
-                  <a:solidFill>
-                    <a:srgbClr val="333333"/>
-                  </a:solidFill>
-                  <a:latin typeface="Calibri"/>
-                </a:rPr>
-                <a:t>Omeka</a:t>
-              </a:r>
-              <a:endParaRPr lang="en-US" sz="1400" b="0" strike="noStrike" spc="-1">
-                <a:solidFill>
-                  <a:srgbClr val="000000"/>
-                </a:solidFill>
-                <a:latin typeface="Arial"/>
-              </a:endParaRPr>
-            </a:p>
-            <a:p>
-              <a:pPr algn="ctr">
-                <a:lnSpc>
-                  <a:spcPct val="100000"/>
-                </a:lnSpc>
-              </a:pPr>
-              <a:endParaRPr lang="en-US" sz="1400" b="0" strike="noStrike" spc="-1">
+              <a:endParaRPr lang="en-US" sz="1800" b="0" strike="noStrike" spc="-1" dirty="0">
                 <a:solidFill>
                   <a:srgbClr val="000000"/>
                 </a:solidFill>
@@ -20178,104 +20408,6 @@
           </p:txBody>
         </p:sp>
       </p:grpSp>
-      <p:grpSp>
-        <p:nvGrpSpPr>
-          <p:cNvPr id="375" name="Group 15"/>
-          <p:cNvGrpSpPr/>
-          <p:nvPr/>
-        </p:nvGrpSpPr>
-        <p:grpSpPr>
-          <a:xfrm>
-            <a:off x="10261080" y="3092040"/>
-            <a:ext cx="1188360" cy="740520"/>
-            <a:chOff x="10261080" y="3092040"/>
-            <a:chExt cx="1188360" cy="740520"/>
-          </a:xfrm>
-        </p:grpSpPr>
-        <p:pic>
-          <p:nvPicPr>
-            <p:cNvPr id="376" name="Picture 2" descr="Image result for folder"/>
-            <p:cNvPicPr/>
-            <p:nvPr/>
-          </p:nvPicPr>
-          <p:blipFill>
-            <a:blip r:embed="rId2"/>
-            <a:stretch/>
-          </p:blipFill>
-          <p:spPr>
-            <a:xfrm>
-              <a:off x="10261080" y="3092040"/>
-              <a:ext cx="1188360" cy="740520"/>
-            </a:xfrm>
-            <a:prstGeom prst="rect">
-              <a:avLst/>
-            </a:prstGeom>
-            <a:ln>
-              <a:noFill/>
-            </a:ln>
-          </p:spPr>
-        </p:pic>
-        <p:sp>
-          <p:nvSpPr>
-            <p:cNvPr id="377" name="CustomShape 16"/>
-            <p:cNvSpPr/>
-            <p:nvPr/>
-          </p:nvSpPr>
-          <p:spPr>
-            <a:xfrm>
-              <a:off x="10555920" y="3295800"/>
-              <a:ext cx="598680" cy="363960"/>
-            </a:xfrm>
-            <a:prstGeom prst="rect">
-              <a:avLst/>
-            </a:prstGeom>
-            <a:noFill/>
-            <a:ln>
-              <a:noFill/>
-            </a:ln>
-          </p:spPr>
-          <p:style>
-            <a:lnRef idx="0">
-              <a:scrgbClr r="0" g="0" b="0"/>
-            </a:lnRef>
-            <a:fillRef idx="0">
-              <a:scrgbClr r="0" g="0" b="0"/>
-            </a:fillRef>
-            <a:effectRef idx="0">
-              <a:scrgbClr r="0" g="0" b="0"/>
-            </a:effectRef>
-            <a:fontRef idx="minor"/>
-          </p:style>
-          <p:txBody>
-            <a:bodyPr wrap="none" lIns="90000" tIns="45000" rIns="90000" bIns="45000">
-              <a:spAutoFit/>
-            </a:bodyPr>
-            <a:lstStyle/>
-            <a:p>
-              <a:pPr algn="ctr">
-                <a:lnSpc>
-                  <a:spcPct val="100000"/>
-                </a:lnSpc>
-              </a:pPr>
-              <a:r>
-                <a:rPr lang="en-US" sz="1800" b="1" strike="noStrike" spc="-1">
-                  <a:solidFill>
-                    <a:srgbClr val="000000"/>
-                  </a:solidFill>
-                  <a:latin typeface="Calibri"/>
-                </a:rPr>
-                <a:t>Logs</a:t>
-              </a:r>
-              <a:endParaRPr lang="en-US" sz="1800" b="0" strike="noStrike" spc="-1">
-                <a:solidFill>
-                  <a:srgbClr val="000000"/>
-                </a:solidFill>
-                <a:latin typeface="Arial"/>
-              </a:endParaRPr>
-            </a:p>
-          </p:txBody>
-        </p:sp>
-      </p:grpSp>
       <p:sp>
         <p:nvSpPr>
           <p:cNvPr id="378" name="CustomShape 17"/>
@@ -20284,8 +20416,8 @@
         </p:nvSpPr>
         <p:spPr>
           <a:xfrm>
-            <a:off x="5735880" y="2630880"/>
-            <a:ext cx="4861440" cy="364680"/>
+            <a:off x="8221414" y="2629517"/>
+            <a:ext cx="1205180" cy="367878"/>
           </a:xfrm>
           <a:prstGeom prst="rect">
             <a:avLst/>
@@ -20319,15 +20451,33 @@
               </a:lnSpc>
             </a:pPr>
             <a:r>
-              <a:rPr lang="en-US" sz="1800" b="1" strike="noStrike" spc="-1">
+              <a:rPr lang="en-US" b="1" spc="-1" dirty="0" err="1">
                 <a:solidFill>
                   <a:srgbClr val="000000"/>
                 </a:solidFill>
                 <a:latin typeface="Calibri"/>
               </a:rPr>
-              <a:t>chcPersist Volume (Fast, single zone redundancy) </a:t>
-            </a:r>
-            <a:endParaRPr lang="en-US" sz="1800" b="0" strike="noStrike" spc="-1">
+              <a:t>C</a:t>
+            </a:r>
+            <a:r>
+              <a:rPr lang="en-US" sz="1800" b="1" strike="noStrike" spc="-1" dirty="0" err="1">
+                <a:solidFill>
+                  <a:srgbClr val="000000"/>
+                </a:solidFill>
+                <a:latin typeface="Calibri"/>
+              </a:rPr>
+              <a:t>hcPersist</a:t>
+            </a:r>
+            <a:r>
+              <a:rPr lang="en-US" sz="1800" b="1" strike="noStrike" spc="-1" dirty="0">
+                <a:solidFill>
+                  <a:srgbClr val="000000"/>
+                </a:solidFill>
+                <a:latin typeface="Calibri"/>
+              </a:rPr>
+              <a:t> </a:t>
+            </a:r>
+            <a:endParaRPr lang="en-US" sz="1800" b="0" strike="noStrike" spc="-1" dirty="0">
               <a:solidFill>
                 <a:srgbClr val="000000"/>
               </a:solidFill>
@@ -20336,179 +20486,6 @@
           </a:p>
         </p:txBody>
       </p:sp>
-      <p:sp>
-        <p:nvSpPr>
-          <p:cNvPr id="379" name="CustomShape 18"/>
-          <p:cNvSpPr/>
-          <p:nvPr/>
-        </p:nvSpPr>
-        <p:spPr>
-          <a:xfrm>
-            <a:off x="3675240" y="2613600"/>
-            <a:ext cx="919080" cy="1364400"/>
-          </a:xfrm>
-          <a:prstGeom prst="flowChartMagneticDisk">
-            <a:avLst/>
-          </a:prstGeom>
-          <a:solidFill>
-            <a:schemeClr val="bg1">
-              <a:lumMod val="95000"/>
-            </a:schemeClr>
-          </a:solidFill>
-          <a:ln w="44280">
-            <a:solidFill>
-              <a:schemeClr val="bg1">
-                <a:lumMod val="75000"/>
-              </a:schemeClr>
-            </a:solidFill>
-          </a:ln>
-        </p:spPr>
-        <p:style>
-          <a:lnRef idx="2">
-            <a:schemeClr val="accent1">
-              <a:shade val="50000"/>
-            </a:schemeClr>
-          </a:lnRef>
-          <a:fillRef idx="1">
-            <a:schemeClr val="accent1"/>
-          </a:fillRef>
-          <a:effectRef idx="0">
-            <a:schemeClr val="accent1"/>
-          </a:effectRef>
-          <a:fontRef idx="minor"/>
-        </p:style>
-        <p:txBody>
-          <a:bodyPr/>
-          <a:lstStyle/>
-          <a:p>
-            <a:endParaRPr lang="en-US"/>
-          </a:p>
-        </p:txBody>
-      </p:sp>
-      <p:grpSp>
-        <p:nvGrpSpPr>
-          <p:cNvPr id="380" name="Group 19"/>
-          <p:cNvGrpSpPr/>
-          <p:nvPr/>
-        </p:nvGrpSpPr>
-        <p:grpSpPr>
-          <a:xfrm>
-            <a:off x="423000" y="2751840"/>
-            <a:ext cx="1394280" cy="1088280"/>
-            <a:chOff x="423000" y="2751840"/>
-            <a:chExt cx="1394280" cy="1088280"/>
-          </a:xfrm>
-        </p:grpSpPr>
-        <p:pic>
-          <p:nvPicPr>
-            <p:cNvPr id="381" name="Picture 2" descr="Image result for azure docker registry"/>
-            <p:cNvPicPr/>
-            <p:nvPr/>
-          </p:nvPicPr>
-          <p:blipFill>
-            <a:blip r:embed="rId4"/>
-            <a:srcRect l="44436" t="8029" r="40888" b="33535"/>
-            <a:stretch/>
-          </p:blipFill>
-          <p:spPr>
-            <a:xfrm>
-              <a:off x="512280" y="2751840"/>
-              <a:ext cx="1188720" cy="1088280"/>
-            </a:xfrm>
-            <a:prstGeom prst="rect">
-              <a:avLst/>
-            </a:prstGeom>
-            <a:ln>
-              <a:noFill/>
-            </a:ln>
-          </p:spPr>
-        </p:pic>
-        <p:sp>
-          <p:nvSpPr>
-            <p:cNvPr id="382" name="CustomShape 20"/>
-            <p:cNvSpPr/>
-            <p:nvPr/>
-          </p:nvSpPr>
-          <p:spPr>
-            <a:xfrm>
-              <a:off x="423000" y="2889000"/>
-              <a:ext cx="1394280" cy="911880"/>
-            </a:xfrm>
-            <a:prstGeom prst="rect">
-              <a:avLst/>
-            </a:prstGeom>
-            <a:noFill/>
-            <a:ln>
-              <a:noFill/>
-            </a:ln>
-          </p:spPr>
-          <p:style>
-            <a:lnRef idx="0">
-              <a:scrgbClr r="0" g="0" b="0"/>
-            </a:lnRef>
-            <a:fillRef idx="0">
-              <a:scrgbClr r="0" g="0" b="0"/>
-            </a:fillRef>
-            <a:effectRef idx="0">
-              <a:scrgbClr r="0" g="0" b="0"/>
-            </a:effectRef>
-            <a:fontRef idx="minor"/>
-          </p:style>
-          <p:txBody>
-            <a:bodyPr wrap="none" lIns="90000" tIns="45000" rIns="90000" bIns="45000">
-              <a:spAutoFit/>
-            </a:bodyPr>
-            <a:lstStyle/>
-            <a:p>
-              <a:pPr algn="ctr"/>
-              <a:r>
-                <a:rPr lang="en-US" sz="1800" b="1" strike="noStrike" spc="-1">
-                  <a:solidFill>
-                    <a:srgbClr val="333333"/>
-                  </a:solidFill>
-                  <a:latin typeface="Calibri"/>
-                </a:rPr>
-                <a:t>AzurePrivate</a:t>
-              </a:r>
-              <a:br/>
-              <a:r>
-                <a:rPr lang="en-US" sz="1800" b="1" strike="noStrike" spc="-1">
-                  <a:solidFill>
-                    <a:srgbClr val="333333"/>
-                  </a:solidFill>
-                  <a:latin typeface="Calibri"/>
-                </a:rPr>
-                <a:t>Docker</a:t>
-              </a:r>
-              <a:br/>
-              <a:r>
-                <a:rPr lang="en-US" sz="1800" b="1" strike="noStrike" spc="-1">
-                  <a:solidFill>
-                    <a:srgbClr val="333333"/>
-                  </a:solidFill>
-                  <a:latin typeface="Calibri"/>
-                </a:rPr>
-                <a:t>Registry</a:t>
-              </a:r>
-              <a:r>
-                <a:rPr lang="en-US" sz="1800" b="1" strike="noStrike" spc="-1">
-                  <a:solidFill>
-                    <a:srgbClr val="000000"/>
-                  </a:solidFill>
-                  <a:latin typeface="Calibri"/>
-                </a:rPr>
-                <a:t> </a:t>
-              </a:r>
-              <a:endParaRPr lang="en-US" sz="1800" b="0" strike="noStrike" spc="-1">
-                <a:solidFill>
-                  <a:srgbClr val="000000"/>
-                </a:solidFill>
-                <a:latin typeface="Arial"/>
-              </a:endParaRPr>
-            </a:p>
-          </p:txBody>
-        </p:sp>
-      </p:grpSp>
       <p:grpSp>
         <p:nvGrpSpPr>
           <p:cNvPr id="383" name="Group 21"/>
@@ -20517,10 +20494,10 @@
         </p:nvGrpSpPr>
         <p:grpSpPr>
           <a:xfrm>
-            <a:off x="5225400" y="3039480"/>
-            <a:ext cx="1188360" cy="789120"/>
-            <a:chOff x="5225400" y="3039480"/>
-            <a:chExt cx="1188360" cy="789120"/>
+            <a:off x="8032572" y="3068010"/>
+            <a:ext cx="1188360" cy="777228"/>
+            <a:chOff x="5270580" y="3051372"/>
+            <a:chExt cx="1188360" cy="777228"/>
           </a:xfrm>
         </p:grpSpPr>
         <p:pic>
@@ -20530,12 +20507,12 @@
             <p:nvPr/>
           </p:nvPicPr>
           <p:blipFill>
-            <a:blip r:embed="rId2"/>
+            <a:blip r:embed="rId4"/>
             <a:stretch/>
           </p:blipFill>
           <p:spPr>
             <a:xfrm>
-              <a:off x="5225400" y="3039480"/>
+              <a:off x="5270580" y="3051372"/>
               <a:ext cx="1188360" cy="740520"/>
             </a:xfrm>
             <a:prstGeom prst="rect">
@@ -20589,7 +20566,7 @@
                 </a:lnSpc>
               </a:pPr>
               <a:r>
-                <a:rPr lang="en-US" sz="1800" b="1" strike="noStrike" spc="-1">
+                <a:rPr lang="en-US" sz="1800" b="1" strike="noStrike" spc="-1" dirty="0">
                   <a:solidFill>
                     <a:srgbClr val="000000"/>
                   </a:solidFill>
@@ -20597,9 +20574,11 @@
                 </a:rPr>
                 <a:t>Omeka</a:t>
               </a:r>
-              <a:br/>
+              <a:br>
+                <a:rPr dirty="0"/>
+              </a:br>
               <a:r>
-                <a:rPr lang="en-US" sz="1800" b="1" strike="noStrike" spc="-1">
+                <a:rPr lang="en-US" sz="1800" b="1" strike="noStrike" spc="-1" dirty="0">
                   <a:solidFill>
                     <a:srgbClr val="000000"/>
                   </a:solidFill>
@@ -20607,7 +20586,7 @@
                 </a:rPr>
                 <a:t>Config</a:t>
               </a:r>
-              <a:endParaRPr lang="en-US" sz="1800" b="0" strike="noStrike" spc="-1">
+              <a:endParaRPr lang="en-US" sz="1800" b="0" strike="noStrike" spc="-1" dirty="0">
                 <a:solidFill>
                   <a:srgbClr val="000000"/>
                 </a:solidFill>
@@ -20625,8 +20604,8 @@
         </p:nvSpPr>
         <p:spPr>
           <a:xfrm>
-            <a:off x="3996720" y="820440"/>
-            <a:ext cx="907920" cy="639000"/>
+            <a:off x="9571329" y="1429938"/>
+            <a:ext cx="1543285" cy="644877"/>
           </a:xfrm>
           <a:prstGeom prst="rect">
             <a:avLst/>
@@ -20660,19 +20639,19 @@
               </a:lnSpc>
             </a:pPr>
             <a:r>
-              <a:rPr lang="en-US" sz="1800" b="1" strike="noStrike" spc="-1">
+              <a:rPr lang="en-US" b="1" spc="-1" dirty="0">
                 <a:solidFill>
                   <a:srgbClr val="000000"/>
                 </a:solidFill>
                 <a:latin typeface="Calibri"/>
               </a:rPr>
-              <a:t>Omeka </a:t>
-            </a:r>
-            <a:endParaRPr lang="en-US" sz="1800" b="0" strike="noStrike" spc="-1">
-              <a:solidFill>
-                <a:srgbClr val="000000"/>
-              </a:solidFill>
-              <a:latin typeface="Arial"/>
+              <a:t>Omeka Admin</a:t>
+            </a:r>
+            <a:endParaRPr lang="en-US" sz="1800" b="1" strike="noStrike" spc="-1" dirty="0">
+              <a:solidFill>
+                <a:srgbClr val="000000"/>
+              </a:solidFill>
+              <a:latin typeface="Calibri"/>
             </a:endParaRPr>
           </a:p>
           <a:p>
@@ -20682,15 +20661,15 @@
               </a:lnSpc>
             </a:pPr>
             <a:r>
-              <a:rPr lang="en-US" sz="1800" b="1" strike="noStrike" spc="-1">
+              <a:rPr lang="en-US" sz="1800" b="1" strike="noStrike" spc="-1" dirty="0">
                 <a:solidFill>
                   <a:srgbClr val="000000"/>
                 </a:solidFill>
                 <a:latin typeface="Calibri"/>
               </a:rPr>
-              <a:t>Owner</a:t>
-            </a:r>
-            <a:endParaRPr lang="en-US" sz="1800" b="0" strike="noStrike" spc="-1">
+              <a:t>New Content</a:t>
+            </a:r>
+            <a:endParaRPr lang="en-US" sz="1800" b="0" strike="noStrike" spc="-1" dirty="0">
               <a:solidFill>
                 <a:srgbClr val="000000"/>
               </a:solidFill>
@@ -20707,7 +20686,7 @@
         </p:nvSpPr>
         <p:spPr>
           <a:xfrm>
-            <a:off x="3657600" y="1874880"/>
+            <a:off x="4235112" y="1874880"/>
             <a:ext cx="181080" cy="639000"/>
           </a:xfrm>
           <a:prstGeom prst="rect">
@@ -20759,7 +20738,7 @@
         </p:nvSpPr>
         <p:spPr>
           <a:xfrm>
-            <a:off x="3008160" y="813960"/>
+            <a:off x="1095599" y="853200"/>
             <a:ext cx="907920" cy="639000"/>
           </a:xfrm>
           <a:prstGeom prst="rect">
@@ -20794,7 +20773,7 @@
               </a:lnSpc>
             </a:pPr>
             <a:r>
-              <a:rPr lang="en-US" sz="1800" b="1" strike="noStrike" spc="-1">
+              <a:rPr lang="en-US" sz="1800" b="1" strike="noStrike" spc="-1" dirty="0">
                 <a:solidFill>
                   <a:srgbClr val="000000"/>
                 </a:solidFill>
@@ -20802,9 +20781,11 @@
               </a:rPr>
               <a:t>Omeka </a:t>
             </a:r>
-            <a:br/>
-            <a:r>
-              <a:rPr lang="en-US" sz="1800" b="1" strike="noStrike" spc="-1">
+            <a:br>
+              <a:rPr dirty="0"/>
+            </a:br>
+            <a:r>
+              <a:rPr lang="en-US" sz="1800" b="1" strike="noStrike" spc="-1" dirty="0">
                 <a:solidFill>
                   <a:srgbClr val="000000"/>
                 </a:solidFill>
@@ -20812,7 +20793,7 @@
               </a:rPr>
               <a:t>Users</a:t>
             </a:r>
-            <a:endParaRPr lang="en-US" sz="1800" b="0" strike="noStrike" spc="-1">
+            <a:endParaRPr lang="en-US" sz="1800" b="0" strike="noStrike" spc="-1" dirty="0">
               <a:solidFill>
                 <a:srgbClr val="000000"/>
               </a:solidFill>
@@ -20829,7 +20810,7 @@
         </p:nvSpPr>
         <p:spPr>
           <a:xfrm>
-            <a:off x="1629360" y="803160"/>
+            <a:off x="2399760" y="843955"/>
             <a:ext cx="1375920" cy="639000"/>
           </a:xfrm>
           <a:prstGeom prst="rect">
@@ -20864,7 +20845,7 @@
               </a:lnSpc>
             </a:pPr>
             <a:r>
-              <a:rPr lang="en-US" sz="1800" b="1" strike="noStrike" spc="-1">
+              <a:rPr lang="en-US" sz="1800" b="1" strike="noStrike" spc="-1" dirty="0">
                 <a:solidFill>
                   <a:srgbClr val="000000"/>
                 </a:solidFill>
@@ -20872,9 +20853,11 @@
               </a:rPr>
               <a:t>Omeka </a:t>
             </a:r>
-            <a:br/>
-            <a:r>
-              <a:rPr lang="en-US" sz="1800" b="1" strike="noStrike" spc="-1">
+            <a:br>
+              <a:rPr dirty="0"/>
+            </a:br>
+            <a:r>
+              <a:rPr lang="en-US" sz="1800" b="1" strike="noStrike" spc="-1" dirty="0">
                 <a:solidFill>
                   <a:srgbClr val="000000"/>
                 </a:solidFill>
@@ -20882,7 +20865,7 @@
               </a:rPr>
               <a:t>Contributors</a:t>
             </a:r>
-            <a:endParaRPr lang="en-US" sz="1800" b="0" strike="noStrike" spc="-1">
+            <a:endParaRPr lang="en-US" sz="1800" b="0" strike="noStrike" spc="-1" dirty="0">
               <a:solidFill>
                 <a:srgbClr val="000000"/>
               </a:solidFill>
@@ -20899,8 +20882,8 @@
         </p:nvSpPr>
         <p:spPr>
           <a:xfrm>
-            <a:off x="8865000" y="4073400"/>
-            <a:ext cx="1365840" cy="1065600"/>
+            <a:off x="9442512" y="4073399"/>
+            <a:ext cx="1365840" cy="1528849"/>
           </a:xfrm>
           <a:prstGeom prst="flowChartMagneticDisk">
             <a:avLst/>
@@ -20948,8 +20931,8 @@
         </p:nvSpPr>
         <p:spPr>
           <a:xfrm>
-            <a:off x="257400" y="5091480"/>
-            <a:ext cx="1657800" cy="1187640"/>
+            <a:off x="886646" y="5284878"/>
+            <a:ext cx="1522959" cy="367878"/>
           </a:xfrm>
           <a:prstGeom prst="rect">
             <a:avLst/>
@@ -20983,81 +20966,15 @@
               </a:lnSpc>
             </a:pPr>
             <a:r>
-              <a:rPr lang="en-US" sz="1800" b="1" strike="noStrike" spc="-1">
+              <a:rPr lang="en-US" sz="1800" b="1" strike="noStrike" spc="-1" dirty="0">
                 <a:solidFill>
                   <a:srgbClr val="000000"/>
                 </a:solidFill>
                 <a:latin typeface="Calibri"/>
               </a:rPr>
-              <a:t>Deployment</a:t>
-            </a:r>
-            <a:endParaRPr lang="en-US" sz="1800" b="0" strike="noStrike" spc="-1">
-              <a:solidFill>
-                <a:srgbClr val="000000"/>
-              </a:solidFill>
-              <a:latin typeface="Arial"/>
-            </a:endParaRPr>
-          </a:p>
-          <a:p>
-            <a:pPr algn="ctr">
-              <a:lnSpc>
-                <a:spcPct val="100000"/>
-              </a:lnSpc>
-            </a:pPr>
-            <a:r>
-              <a:rPr lang="en-US" sz="1800" b="1" strike="noStrike" spc="-1">
-                <a:solidFill>
-                  <a:srgbClr val="000000"/>
-                </a:solidFill>
-                <a:latin typeface="Calibri"/>
-              </a:rPr>
-              <a:t>Scripts</a:t>
-            </a:r>
-            <a:endParaRPr lang="en-US" sz="1800" b="0" strike="noStrike" spc="-1">
-              <a:solidFill>
-                <a:srgbClr val="000000"/>
-              </a:solidFill>
-              <a:latin typeface="Arial"/>
-            </a:endParaRPr>
-          </a:p>
-          <a:p>
-            <a:pPr algn="ctr">
-              <a:lnSpc>
-                <a:spcPct val="100000"/>
-              </a:lnSpc>
-            </a:pPr>
-            <a:r>
-              <a:rPr lang="en-US" sz="1800" b="1" strike="noStrike" spc="-1">
-                <a:solidFill>
-                  <a:srgbClr val="000000"/>
-                </a:solidFill>
-                <a:latin typeface="Calibri"/>
-              </a:rPr>
-              <a:t>Passwords</a:t>
-            </a:r>
-            <a:endParaRPr lang="en-US" sz="1800" b="0" strike="noStrike" spc="-1">
-              <a:solidFill>
-                <a:srgbClr val="000000"/>
-              </a:solidFill>
-              <a:latin typeface="Arial"/>
-            </a:endParaRPr>
-          </a:p>
-          <a:p>
-            <a:pPr algn="ctr">
-              <a:lnSpc>
-                <a:spcPct val="100000"/>
-              </a:lnSpc>
-            </a:pPr>
-            <a:r>
-              <a:rPr lang="en-US" sz="1800" b="1" strike="noStrike" spc="-1">
-                <a:solidFill>
-                  <a:srgbClr val="000000"/>
-                </a:solidFill>
-                <a:latin typeface="Calibri"/>
-              </a:rPr>
-              <a:t>Documentation</a:t>
-            </a:r>
-            <a:endParaRPr lang="en-US" sz="1800" b="0" strike="noStrike" spc="-1">
+              <a:t>Development </a:t>
+            </a:r>
+            <a:endParaRPr lang="en-US" sz="1800" b="0" strike="noStrike" spc="-1" dirty="0">
               <a:solidFill>
                 <a:srgbClr val="000000"/>
               </a:solidFill>
@@ -21074,8 +20991,8 @@
         </p:nvSpPr>
         <p:spPr>
           <a:xfrm>
-            <a:off x="1797120" y="5309640"/>
-            <a:ext cx="1950480" cy="639000"/>
+            <a:off x="2554149" y="5258601"/>
+            <a:ext cx="1834967" cy="921876"/>
           </a:xfrm>
           <a:prstGeom prst="rect">
             <a:avLst/>
@@ -21109,15 +21026,59 @@
               </a:lnSpc>
             </a:pPr>
             <a:r>
-              <a:rPr lang="en-US" sz="1800" b="1" strike="noStrike" spc="-1">
+              <a:rPr lang="en-US" sz="1800" b="1" strike="noStrike" spc="-1" dirty="0">
                 <a:solidFill>
                   <a:srgbClr val="000000"/>
                 </a:solidFill>
                 <a:latin typeface="Calibri"/>
               </a:rPr>
-              <a:t>System Inspection </a:t>
-            </a:r>
-            <a:endParaRPr lang="en-US" sz="1800" b="0" strike="noStrike" spc="-1">
+              <a:t>Passwords</a:t>
+            </a:r>
+            <a:r>
+              <a:rPr lang="en-US" spc="-1" dirty="0">
+                <a:solidFill>
+                  <a:srgbClr val="000000"/>
+                </a:solidFill>
+                <a:latin typeface="Arial"/>
+              </a:rPr>
+              <a:t>, </a:t>
+            </a:r>
+            <a:r>
+              <a:rPr lang="en-US" b="1" spc="-1" dirty="0">
+                <a:solidFill>
+                  <a:srgbClr val="000000"/>
+                </a:solidFill>
+                <a:latin typeface="Calibri"/>
+              </a:rPr>
+              <a:t>Docs</a:t>
+            </a:r>
+            <a:br>
+              <a:rPr lang="en-US" b="1" spc="-1" dirty="0">
+                <a:solidFill>
+                  <a:srgbClr val="000000"/>
+                </a:solidFill>
+                <a:latin typeface="Calibri"/>
+              </a:rPr>
+            </a:br>
+            <a:r>
+              <a:rPr lang="en-US" b="1" spc="-1" dirty="0">
+                <a:solidFill>
+                  <a:srgbClr val="000000"/>
+                </a:solidFill>
+                <a:latin typeface="Calibri"/>
+              </a:rPr>
+              <a:t>Troubleshooting</a:t>
+            </a:r>
+            <a:r>
+              <a:rPr lang="en-US" sz="1800" b="1" strike="noStrike" spc="-1" dirty="0">
+                <a:solidFill>
+                  <a:srgbClr val="000000"/>
+                </a:solidFill>
+                <a:latin typeface="Calibri"/>
+              </a:rPr>
+              <a:t> </a:t>
+            </a:r>
+            <a:endParaRPr lang="en-US" sz="1800" b="0" strike="noStrike" spc="-1" dirty="0">
               <a:solidFill>
                 <a:srgbClr val="000000"/>
               </a:solidFill>
@@ -21131,33 +21092,36 @@
               </a:lnSpc>
             </a:pPr>
             <a:r>
-              <a:rPr lang="en-US" sz="1800" b="1" strike="noStrike" spc="-1">
+              <a:rPr lang="en-US" b="1" spc="-1" dirty="0">
                 <a:solidFill>
                   <a:srgbClr val="000000"/>
                 </a:solidFill>
                 <a:latin typeface="Calibri"/>
               </a:rPr>
-              <a:t>And Monitoring</a:t>
-            </a:r>
-            <a:endParaRPr lang="en-US" sz="1800" b="0" strike="noStrike" spc="-1">
-              <a:solidFill>
-                <a:srgbClr val="000000"/>
-              </a:solidFill>
-              <a:latin typeface="Arial"/>
-            </a:endParaRPr>
-          </a:p>
-        </p:txBody>
-      </p:sp>
-      <p:sp>
-        <p:nvSpPr>
-          <p:cNvPr id="393" name="CustomShape 30"/>
+              <a:t>a</a:t>
+            </a:r>
+            <a:r>
+              <a:rPr lang="en-US" sz="1800" b="1" strike="noStrike" spc="-1" dirty="0">
+                <a:solidFill>
+                  <a:srgbClr val="000000"/>
+                </a:solidFill>
+                <a:latin typeface="Calibri"/>
+              </a:rPr>
+              <a:t>nd Monitoring</a:t>
+            </a:r>
+          </a:p>
+        </p:txBody>
+      </p:sp>
+      <p:sp>
+        <p:nvSpPr>
+          <p:cNvPr id="394" name="CustomShape 31"/>
           <p:cNvSpPr/>
           <p:nvPr/>
         </p:nvSpPr>
         <p:spPr>
           <a:xfrm>
-            <a:off x="629640" y="794160"/>
-            <a:ext cx="907920" cy="639000"/>
+            <a:off x="8728200" y="813930"/>
+            <a:ext cx="3006697" cy="460211"/>
           </a:xfrm>
           <a:prstGeom prst="rect">
             <a:avLst/>
@@ -21191,25 +21155,15 @@
               </a:lnSpc>
             </a:pPr>
             <a:r>
-              <a:rPr lang="en-US" sz="1800" b="1" strike="noStrike" spc="-1">
-                <a:solidFill>
-                  <a:srgbClr val="000000"/>
+              <a:rPr lang="en-US" sz="2400" b="1" strike="noStrike" spc="-1" dirty="0">
+                <a:solidFill>
+                  <a:srgbClr val="2E75B6"/>
                 </a:solidFill>
                 <a:latin typeface="Calibri"/>
               </a:rPr>
-              <a:t>Search </a:t>
-            </a:r>
-            <a:br/>
-            <a:r>
-              <a:rPr lang="en-US" sz="1800" b="1" strike="noStrike" spc="-1">
-                <a:solidFill>
-                  <a:srgbClr val="000000"/>
-                </a:solidFill>
-                <a:latin typeface="Calibri"/>
-              </a:rPr>
-              <a:t>Engines</a:t>
-            </a:r>
-            <a:endParaRPr lang="en-US" sz="1800" b="0" strike="noStrike" spc="-1">
+              <a:t>Web Admin and Users</a:t>
+            </a:r>
+            <a:endParaRPr lang="en-US" sz="2400" b="0" strike="noStrike" spc="-1" dirty="0">
               <a:solidFill>
                 <a:srgbClr val="000000"/>
               </a:solidFill>
@@ -21220,14 +21174,14 @@
       </p:sp>
       <p:sp>
         <p:nvSpPr>
-          <p:cNvPr id="394" name="CustomShape 31"/>
+          <p:cNvPr id="395" name="CustomShape 32"/>
           <p:cNvSpPr/>
           <p:nvPr/>
         </p:nvSpPr>
         <p:spPr>
           <a:xfrm>
-            <a:off x="7617600" y="800280"/>
-            <a:ext cx="3953160" cy="456120"/>
+            <a:off x="7812363" y="5980703"/>
+            <a:ext cx="4806000" cy="460211"/>
           </a:xfrm>
           <a:prstGeom prst="rect">
             <a:avLst/>
@@ -21250,66 +21204,6 @@
           <a:fontRef idx="minor"/>
         </p:style>
         <p:txBody>
-          <a:bodyPr wrap="none" lIns="90000" tIns="45000" rIns="90000" bIns="45000">
-            <a:spAutoFit/>
-          </a:bodyPr>
-          <a:lstStyle/>
-          <a:p>
-            <a:pPr algn="ctr">
-              <a:lnSpc>
-                <a:spcPct val="100000"/>
-              </a:lnSpc>
-            </a:pPr>
-            <a:r>
-              <a:rPr lang="en-US" sz="2400" b="1" strike="noStrike" spc="-1">
-                <a:solidFill>
-                  <a:srgbClr val="2E75B6"/>
-                </a:solidFill>
-                <a:latin typeface="Calibri"/>
-              </a:rPr>
-              <a:t>Omeka Web Admin and Users</a:t>
-            </a:r>
-            <a:endParaRPr lang="en-US" sz="2400" b="0" strike="noStrike" spc="-1">
-              <a:solidFill>
-                <a:srgbClr val="000000"/>
-              </a:solidFill>
-              <a:latin typeface="Arial"/>
-            </a:endParaRPr>
-          </a:p>
-        </p:txBody>
-      </p:sp>
-      <p:sp>
-        <p:nvSpPr>
-          <p:cNvPr id="395" name="CustomShape 32"/>
-          <p:cNvSpPr/>
-          <p:nvPr/>
-        </p:nvSpPr>
-        <p:spPr>
-          <a:xfrm>
-            <a:off x="7076880" y="5521320"/>
-            <a:ext cx="4806000" cy="821880"/>
-          </a:xfrm>
-          <a:prstGeom prst="rect">
-            <a:avLst/>
-          </a:prstGeom>
-          <a:noFill/>
-          <a:ln>
-            <a:noFill/>
-          </a:ln>
-        </p:spPr>
-        <p:style>
-          <a:lnRef idx="0">
-            <a:scrgbClr r="0" g="0" b="0"/>
-          </a:lnRef>
-          <a:fillRef idx="0">
-            <a:scrgbClr r="0" g="0" b="0"/>
-          </a:fillRef>
-          <a:effectRef idx="0">
-            <a:scrgbClr r="0" g="0" b="0"/>
-          </a:effectRef>
-          <a:fontRef idx="minor"/>
-        </p:style>
-        <p:txBody>
           <a:bodyPr lIns="90000" tIns="45000" rIns="90000" bIns="45000">
             <a:spAutoFit/>
           </a:bodyPr>
@@ -21321,15 +21215,15 @@
               </a:lnSpc>
             </a:pPr>
             <a:r>
-              <a:rPr lang="en-US" sz="2400" b="1" strike="noStrike" spc="-1">
+              <a:rPr lang="en-US" sz="2400" b="1" strike="noStrike" spc="-1" dirty="0">
                 <a:solidFill>
                   <a:srgbClr val="2E75B6"/>
                 </a:solidFill>
                 <a:latin typeface="Calibri"/>
               </a:rPr>
-              <a:t>Azure Deployment and Back-End System Administration</a:t>
-            </a:r>
-            <a:endParaRPr lang="en-US" sz="2400" b="0" strike="noStrike" spc="-1">
+              <a:t>Develop, Deploy, Admin</a:t>
+            </a:r>
+            <a:endParaRPr lang="en-US" sz="2400" b="0" strike="noStrike" spc="-1" dirty="0">
               <a:solidFill>
                 <a:srgbClr val="000000"/>
               </a:solidFill>
@@ -21338,54 +21232,45 @@
           </a:p>
         </p:txBody>
       </p:sp>
-      <p:pic>
-        <p:nvPicPr>
-          <p:cNvPr id="396" name="Picture 4" descr="Image result for azure logo"/>
-          <p:cNvPicPr/>
-          <p:nvPr/>
-        </p:nvPicPr>
-        <p:blipFill>
-          <a:blip r:embed="rId5"/>
-          <a:stretch/>
-        </p:blipFill>
-        <p:spPr>
-          <a:xfrm>
-            <a:off x="618120" y="2347560"/>
-            <a:ext cx="974160" cy="366840"/>
-          </a:xfrm>
-          <a:prstGeom prst="rect">
-            <a:avLst/>
-          </a:prstGeom>
-          <a:ln>
-            <a:noFill/>
-          </a:ln>
-        </p:spPr>
-      </p:pic>
-      <p:sp>
-        <p:nvSpPr>
-          <p:cNvPr id="397" name="CustomShape 33"/>
+      <p:sp>
+        <p:nvSpPr>
+          <p:cNvPr id="399" name="CustomShape 35"/>
           <p:cNvSpPr/>
           <p:nvPr/>
         </p:nvSpPr>
         <p:spPr>
-          <a:xfrm>
-            <a:off x="1587960" y="1512720"/>
-            <a:ext cx="695520" cy="860760"/>
+          <a:xfrm flipV="1">
+            <a:off x="1664089" y="3800880"/>
+            <a:ext cx="9624" cy="1456920"/>
           </a:xfrm>
           <a:custGeom>
             <a:avLst/>
-            <a:gdLst/>
+            <a:gdLst>
+              <a:gd name="connsiteX0" fmla="*/ 0 w 4547"/>
+              <a:gd name="connsiteY0" fmla="*/ 0 h 21600"/>
+              <a:gd name="connsiteX1" fmla="*/ 4547 w 4547"/>
+              <a:gd name="connsiteY1" fmla="*/ 21600 h 21600"/>
+            </a:gdLst>
             <a:ahLst/>
-            <a:cxnLst/>
+            <a:cxnLst>
+              <a:cxn ang="0">
+                <a:pos x="connsiteX0" y="connsiteY0"/>
+              </a:cxn>
+              <a:cxn ang="0">
+                <a:pos x="connsiteX1" y="connsiteY1"/>
+              </a:cxn>
+            </a:cxnLst>
             <a:rect l="l" t="t" r="r" b="b"/>
             <a:pathLst>
-              <a:path w="21600" h="21600">
+              <a:path w="4547" h="21600">
                 <a:moveTo>
                   <a:pt x="0" y="0"/>
                 </a:moveTo>
-                <a:lnTo>
-                  <a:pt x="21600" y="21600"/>
-                </a:lnTo>
+                <a:cubicBezTo>
+                  <a:pt x="7200" y="7200"/>
+                  <a:pt x="-2653" y="14400"/>
+                  <a:pt x="4547" y="21600"/>
+                </a:cubicBezTo>
               </a:path>
             </a:pathLst>
           </a:custGeom>
@@ -21416,119 +21301,13 @@
       </p:sp>
       <p:sp>
         <p:nvSpPr>
-          <p:cNvPr id="398" name="CustomShape 34"/>
-          <p:cNvSpPr/>
-          <p:nvPr/>
-        </p:nvSpPr>
-        <p:spPr>
-          <a:xfrm flipH="1">
-            <a:off x="3160440" y="1534320"/>
-            <a:ext cx="830520" cy="849960"/>
-          </a:xfrm>
-          <a:custGeom>
-            <a:avLst/>
-            <a:gdLst/>
-            <a:ahLst/>
-            <a:cxnLst/>
-            <a:rect l="l" t="t" r="r" b="b"/>
-            <a:pathLst>
-              <a:path w="21600" h="21600">
-                <a:moveTo>
-                  <a:pt x="0" y="0"/>
-                </a:moveTo>
-                <a:lnTo>
-                  <a:pt x="21600" y="21600"/>
-                </a:lnTo>
-              </a:path>
-            </a:pathLst>
-          </a:custGeom>
-          <a:noFill/>
-          <a:ln w="82440">
-            <a:tailEnd type="triangle" w="sm" len="med"/>
-          </a:ln>
-        </p:spPr>
-        <p:style>
-          <a:lnRef idx="1">
-            <a:schemeClr val="accent1"/>
-          </a:lnRef>
-          <a:fillRef idx="0">
-            <a:schemeClr val="accent1"/>
-          </a:fillRef>
-          <a:effectRef idx="0">
-            <a:schemeClr val="accent1"/>
-          </a:effectRef>
-          <a:fontRef idx="minor"/>
-        </p:style>
-        <p:txBody>
-          <a:bodyPr/>
-          <a:lstStyle/>
-          <a:p>
-            <a:endParaRPr lang="en-US"/>
-          </a:p>
-        </p:txBody>
-      </p:sp>
-      <p:sp>
-        <p:nvSpPr>
-          <p:cNvPr id="399" name="CustomShape 35"/>
-          <p:cNvSpPr/>
-          <p:nvPr/>
-        </p:nvSpPr>
-        <p:spPr>
-          <a:xfrm flipH="1" flipV="1">
-            <a:off x="1096200" y="3800880"/>
-            <a:ext cx="360" cy="1289520"/>
-          </a:xfrm>
-          <a:custGeom>
-            <a:avLst/>
-            <a:gdLst/>
-            <a:ahLst/>
-            <a:cxnLst/>
-            <a:rect l="l" t="t" r="r" b="b"/>
-            <a:pathLst>
-              <a:path w="21600" h="21600">
-                <a:moveTo>
-                  <a:pt x="0" y="0"/>
-                </a:moveTo>
-                <a:lnTo>
-                  <a:pt x="21600" y="21600"/>
-                </a:lnTo>
-              </a:path>
-            </a:pathLst>
-          </a:custGeom>
-          <a:noFill/>
-          <a:ln w="82440">
-            <a:tailEnd type="triangle" w="sm" len="med"/>
-          </a:ln>
-        </p:spPr>
-        <p:style>
-          <a:lnRef idx="1">
-            <a:schemeClr val="accent1"/>
-          </a:lnRef>
-          <a:fillRef idx="0">
-            <a:schemeClr val="accent1"/>
-          </a:fillRef>
-          <a:effectRef idx="0">
-            <a:schemeClr val="accent1"/>
-          </a:effectRef>
-          <a:fontRef idx="minor"/>
-        </p:style>
-        <p:txBody>
-          <a:bodyPr/>
-          <a:lstStyle/>
-          <a:p>
-            <a:endParaRPr lang="en-US"/>
-          </a:p>
-        </p:txBody>
-      </p:sp>
-      <p:sp>
-        <p:nvSpPr>
           <p:cNvPr id="400" name="CustomShape 36"/>
           <p:cNvSpPr/>
           <p:nvPr/>
         </p:nvSpPr>
         <p:spPr>
           <a:xfrm flipV="1">
-            <a:off x="2725560" y="3978360"/>
+            <a:off x="3832480" y="3978360"/>
             <a:ext cx="10800" cy="1358640"/>
           </a:xfrm>
           <a:custGeom>
@@ -21582,7 +21361,7 @@
         </p:nvSpPr>
         <p:spPr>
           <a:xfrm flipV="1">
-            <a:off x="4254840" y="3978360"/>
+            <a:off x="5409888" y="3978360"/>
             <a:ext cx="360" cy="1419120"/>
           </a:xfrm>
           <a:custGeom>
@@ -21636,7 +21415,7 @@
         </p:nvSpPr>
         <p:spPr>
           <a:xfrm>
-            <a:off x="6562080" y="4915800"/>
+            <a:off x="7167185" y="4765657"/>
             <a:ext cx="360" cy="646920"/>
           </a:xfrm>
           <a:custGeom>
@@ -21689,8 +21468,8 @@
         </p:nvSpPr>
         <p:spPr>
           <a:xfrm>
-            <a:off x="8872560" y="4354560"/>
-            <a:ext cx="1442520" cy="729720"/>
+            <a:off x="9305712" y="4500775"/>
+            <a:ext cx="1646640" cy="1106542"/>
           </a:xfrm>
           <a:prstGeom prst="rect">
             <a:avLst/>
@@ -21713,7 +21492,7 @@
           <a:fontRef idx="minor"/>
         </p:style>
         <p:txBody>
-          <a:bodyPr lIns="90000" tIns="45000" rIns="90000" bIns="45000">
+          <a:bodyPr wrap="square" lIns="90000" tIns="45000" rIns="90000" bIns="45000">
             <a:spAutoFit/>
           </a:bodyPr>
           <a:lstStyle/>
@@ -21724,24 +21503,33 @@
               </a:lnSpc>
             </a:pPr>
             <a:r>
-              <a:rPr lang="en-US" sz="1800" b="1" strike="noStrike" spc="-1">
+              <a:rPr lang="en-US" b="1" spc="-1" dirty="0" err="1">
                 <a:solidFill>
                   <a:srgbClr val="0D0D0D"/>
                 </a:solidFill>
                 <a:latin typeface="Calibri"/>
               </a:rPr>
-              <a:t>chcoffline</a:t>
-            </a:r>
-            <a:r>
-              <a:rPr lang="en-US" sz="1200" b="1" strike="noStrike" spc="-1">
+              <a:t>CHC</a:t>
+            </a:r>
+            <a:r>
+              <a:rPr lang="en-US" sz="1800" b="1" strike="noStrike" spc="-1" dirty="0" err="1">
                 <a:solidFill>
                   <a:srgbClr val="0D0D0D"/>
                 </a:solidFill>
                 <a:latin typeface="Calibri"/>
               </a:rPr>
+              <a:t>Offline</a:t>
+            </a:r>
+            <a:r>
+              <a:rPr lang="en-US" sz="1200" b="1" strike="noStrike" spc="-1" dirty="0">
+                <a:solidFill>
+                  <a:srgbClr val="0D0D0D"/>
+                </a:solidFill>
+                <a:latin typeface="Calibri"/>
+              </a:rPr>
               <a:t> </a:t>
             </a:r>
-            <a:endParaRPr lang="en-US" sz="1200" b="0" strike="noStrike" spc="-1">
+            <a:endParaRPr lang="en-US" sz="1200" b="0" strike="noStrike" spc="-1" dirty="0">
               <a:solidFill>
                 <a:srgbClr val="000000"/>
               </a:solidFill>
@@ -21755,59 +21543,15 @@
               </a:lnSpc>
             </a:pPr>
             <a:r>
-              <a:rPr lang="en-US" sz="1200" b="1" strike="noStrike" spc="-1">
+              <a:rPr lang="en-US" sz="1200" b="1" strike="noStrike" spc="-1" dirty="0">
                 <a:solidFill>
                   <a:srgbClr val="0D0D0D"/>
                 </a:solidFill>
                 <a:latin typeface="Calibri"/>
               </a:rPr>
-              <a:t>Backup Snapshots Docker files</a:t>
-            </a:r>
-            <a:endParaRPr lang="en-US" sz="1200" b="0" strike="noStrike" spc="-1">
-              <a:solidFill>
-                <a:srgbClr val="000000"/>
-              </a:solidFill>
-              <a:latin typeface="Arial"/>
-            </a:endParaRPr>
-          </a:p>
-        </p:txBody>
-      </p:sp>
-      <p:sp>
-        <p:nvSpPr>
-          <p:cNvPr id="404" name="CustomShape 40"/>
-          <p:cNvSpPr/>
-          <p:nvPr/>
-        </p:nvSpPr>
-        <p:spPr>
-          <a:xfrm>
-            <a:off x="1950480" y="2702160"/>
-            <a:ext cx="1572480" cy="363960"/>
-          </a:xfrm>
-          <a:prstGeom prst="rect">
-            <a:avLst/>
-          </a:prstGeom>
-          <a:noFill/>
-          <a:ln>
-            <a:noFill/>
-          </a:ln>
-        </p:spPr>
-        <p:style>
-          <a:lnRef idx="0">
-            <a:scrgbClr r="0" g="0" b="0"/>
-          </a:lnRef>
-          <a:fillRef idx="0">
-            <a:scrgbClr r="0" g="0" b="0"/>
-          </a:fillRef>
-          <a:effectRef idx="0">
-            <a:scrgbClr r="0" g="0" b="0"/>
-          </a:effectRef>
-          <a:fontRef idx="minor"/>
-        </p:style>
-        <p:txBody>
-          <a:bodyPr wrap="none" lIns="90000" tIns="45000" rIns="90000" bIns="45000">
-            <a:spAutoFit/>
-          </a:bodyPr>
-          <a:lstStyle/>
+              <a:t>CDASH Build &amp; Docs</a:t>
+            </a:r>
+          </a:p>
           <a:p>
             <a:pPr algn="ctr">
               <a:lnSpc>
@@ -21815,17 +21559,39 @@
               </a:lnSpc>
             </a:pPr>
             <a:r>
-              <a:rPr lang="en-US" sz="1800" b="1" strike="noStrike" spc="-1">
-                <a:solidFill>
-                  <a:srgbClr val="333333"/>
+              <a:rPr lang="en-US" sz="1200" b="1" spc="-1" dirty="0">
+                <a:solidFill>
+                  <a:srgbClr val="0D0D0D"/>
                 </a:solidFill>
                 <a:latin typeface="Calibri"/>
               </a:rPr>
-              <a:t>chcomeka App</a:t>
-            </a:r>
-            <a:endParaRPr lang="en-US" sz="1800" b="0" strike="noStrike" spc="-1">
-              <a:solidFill>
-                <a:srgbClr val="333333"/>
+              <a:t>Admin Secrets</a:t>
+            </a:r>
+            <a:endParaRPr lang="en-US" sz="1200" b="1" strike="noStrike" spc="-1" dirty="0">
+              <a:solidFill>
+                <a:srgbClr val="0D0D0D"/>
+              </a:solidFill>
+              <a:latin typeface="Calibri"/>
+            </a:endParaRPr>
+          </a:p>
+          <a:p>
+            <a:pPr algn="ctr">
+              <a:lnSpc>
+                <a:spcPct val="100000"/>
+              </a:lnSpc>
+            </a:pPr>
+            <a:r>
+              <a:rPr lang="en-US" sz="1200" b="1" strike="noStrike" spc="-1" dirty="0">
+                <a:solidFill>
+                  <a:srgbClr val="0D0D0D"/>
+                </a:solidFill>
+                <a:latin typeface="Calibri"/>
+              </a:rPr>
+              <a:t>Database Snapshots Docker files</a:t>
+            </a:r>
+            <a:endParaRPr lang="en-US" sz="1200" b="0" strike="noStrike" spc="-1" dirty="0">
+              <a:solidFill>
+                <a:srgbClr val="000000"/>
               </a:solidFill>
               <a:latin typeface="Arial"/>
             </a:endParaRPr>
@@ -21840,7 +21606,7 @@
         </p:nvSpPr>
         <p:spPr>
           <a:xfrm flipV="1">
-            <a:off x="6562080" y="3899880"/>
+            <a:off x="7139592" y="3899880"/>
             <a:ext cx="360" cy="686880"/>
           </a:xfrm>
           <a:custGeom>
@@ -21887,63 +21653,14 @@
       </p:sp>
       <p:sp>
         <p:nvSpPr>
-          <p:cNvPr id="406" name="CustomShape 42"/>
-          <p:cNvSpPr/>
-          <p:nvPr/>
-        </p:nvSpPr>
-        <p:spPr>
-          <a:xfrm>
-            <a:off x="6937920" y="1502640"/>
-            <a:ext cx="1320840" cy="927360"/>
-          </a:xfrm>
-          <a:prstGeom prst="flowChartMagneticDisk">
-            <a:avLst/>
-          </a:prstGeom>
-          <a:solidFill>
-            <a:schemeClr val="bg1">
-              <a:lumMod val="95000"/>
-            </a:schemeClr>
-          </a:solidFill>
-          <a:ln w="44280">
-            <a:solidFill>
-              <a:schemeClr val="bg1">
-                <a:lumMod val="75000"/>
-              </a:schemeClr>
-            </a:solidFill>
-          </a:ln>
-        </p:spPr>
-        <p:style>
-          <a:lnRef idx="2">
-            <a:schemeClr val="accent1">
-              <a:shade val="50000"/>
-            </a:schemeClr>
-          </a:lnRef>
-          <a:fillRef idx="1">
-            <a:schemeClr val="accent1"/>
-          </a:fillRef>
-          <a:effectRef idx="0">
-            <a:schemeClr val="accent1"/>
-          </a:effectRef>
-          <a:fontRef idx="minor"/>
-        </p:style>
-        <p:txBody>
-          <a:bodyPr/>
-          <a:lstStyle/>
-          <a:p>
-            <a:endParaRPr lang="en-US"/>
-          </a:p>
-        </p:txBody>
-      </p:sp>
-      <p:sp>
-        <p:nvSpPr>
           <p:cNvPr id="407" name="CustomShape 43"/>
           <p:cNvSpPr/>
           <p:nvPr/>
         </p:nvSpPr>
         <p:spPr>
           <a:xfrm>
-            <a:off x="5939280" y="5485320"/>
-            <a:ext cx="1311840" cy="364680"/>
+            <a:off x="6729352" y="5327191"/>
+            <a:ext cx="887079" cy="644877"/>
           </a:xfrm>
           <a:prstGeom prst="rect">
             <a:avLst/>
@@ -21977,15 +21694,32 @@
               </a:lnSpc>
             </a:pPr>
             <a:r>
-              <a:rPr lang="en-US" sz="1800" b="1" strike="noStrike" spc="-1">
+              <a:rPr lang="en-US" b="1" spc="-1" dirty="0">
                 <a:solidFill>
                   <a:srgbClr val="000000"/>
                 </a:solidFill>
                 <a:latin typeface="Calibri"/>
               </a:rPr>
-              <a:t>File transfer</a:t>
-            </a:r>
-            <a:endParaRPr lang="en-US" sz="1800" b="0" strike="noStrike" spc="-1">
+              <a:t>Fixes</a:t>
+            </a:r>
+            <a:br>
+              <a:rPr lang="en-US" b="1" spc="-1" dirty="0">
+                <a:solidFill>
+                  <a:srgbClr val="000000"/>
+                </a:solidFill>
+                <a:latin typeface="Calibri"/>
+              </a:rPr>
+            </a:br>
+            <a:r>
+              <a:rPr lang="en-US" b="1" spc="-1" dirty="0">
+                <a:solidFill>
+                  <a:srgbClr val="000000"/>
+                </a:solidFill>
+                <a:latin typeface="Calibri"/>
+              </a:rPr>
+              <a:t>Tweaks</a:t>
+            </a:r>
+            <a:endParaRPr lang="en-US" sz="1800" b="0" strike="noStrike" spc="-1" dirty="0">
               <a:solidFill>
                 <a:srgbClr val="000000"/>
               </a:solidFill>
@@ -21996,65 +21730,14 @@
       </p:sp>
       <p:sp>
         <p:nvSpPr>
-          <p:cNvPr id="408" name="CustomShape 44"/>
+          <p:cNvPr id="411" name="CustomShape 47"/>
           <p:cNvSpPr/>
           <p:nvPr/>
         </p:nvSpPr>
         <p:spPr>
-          <a:xfrm flipH="1" flipV="1">
-            <a:off x="4791960" y="1527120"/>
-            <a:ext cx="437760" cy="573480"/>
-          </a:xfrm>
-          <a:custGeom>
-            <a:avLst/>
-            <a:gdLst/>
-            <a:ahLst/>
-            <a:cxnLst/>
-            <a:rect l="l" t="t" r="r" b="b"/>
-            <a:pathLst>
-              <a:path w="21600" h="21600">
-                <a:moveTo>
-                  <a:pt x="0" y="0"/>
-                </a:moveTo>
-                <a:lnTo>
-                  <a:pt x="21600" y="21600"/>
-                </a:lnTo>
-              </a:path>
-            </a:pathLst>
-          </a:custGeom>
-          <a:noFill/>
-          <a:ln w="82440"/>
-        </p:spPr>
-        <p:style>
-          <a:lnRef idx="1">
-            <a:schemeClr val="accent1"/>
-          </a:lnRef>
-          <a:fillRef idx="0">
-            <a:schemeClr val="accent1"/>
-          </a:fillRef>
-          <a:effectRef idx="0">
-            <a:schemeClr val="accent1"/>
-          </a:effectRef>
-          <a:fontRef idx="minor"/>
-        </p:style>
-        <p:txBody>
-          <a:bodyPr/>
-          <a:lstStyle/>
-          <a:p>
-            <a:endParaRPr lang="en-US"/>
-          </a:p>
-        </p:txBody>
-      </p:sp>
-      <p:sp>
-        <p:nvSpPr>
-          <p:cNvPr id="409" name="CustomShape 45"/>
-          <p:cNvSpPr/>
-          <p:nvPr/>
-        </p:nvSpPr>
-        <p:spPr>
-          <a:xfrm>
-            <a:off x="6886080" y="1673640"/>
-            <a:ext cx="1442520" cy="729720"/>
+          <a:xfrm>
+            <a:off x="4561902" y="5335253"/>
+            <a:ext cx="1765205" cy="644877"/>
           </a:xfrm>
           <a:prstGeom prst="rect">
             <a:avLst/>
@@ -22077,150 +21760,6 @@
           <a:fontRef idx="minor"/>
         </p:style>
         <p:txBody>
-          <a:bodyPr lIns="90000" tIns="45000" rIns="90000" bIns="45000">
-            <a:spAutoFit/>
-          </a:bodyPr>
-          <a:lstStyle/>
-          <a:p>
-            <a:pPr algn="ctr">
-              <a:lnSpc>
-                <a:spcPct val="100000"/>
-              </a:lnSpc>
-            </a:pPr>
-            <a:r>
-              <a:rPr lang="en-US" sz="1800" b="1" strike="noStrike" spc="-1">
-                <a:solidFill>
-                  <a:srgbClr val="0D0D0D"/>
-                </a:solidFill>
-                <a:latin typeface="Calibri"/>
-              </a:rPr>
-              <a:t>chcscans</a:t>
-            </a:r>
-            <a:r>
-              <a:rPr lang="en-US" sz="1200" b="1" strike="noStrike" spc="-1">
-                <a:solidFill>
-                  <a:srgbClr val="0D0D0D"/>
-                </a:solidFill>
-                <a:latin typeface="Calibri"/>
-              </a:rPr>
-              <a:t> </a:t>
-            </a:r>
-            <a:endParaRPr lang="en-US" sz="1200" b="0" strike="noStrike" spc="-1">
-              <a:solidFill>
-                <a:srgbClr val="000000"/>
-              </a:solidFill>
-              <a:latin typeface="Arial"/>
-            </a:endParaRPr>
-          </a:p>
-          <a:p>
-            <a:pPr algn="ctr">
-              <a:lnSpc>
-                <a:spcPct val="100000"/>
-              </a:lnSpc>
-            </a:pPr>
-            <a:r>
-              <a:rPr lang="en-US" sz="1200" b="1" strike="noStrike" spc="-1">
-                <a:solidFill>
-                  <a:srgbClr val="0D0D0D"/>
-                </a:solidFill>
-                <a:latin typeface="Calibri"/>
-              </a:rPr>
-              <a:t>Original scans and csv files for import</a:t>
-            </a:r>
-            <a:endParaRPr lang="en-US" sz="1200" b="0" strike="noStrike" spc="-1">
-              <a:solidFill>
-                <a:srgbClr val="000000"/>
-              </a:solidFill>
-              <a:latin typeface="Arial"/>
-            </a:endParaRPr>
-          </a:p>
-        </p:txBody>
-      </p:sp>
-      <p:sp>
-        <p:nvSpPr>
-          <p:cNvPr id="410" name="CustomShape 46"/>
-          <p:cNvSpPr/>
-          <p:nvPr/>
-        </p:nvSpPr>
-        <p:spPr>
-          <a:xfrm flipH="1">
-            <a:off x="5819040" y="2091600"/>
-            <a:ext cx="1117800" cy="9720"/>
-          </a:xfrm>
-          <a:custGeom>
-            <a:avLst/>
-            <a:gdLst/>
-            <a:ahLst/>
-            <a:cxnLst/>
-            <a:rect l="l" t="t" r="r" b="b"/>
-            <a:pathLst>
-              <a:path w="21600" h="21600">
-                <a:moveTo>
-                  <a:pt x="0" y="0"/>
-                </a:moveTo>
-                <a:lnTo>
-                  <a:pt x="21600" y="21600"/>
-                </a:lnTo>
-              </a:path>
-            </a:pathLst>
-          </a:custGeom>
-          <a:noFill/>
-          <a:ln w="82440">
-            <a:headEnd type="triangle" w="sm" len="med"/>
-          </a:ln>
-        </p:spPr>
-        <p:style>
-          <a:lnRef idx="1">
-            <a:schemeClr val="accent1"/>
-          </a:lnRef>
-          <a:fillRef idx="0">
-            <a:schemeClr val="accent1"/>
-          </a:fillRef>
-          <a:effectRef idx="0">
-            <a:schemeClr val="accent1"/>
-          </a:effectRef>
-          <a:fontRef idx="minor"/>
-        </p:style>
-        <p:txBody>
-          <a:bodyPr/>
-          <a:lstStyle/>
-          <a:p>
-            <a:endParaRPr lang="en-US"/>
-          </a:p>
-        </p:txBody>
-      </p:sp>
-      <p:sp>
-        <p:nvSpPr>
-          <p:cNvPr id="411" name="CustomShape 47"/>
-          <p:cNvSpPr/>
-          <p:nvPr/>
-        </p:nvSpPr>
-        <p:spPr>
-          <a:xfrm>
-            <a:off x="3841560" y="5335200"/>
-            <a:ext cx="1665360" cy="639000"/>
-          </a:xfrm>
-          <a:prstGeom prst="rect">
-            <a:avLst/>
-          </a:prstGeom>
-          <a:noFill/>
-          <a:ln>
-            <a:noFill/>
-          </a:ln>
-        </p:spPr>
-        <p:style>
-          <a:lnRef idx="0">
-            <a:scrgbClr r="0" g="0" b="0"/>
-          </a:lnRef>
-          <a:fillRef idx="0">
-            <a:scrgbClr r="0" g="0" b="0"/>
-          </a:fillRef>
-          <a:effectRef idx="0">
-            <a:scrgbClr r="0" g="0" b="0"/>
-          </a:effectRef>
-          <a:fontRef idx="minor"/>
-        </p:style>
-        <p:txBody>
           <a:bodyPr wrap="none" lIns="90000" tIns="45000" rIns="90000" bIns="45000">
             <a:spAutoFit/>
           </a:bodyPr>
@@ -22232,7 +21771,7 @@
               </a:lnSpc>
             </a:pPr>
             <a:r>
-              <a:rPr lang="en-US" sz="1800" b="1" strike="noStrike" spc="-1">
+              <a:rPr lang="en-US" sz="1800" b="1" strike="noStrike" spc="-1" dirty="0">
                 <a:solidFill>
                   <a:srgbClr val="000000"/>
                 </a:solidFill>
@@ -22240,17 +21779,28 @@
               </a:rPr>
               <a:t>Database Setup</a:t>
             </a:r>
-            <a:br/>
-            <a:r>
-              <a:rPr lang="en-US" sz="1800" b="1" strike="noStrike" spc="-1">
+            <a:br>
+              <a:rPr dirty="0"/>
+            </a:br>
+            <a:r>
+              <a:rPr lang="en-US" b="1" spc="-1" dirty="0">
                 <a:solidFill>
                   <a:srgbClr val="000000"/>
                 </a:solidFill>
                 <a:latin typeface="Calibri"/>
               </a:rPr>
-              <a:t>backups</a:t>
-            </a:r>
-            <a:endParaRPr lang="en-US" sz="1800" b="0" strike="noStrike" spc="-1">
+              <a:t>Routine B</a:t>
+            </a:r>
+            <a:r>
+              <a:rPr lang="en-US" sz="1800" b="1" strike="noStrike" spc="-1" dirty="0">
+                <a:solidFill>
+                  <a:srgbClr val="000000"/>
+                </a:solidFill>
+                <a:latin typeface="Calibri"/>
+              </a:rPr>
+              <a:t>ackups</a:t>
+            </a:r>
+            <a:endParaRPr lang="en-US" sz="1800" b="0" strike="noStrike" spc="-1" dirty="0">
               <a:solidFill>
                 <a:srgbClr val="000000"/>
               </a:solidFill>
@@ -22267,8 +21817,8 @@
         </p:nvSpPr>
         <p:spPr>
           <a:xfrm>
-            <a:off x="1862280" y="4389120"/>
-            <a:ext cx="1683360" cy="646920"/>
+            <a:off x="2656368" y="4389120"/>
+            <a:ext cx="1702050" cy="653601"/>
           </a:xfrm>
           <a:prstGeom prst="rect">
             <a:avLst/>
@@ -22302,7 +21852,7 @@
           <a:lstStyle/>
           <a:p>
             <a:r>
-              <a:rPr lang="en-US" sz="1800" b="0" strike="noStrike" spc="-1">
+              <a:rPr lang="en-US" sz="1800" b="0" strike="noStrike" spc="-1" dirty="0">
                 <a:solidFill>
                   <a:srgbClr val="000000"/>
                 </a:solidFill>
@@ -22314,15 +21864,16 @@
           <a:p>
             <a:pPr algn="ctr"/>
             <a:r>
-              <a:rPr lang="en-US" sz="1800" b="0" strike="noStrike" spc="-1">
+              <a:rPr lang="en-US" spc="-1" dirty="0">
                 <a:solidFill>
                   <a:srgbClr val="000000"/>
                 </a:solidFill>
                 <a:latin typeface="Arial"/>
-              </a:rPr>
-              <a:t>Azure SSH</a:t>
-            </a:r>
-            <a:endParaRPr lang="en-US" sz="1800" b="0" strike="noStrike" spc="-1">
+                <a:ea typeface="Microsoft YaHei"/>
+              </a:rPr>
+              <a:t>Secure Shell</a:t>
+            </a:r>
+            <a:endParaRPr lang="en-US" sz="1800" b="0" strike="noStrike" spc="-1" dirty="0">
               <a:solidFill>
                 <a:srgbClr val="000000"/>
               </a:solidFill>
@@ -22334,13 +21885,103 @@
       </p:sp>
       <p:sp>
         <p:nvSpPr>
-          <p:cNvPr id="413" name="CustomShape 49"/>
+          <p:cNvPr id="415" name="TextShape 51"/>
+          <p:cNvSpPr txBox="1"/>
+          <p:nvPr/>
+        </p:nvSpPr>
+        <p:spPr>
+          <a:xfrm>
+            <a:off x="6019272" y="6390360"/>
+            <a:ext cx="1247040" cy="364680"/>
+          </a:xfrm>
+          <a:prstGeom prst="rect">
+            <a:avLst/>
+          </a:prstGeom>
+          <a:noFill/>
+          <a:ln>
+            <a:noFill/>
+          </a:ln>
+        </p:spPr>
+        <p:txBody>
+          <a:bodyPr anchor="ctr">
+            <a:noAutofit/>
+          </a:bodyPr>
+          <a:lstStyle/>
+          <a:p>
+            <a:pPr>
+              <a:lnSpc>
+                <a:spcPct val="100000"/>
+              </a:lnSpc>
+            </a:pPr>
+            <a:fld id="{03AD6084-321B-4C1B-8ED5-E26BE9B8EDC4}" type="datetime1">
+              <a:rPr lang="en-US" sz="1200" b="0" strike="noStrike" spc="-1">
+                <a:solidFill>
+                  <a:srgbClr val="8B8B8B"/>
+                </a:solidFill>
+                <a:latin typeface="Calibri"/>
+              </a:rPr>
+              <a:t>1/3/2024</a:t>
+            </a:fld>
+            <a:endParaRPr lang="en-US" sz="1200" b="0" strike="noStrike" spc="-1">
+              <a:latin typeface="Times New Roman"/>
+            </a:endParaRPr>
+          </a:p>
+        </p:txBody>
+      </p:sp>
+      <p:sp>
+        <p:nvSpPr>
+          <p:cNvPr id="416" name="TextShape 52"/>
+          <p:cNvSpPr txBox="1"/>
+          <p:nvPr/>
+        </p:nvSpPr>
+        <p:spPr>
+          <a:xfrm>
+            <a:off x="833112" y="6390360"/>
+            <a:ext cx="2742840" cy="364680"/>
+          </a:xfrm>
+          <a:prstGeom prst="rect">
+            <a:avLst/>
+          </a:prstGeom>
+          <a:noFill/>
+          <a:ln>
+            <a:noFill/>
+          </a:ln>
+        </p:spPr>
+        <p:txBody>
+          <a:bodyPr anchor="ctr">
+            <a:noAutofit/>
+          </a:bodyPr>
+          <a:lstStyle/>
+          <a:p>
+            <a:pPr>
+              <a:lnSpc>
+                <a:spcPct val="100000"/>
+              </a:lnSpc>
+            </a:pPr>
+            <a:fld id="{D00192D6-550B-4022-A116-B4A4ACEE4BDA}" type="slidenum">
+              <a:rPr lang="en-US" sz="1200" b="0" strike="noStrike" spc="-1">
+                <a:solidFill>
+                  <a:srgbClr val="8B8B8B"/>
+                </a:solidFill>
+                <a:latin typeface="Calibri"/>
+              </a:rPr>
+              <a:t>25</a:t>
+            </a:fld>
+            <a:endParaRPr lang="en-US" sz="1200" b="0" strike="noStrike" spc="-1">
+              <a:latin typeface="Times New Roman"/>
+            </a:endParaRPr>
+          </a:p>
+        </p:txBody>
+      </p:sp>
+      <p:sp>
+        <p:nvSpPr>
+          <p:cNvPr id="417" name="CustomShape 53"/>
           <p:cNvSpPr/>
           <p:nvPr/>
         </p:nvSpPr>
         <p:spPr>
           <a:xfrm>
-            <a:off x="4864320" y="1737360"/>
+            <a:off x="6316272" y="4389120"/>
             <a:ext cx="1646640" cy="646920"/>
           </a:xfrm>
           <a:prstGeom prst="rect">
@@ -22406,246 +22047,13 @@
       </p:sp>
       <p:sp>
         <p:nvSpPr>
-          <p:cNvPr id="414" name="CustomShape 50"/>
-          <p:cNvSpPr/>
-          <p:nvPr/>
-        </p:nvSpPr>
-        <p:spPr>
-          <a:xfrm>
-            <a:off x="3759840" y="3200400"/>
-            <a:ext cx="793440" cy="459720"/>
-          </a:xfrm>
-          <a:prstGeom prst="rect">
-            <a:avLst/>
-          </a:prstGeom>
-          <a:noFill/>
-          <a:ln>
-            <a:noFill/>
-          </a:ln>
-        </p:spPr>
-        <p:style>
-          <a:lnRef idx="0">
-            <a:scrgbClr r="0" g="0" b="0"/>
-          </a:lnRef>
-          <a:fillRef idx="0">
-            <a:scrgbClr r="0" g="0" b="0"/>
-          </a:fillRef>
-          <a:effectRef idx="0">
-            <a:scrgbClr r="0" g="0" b="0"/>
-          </a:effectRef>
-          <a:fontRef idx="minor"/>
-        </p:style>
-        <p:txBody>
-          <a:bodyPr wrap="none" lIns="0" tIns="0" rIns="0" bIns="0">
-            <a:spAutoFit/>
-          </a:bodyPr>
-          <a:lstStyle/>
-          <a:p>
-            <a:pPr algn="ctr">
-              <a:lnSpc>
-                <a:spcPct val="100000"/>
-              </a:lnSpc>
-            </a:pPr>
-            <a:r>
-              <a:rPr lang="en-US" sz="1800" b="1" strike="noStrike" spc="-1">
-                <a:solidFill>
-                  <a:srgbClr val="333333"/>
-                </a:solidFill>
-                <a:latin typeface="Calibri"/>
-              </a:rPr>
-              <a:t>Azure</a:t>
-            </a:r>
-            <a:br/>
-            <a:r>
-              <a:rPr lang="en-US" sz="1800" b="1" strike="noStrike" spc="-1">
-                <a:solidFill>
-                  <a:srgbClr val="333333"/>
-                </a:solidFill>
-                <a:latin typeface="Calibri"/>
-              </a:rPr>
-              <a:t>mariadb</a:t>
-            </a:r>
-            <a:endParaRPr lang="en-US" sz="1800" b="1" strike="noStrike" spc="-1">
-              <a:solidFill>
-                <a:srgbClr val="333333"/>
-              </a:solidFill>
-              <a:latin typeface="Calibri"/>
-              <a:ea typeface="Microsoft YaHei"/>
-            </a:endParaRPr>
-          </a:p>
-        </p:txBody>
-      </p:sp>
-      <p:sp>
-        <p:nvSpPr>
-          <p:cNvPr id="415" name="TextShape 51"/>
-          <p:cNvSpPr txBox="1"/>
-          <p:nvPr/>
-        </p:nvSpPr>
-        <p:spPr>
-          <a:xfrm>
-            <a:off x="5441760" y="6390360"/>
-            <a:ext cx="1247040" cy="364680"/>
-          </a:xfrm>
-          <a:prstGeom prst="rect">
-            <a:avLst/>
-          </a:prstGeom>
-          <a:noFill/>
-          <a:ln>
-            <a:noFill/>
-          </a:ln>
-        </p:spPr>
-        <p:txBody>
-          <a:bodyPr anchor="ctr">
-            <a:noAutofit/>
-          </a:bodyPr>
-          <a:lstStyle/>
-          <a:p>
-            <a:pPr>
-              <a:lnSpc>
-                <a:spcPct val="100000"/>
-              </a:lnSpc>
-            </a:pPr>
-            <a:fld id="{03AD6084-321B-4C1B-8ED5-E26BE9B8EDC4}" type="datetime1">
-              <a:rPr lang="en-US" sz="1200" b="0" strike="noStrike" spc="-1">
-                <a:solidFill>
-                  <a:srgbClr val="8B8B8B"/>
-                </a:solidFill>
-                <a:latin typeface="Calibri"/>
-              </a:rPr>
-              <a:t>9/1/2023</a:t>
-            </a:fld>
-            <a:endParaRPr lang="en-US" sz="1200" b="0" strike="noStrike" spc="-1">
-              <a:latin typeface="Times New Roman"/>
-            </a:endParaRPr>
-          </a:p>
-        </p:txBody>
-      </p:sp>
-      <p:sp>
-        <p:nvSpPr>
-          <p:cNvPr id="416" name="TextShape 52"/>
-          <p:cNvSpPr txBox="1"/>
-          <p:nvPr/>
-        </p:nvSpPr>
-        <p:spPr>
-          <a:xfrm>
-            <a:off x="255600" y="6390360"/>
-            <a:ext cx="2742840" cy="364680"/>
-          </a:xfrm>
-          <a:prstGeom prst="rect">
-            <a:avLst/>
-          </a:prstGeom>
-          <a:noFill/>
-          <a:ln>
-            <a:noFill/>
-          </a:ln>
-        </p:spPr>
-        <p:txBody>
-          <a:bodyPr anchor="ctr">
-            <a:noAutofit/>
-          </a:bodyPr>
-          <a:lstStyle/>
-          <a:p>
-            <a:pPr>
-              <a:lnSpc>
-                <a:spcPct val="100000"/>
-              </a:lnSpc>
-            </a:pPr>
-            <a:fld id="{D00192D6-550B-4022-A116-B4A4ACEE4BDA}" type="slidenum">
-              <a:rPr lang="en-US" sz="1200" b="0" strike="noStrike" spc="-1">
-                <a:solidFill>
-                  <a:srgbClr val="8B8B8B"/>
-                </a:solidFill>
-                <a:latin typeface="Calibri"/>
-              </a:rPr>
-              <a:t>25</a:t>
-            </a:fld>
-            <a:endParaRPr lang="en-US" sz="1200" b="0" strike="noStrike" spc="-1">
-              <a:latin typeface="Times New Roman"/>
-            </a:endParaRPr>
-          </a:p>
-        </p:txBody>
-      </p:sp>
-      <p:sp>
-        <p:nvSpPr>
-          <p:cNvPr id="417" name="CustomShape 53"/>
-          <p:cNvSpPr/>
-          <p:nvPr/>
-        </p:nvSpPr>
-        <p:spPr>
-          <a:xfrm>
-            <a:off x="5738760" y="4389120"/>
-            <a:ext cx="1646640" cy="646920"/>
-          </a:xfrm>
-          <a:prstGeom prst="rect">
-            <a:avLst/>
-          </a:prstGeom>
-          <a:solidFill>
-            <a:srgbClr val="DEDCE6"/>
-          </a:solidFill>
-          <a:ln w="9000">
-            <a:solidFill>
-              <a:srgbClr val="FFD74C"/>
-            </a:solidFill>
-            <a:round/>
-          </a:ln>
-        </p:spPr>
-        <p:style>
-          <a:lnRef idx="0">
-            <a:scrgbClr r="0" g="0" b="0"/>
-          </a:lnRef>
-          <a:fillRef idx="0">
-            <a:scrgbClr r="0" g="0" b="0"/>
-          </a:fillRef>
-          <a:effectRef idx="0">
-            <a:scrgbClr r="0" g="0" b="0"/>
-          </a:effectRef>
-          <a:fontRef idx="minor"/>
-        </p:style>
-        <p:txBody>
-          <a:bodyPr wrap="none" lIns="94320" tIns="49320" rIns="94320" bIns="49320">
-            <a:spAutoFit/>
-          </a:bodyPr>
-          <a:lstStyle/>
-          <a:p>
-            <a:pPr algn="ctr"/>
-            <a:r>
-              <a:rPr lang="en-US" sz="1800" b="0" strike="noStrike" spc="-1">
-                <a:solidFill>
-                  <a:srgbClr val="000000"/>
-                </a:solidFill>
-                <a:latin typeface="Arial"/>
-              </a:rPr>
-              <a:t>Azure Storage</a:t>
-            </a:r>
-            <a:br/>
-            <a:r>
-              <a:rPr lang="en-US" sz="1800" b="0" strike="noStrike" spc="-1">
-                <a:solidFill>
-                  <a:srgbClr val="000000"/>
-                </a:solidFill>
-                <a:latin typeface="Arial"/>
-              </a:rPr>
-              <a:t>Explorer</a:t>
-            </a:r>
-            <a:endParaRPr lang="en-US" sz="1800" b="0" strike="noStrike" spc="-1">
-              <a:solidFill>
-                <a:srgbClr val="000000"/>
-              </a:solidFill>
-              <a:latin typeface="Arial"/>
-              <a:ea typeface="Microsoft YaHei"/>
-            </a:endParaRPr>
-          </a:p>
-        </p:txBody>
-      </p:sp>
-      <p:sp>
-        <p:nvSpPr>
           <p:cNvPr id="418" name="CustomShape 54"/>
           <p:cNvSpPr/>
           <p:nvPr/>
         </p:nvSpPr>
         <p:spPr>
           <a:xfrm flipV="1">
-            <a:off x="7226280" y="4708080"/>
+            <a:off x="7803792" y="4708080"/>
             <a:ext cx="1645920" cy="15120"/>
           </a:xfrm>
           <a:custGeom>
@@ -22699,7 +22107,7 @@
         </p:nvSpPr>
         <p:spPr>
           <a:xfrm>
-            <a:off x="3657600" y="4382280"/>
+            <a:off x="4752488" y="4382280"/>
             <a:ext cx="1337400" cy="646920"/>
           </a:xfrm>
           <a:prstGeom prst="rect">
@@ -22776,8 +22184,8 @@
         </p:nvSpPr>
         <p:spPr>
           <a:xfrm>
-            <a:off x="274320" y="4382280"/>
-            <a:ext cx="1494360" cy="646200"/>
+            <a:off x="943223" y="4383624"/>
+            <a:ext cx="1399271" cy="653601"/>
           </a:xfrm>
           <a:prstGeom prst="rect">
             <a:avLst/>
@@ -22805,6 +22213,438 @@
           <a:fontRef idx="minor"/>
         </p:style>
         <p:txBody>
+          <a:bodyPr wrap="square" lIns="94320" tIns="49320" rIns="94320" bIns="49320">
+            <a:spAutoFit/>
+          </a:bodyPr>
+          <a:lstStyle/>
+          <a:p>
+            <a:pPr algn="ctr"/>
+            <a:r>
+              <a:rPr lang="en-US" spc="-1" dirty="0">
+                <a:solidFill>
+                  <a:srgbClr val="000000"/>
+                </a:solidFill>
+                <a:latin typeface="Arial"/>
+                <a:ea typeface="Microsoft YaHei"/>
+              </a:rPr>
+              <a:t>Docker</a:t>
+            </a:r>
+          </a:p>
+          <a:p>
+            <a:pPr algn="ctr"/>
+            <a:r>
+              <a:rPr lang="en-US" spc="-1" dirty="0">
+                <a:solidFill>
+                  <a:srgbClr val="000000"/>
+                </a:solidFill>
+                <a:latin typeface="Arial"/>
+                <a:ea typeface="Microsoft YaHei"/>
+              </a:rPr>
+              <a:t>Desktop</a:t>
+            </a:r>
+          </a:p>
+        </p:txBody>
+      </p:sp>
+      <p:sp>
+        <p:nvSpPr>
+          <p:cNvPr id="6" name="CustomShape 35">
+            <a:extLst>
+              <a:ext uri="{FF2B5EF4-FFF2-40B4-BE49-F238E27FC236}">
+                <a16:creationId xmlns:a16="http://schemas.microsoft.com/office/drawing/2014/main" id="{FB3C1A40-C0BC-F048-80C7-79398DB74865}"/>
+              </a:ext>
+            </a:extLst>
+          </p:cNvPr>
+          <p:cNvSpPr/>
+          <p:nvPr/>
+        </p:nvSpPr>
+        <p:spPr>
+          <a:xfrm flipV="1">
+            <a:off x="2393631" y="3300191"/>
+            <a:ext cx="752906" cy="17229"/>
+          </a:xfrm>
+          <a:custGeom>
+            <a:avLst/>
+            <a:gdLst>
+              <a:gd name="connsiteX0" fmla="*/ 0 w 4547"/>
+              <a:gd name="connsiteY0" fmla="*/ 0 h 21600"/>
+              <a:gd name="connsiteX1" fmla="*/ 4547 w 4547"/>
+              <a:gd name="connsiteY1" fmla="*/ 21600 h 21600"/>
+              <a:gd name="connsiteX0" fmla="*/ 0 w 10000"/>
+              <a:gd name="connsiteY0" fmla="*/ 0 h 10000"/>
+              <a:gd name="connsiteX1" fmla="*/ 10000 w 10000"/>
+              <a:gd name="connsiteY1" fmla="*/ 10000 h 10000"/>
+              <a:gd name="connsiteX0" fmla="*/ 0 w 10000"/>
+              <a:gd name="connsiteY0" fmla="*/ 0 h 10000"/>
+              <a:gd name="connsiteX1" fmla="*/ 10000 w 10000"/>
+              <a:gd name="connsiteY1" fmla="*/ 10000 h 10000"/>
+              <a:gd name="connsiteX0" fmla="*/ 0 w 10000"/>
+              <a:gd name="connsiteY0" fmla="*/ 0 h 10000"/>
+              <a:gd name="connsiteX1" fmla="*/ 10000 w 10000"/>
+              <a:gd name="connsiteY1" fmla="*/ 10000 h 10000"/>
+              <a:gd name="connsiteX0" fmla="*/ 0 w 7639"/>
+              <a:gd name="connsiteY0" fmla="*/ 0 h 1499"/>
+              <a:gd name="connsiteX1" fmla="*/ 5547 w 7639"/>
+              <a:gd name="connsiteY1" fmla="*/ 489 h 1499"/>
+              <a:gd name="connsiteX0" fmla="*/ 0 w 7261"/>
+              <a:gd name="connsiteY0" fmla="*/ 0 h 3262"/>
+              <a:gd name="connsiteX1" fmla="*/ 7261 w 7261"/>
+              <a:gd name="connsiteY1" fmla="*/ 3262 h 3262"/>
+              <a:gd name="connsiteX0" fmla="*/ 0 w 10000"/>
+              <a:gd name="connsiteY0" fmla="*/ 0 h 10000"/>
+              <a:gd name="connsiteX1" fmla="*/ 10000 w 10000"/>
+              <a:gd name="connsiteY1" fmla="*/ 10000 h 10000"/>
+              <a:gd name="connsiteX0" fmla="*/ 0 w 13294"/>
+              <a:gd name="connsiteY0" fmla="*/ 0 h 13558"/>
+              <a:gd name="connsiteX1" fmla="*/ 13294 w 13294"/>
+              <a:gd name="connsiteY1" fmla="*/ 13558 h 13558"/>
+              <a:gd name="connsiteX0" fmla="*/ 0 w 12882"/>
+              <a:gd name="connsiteY0" fmla="*/ 3106 h 4804"/>
+              <a:gd name="connsiteX1" fmla="*/ 12882 w 12882"/>
+              <a:gd name="connsiteY1" fmla="*/ 4804 h 4804"/>
+              <a:gd name="connsiteX0" fmla="*/ 0 w 10000"/>
+              <a:gd name="connsiteY0" fmla="*/ 76 h 3611"/>
+              <a:gd name="connsiteX1" fmla="*/ 10000 w 10000"/>
+              <a:gd name="connsiteY1" fmla="*/ 3611 h 3611"/>
+              <a:gd name="connsiteX0" fmla="*/ 0 w 10000"/>
+              <a:gd name="connsiteY0" fmla="*/ 0 h 9790"/>
+              <a:gd name="connsiteX1" fmla="*/ 10000 w 10000"/>
+              <a:gd name="connsiteY1" fmla="*/ 9790 h 9790"/>
+            </a:gdLst>
+            <a:ahLst/>
+            <a:cxnLst>
+              <a:cxn ang="0">
+                <a:pos x="connsiteX0" y="connsiteY0"/>
+              </a:cxn>
+              <a:cxn ang="0">
+                <a:pos x="connsiteX1" y="connsiteY1"/>
+              </a:cxn>
+            </a:cxnLst>
+            <a:rect l="l" t="t" r="r" b="b"/>
+            <a:pathLst>
+              <a:path w="10000" h="9790">
+                <a:moveTo>
+                  <a:pt x="0" y="0"/>
+                </a:moveTo>
+                <a:cubicBezTo>
+                  <a:pt x="2666" y="10089"/>
+                  <a:pt x="4298" y="-7064"/>
+                  <a:pt x="10000" y="9790"/>
+                </a:cubicBezTo>
+              </a:path>
+            </a:pathLst>
+          </a:custGeom>
+          <a:noFill/>
+          <a:ln w="82440">
+            <a:tailEnd type="triangle" w="sm" len="med"/>
+          </a:ln>
+        </p:spPr>
+        <p:style>
+          <a:lnRef idx="1">
+            <a:schemeClr val="accent1"/>
+          </a:lnRef>
+          <a:fillRef idx="0">
+            <a:schemeClr val="accent1"/>
+          </a:fillRef>
+          <a:effectRef idx="0">
+            <a:schemeClr val="accent1"/>
+          </a:effectRef>
+          <a:fontRef idx="minor"/>
+        </p:style>
+        <p:txBody>
+          <a:bodyPr/>
+          <a:lstStyle/>
+          <a:p>
+            <a:endParaRPr lang="en-US"/>
+          </a:p>
+        </p:txBody>
+      </p:sp>
+      <p:cxnSp>
+        <p:nvCxnSpPr>
+          <p:cNvPr id="9" name="Straight Connector 8">
+            <a:extLst>
+              <a:ext uri="{FF2B5EF4-FFF2-40B4-BE49-F238E27FC236}">
+                <a16:creationId xmlns:a16="http://schemas.microsoft.com/office/drawing/2014/main" id="{74E7D553-5273-CD7A-B508-6EBE6F71EFE8}"/>
+              </a:ext>
+            </a:extLst>
+          </p:cNvPr>
+          <p:cNvCxnSpPr>
+            <a:cxnSpLocks/>
+          </p:cNvCxnSpPr>
+          <p:nvPr/>
+        </p:nvCxnSpPr>
+        <p:spPr>
+          <a:xfrm flipV="1">
+            <a:off x="4537866" y="2022679"/>
+            <a:ext cx="1162864" cy="703754"/>
+          </a:xfrm>
+          <a:prstGeom prst="line">
+            <a:avLst/>
+          </a:prstGeom>
+          <a:noFill/>
+          <a:ln w="82440">
+            <a:headEnd type="triangle" w="sm" len="med"/>
+          </a:ln>
+        </p:spPr>
+        <p:style>
+          <a:lnRef idx="1">
+            <a:schemeClr val="accent1"/>
+          </a:lnRef>
+          <a:fillRef idx="0">
+            <a:schemeClr val="accent1"/>
+          </a:fillRef>
+          <a:effectRef idx="0">
+            <a:schemeClr val="accent1"/>
+          </a:effectRef>
+          <a:fontRef idx="minor"/>
+        </p:style>
+      </p:cxnSp>
+      <p:cxnSp>
+        <p:nvCxnSpPr>
+          <p:cNvPr id="12" name="Straight Connector 11">
+            <a:extLst>
+              <a:ext uri="{FF2B5EF4-FFF2-40B4-BE49-F238E27FC236}">
+                <a16:creationId xmlns:a16="http://schemas.microsoft.com/office/drawing/2014/main" id="{C9CDEDE0-091C-86A0-4EC2-B52EA8615870}"/>
+              </a:ext>
+            </a:extLst>
+          </p:cNvPr>
+          <p:cNvCxnSpPr>
+            <a:cxnSpLocks/>
+          </p:cNvCxnSpPr>
+          <p:nvPr/>
+        </p:nvCxnSpPr>
+        <p:spPr>
+          <a:xfrm flipV="1">
+            <a:off x="6755928" y="1816814"/>
+            <a:ext cx="2815401" cy="14990"/>
+          </a:xfrm>
+          <a:prstGeom prst="line">
+            <a:avLst/>
+          </a:prstGeom>
+          <a:noFill/>
+          <a:ln w="82440">
+            <a:headEnd type="triangle" w="sm" len="med"/>
+          </a:ln>
+        </p:spPr>
+        <p:style>
+          <a:lnRef idx="1">
+            <a:schemeClr val="accent1"/>
+          </a:lnRef>
+          <a:fillRef idx="0">
+            <a:schemeClr val="accent1"/>
+          </a:fillRef>
+          <a:effectRef idx="0">
+            <a:schemeClr val="accent1"/>
+          </a:effectRef>
+          <a:fontRef idx="minor"/>
+        </p:style>
+      </p:cxnSp>
+      <p:grpSp>
+        <p:nvGrpSpPr>
+          <p:cNvPr id="5" name="Group 4">
+            <a:extLst>
+              <a:ext uri="{FF2B5EF4-FFF2-40B4-BE49-F238E27FC236}">
+                <a16:creationId xmlns:a16="http://schemas.microsoft.com/office/drawing/2014/main" id="{02A332C6-1C7E-64A7-F11C-EF38980E5EEE}"/>
+              </a:ext>
+            </a:extLst>
+          </p:cNvPr>
+          <p:cNvGrpSpPr/>
+          <p:nvPr/>
+        </p:nvGrpSpPr>
+        <p:grpSpPr>
+          <a:xfrm>
+            <a:off x="5435254" y="1413791"/>
+            <a:ext cx="1442520" cy="1197731"/>
+            <a:chOff x="6886060" y="1502640"/>
+            <a:chExt cx="1442520" cy="987573"/>
+          </a:xfrm>
+        </p:grpSpPr>
+        <p:sp>
+          <p:nvSpPr>
+            <p:cNvPr id="406" name="CustomShape 42"/>
+            <p:cNvSpPr/>
+            <p:nvPr/>
+          </p:nvSpPr>
+          <p:spPr>
+            <a:xfrm>
+              <a:off x="6937920" y="1502640"/>
+              <a:ext cx="1320840" cy="927360"/>
+            </a:xfrm>
+            <a:prstGeom prst="flowChartMagneticDisk">
+              <a:avLst/>
+            </a:prstGeom>
+            <a:solidFill>
+              <a:schemeClr val="bg1">
+                <a:lumMod val="95000"/>
+              </a:schemeClr>
+            </a:solidFill>
+            <a:ln w="44280">
+              <a:solidFill>
+                <a:schemeClr val="bg1">
+                  <a:lumMod val="75000"/>
+                </a:schemeClr>
+              </a:solidFill>
+            </a:ln>
+          </p:spPr>
+          <p:style>
+            <a:lnRef idx="2">
+              <a:schemeClr val="accent1">
+                <a:shade val="50000"/>
+              </a:schemeClr>
+            </a:lnRef>
+            <a:fillRef idx="1">
+              <a:schemeClr val="accent1"/>
+            </a:fillRef>
+            <a:effectRef idx="0">
+              <a:schemeClr val="accent1"/>
+            </a:effectRef>
+            <a:fontRef idx="minor"/>
+          </p:style>
+          <p:txBody>
+            <a:bodyPr/>
+            <a:lstStyle/>
+            <a:p>
+              <a:endParaRPr lang="en-US"/>
+            </a:p>
+          </p:txBody>
+        </p:sp>
+        <p:sp>
+          <p:nvSpPr>
+            <p:cNvPr id="409" name="CustomShape 45"/>
+            <p:cNvSpPr/>
+            <p:nvPr/>
+          </p:nvSpPr>
+          <p:spPr>
+            <a:xfrm>
+              <a:off x="6886060" y="1753003"/>
+              <a:ext cx="1442520" cy="737210"/>
+            </a:xfrm>
+            <a:prstGeom prst="rect">
+              <a:avLst/>
+            </a:prstGeom>
+            <a:noFill/>
+            <a:ln>
+              <a:noFill/>
+            </a:ln>
+          </p:spPr>
+          <p:style>
+            <a:lnRef idx="0">
+              <a:scrgbClr r="0" g="0" b="0"/>
+            </a:lnRef>
+            <a:fillRef idx="0">
+              <a:scrgbClr r="0" g="0" b="0"/>
+            </a:fillRef>
+            <a:effectRef idx="0">
+              <a:scrgbClr r="0" g="0" b="0"/>
+            </a:effectRef>
+            <a:fontRef idx="minor"/>
+          </p:style>
+          <p:txBody>
+            <a:bodyPr lIns="90000" tIns="45000" rIns="90000" bIns="45000">
+              <a:spAutoFit/>
+            </a:bodyPr>
+            <a:lstStyle/>
+            <a:p>
+              <a:pPr algn="ctr">
+                <a:lnSpc>
+                  <a:spcPct val="100000"/>
+                </a:lnSpc>
+              </a:pPr>
+              <a:r>
+                <a:rPr lang="en-US" b="1" spc="-1" dirty="0" err="1">
+                  <a:solidFill>
+                    <a:srgbClr val="0D0D0D"/>
+                  </a:solidFill>
+                  <a:latin typeface="Calibri"/>
+                </a:rPr>
+                <a:t>CHC</a:t>
+              </a:r>
+              <a:r>
+                <a:rPr lang="en-US" sz="1800" b="1" strike="noStrike" spc="-1" dirty="0" err="1">
+                  <a:solidFill>
+                    <a:srgbClr val="0D0D0D"/>
+                  </a:solidFill>
+                  <a:latin typeface="Calibri"/>
+                </a:rPr>
+                <a:t>Scans</a:t>
+              </a:r>
+              <a:r>
+                <a:rPr lang="en-US" sz="1200" b="1" strike="noStrike" spc="-1" dirty="0">
+                  <a:solidFill>
+                    <a:srgbClr val="0D0D0D"/>
+                  </a:solidFill>
+                  <a:latin typeface="Calibri"/>
+                </a:rPr>
+                <a:t> </a:t>
+              </a:r>
+              <a:endParaRPr lang="en-US" sz="1200" b="0" strike="noStrike" spc="-1" dirty="0">
+                <a:solidFill>
+                  <a:srgbClr val="000000"/>
+                </a:solidFill>
+                <a:latin typeface="Arial"/>
+              </a:endParaRPr>
+            </a:p>
+            <a:p>
+              <a:pPr algn="ctr">
+                <a:lnSpc>
+                  <a:spcPct val="100000"/>
+                </a:lnSpc>
+              </a:pPr>
+              <a:r>
+                <a:rPr lang="en-US" sz="1200" b="1" strike="noStrike" spc="-1" dirty="0">
+                  <a:solidFill>
+                    <a:srgbClr val="0D0D0D"/>
+                  </a:solidFill>
+                  <a:latin typeface="Calibri"/>
+                </a:rPr>
+                <a:t>Original scans and csv files for import</a:t>
+              </a:r>
+              <a:endParaRPr lang="en-US" sz="1200" b="0" strike="noStrike" spc="-1" dirty="0">
+                <a:solidFill>
+                  <a:srgbClr val="000000"/>
+                </a:solidFill>
+                <a:latin typeface="Arial"/>
+              </a:endParaRPr>
+            </a:p>
+          </p:txBody>
+        </p:sp>
+      </p:grpSp>
+      <p:sp>
+        <p:nvSpPr>
+          <p:cNvPr id="413" name="CustomShape 49"/>
+          <p:cNvSpPr/>
+          <p:nvPr/>
+        </p:nvSpPr>
+        <p:spPr>
+          <a:xfrm>
+            <a:off x="7288933" y="1703613"/>
+            <a:ext cx="1646640" cy="646920"/>
+          </a:xfrm>
+          <a:prstGeom prst="rect">
+            <a:avLst/>
+          </a:prstGeom>
+          <a:solidFill>
+            <a:srgbClr val="DEDCE6"/>
+          </a:solidFill>
+          <a:ln w="9000">
+            <a:solidFill>
+              <a:srgbClr val="FFD74C"/>
+            </a:solidFill>
+            <a:round/>
+          </a:ln>
+        </p:spPr>
+        <p:style>
+          <a:lnRef idx="0">
+            <a:scrgbClr r="0" g="0" b="0"/>
+          </a:lnRef>
+          <a:fillRef idx="0">
+            <a:scrgbClr r="0" g="0" b="0"/>
+          </a:fillRef>
+          <a:effectRef idx="0">
+            <a:scrgbClr r="0" g="0" b="0"/>
+          </a:effectRef>
+          <a:fontRef idx="minor"/>
+        </p:style>
+        <p:txBody>
           <a:bodyPr wrap="none" lIns="94320" tIns="49320" rIns="94320" bIns="49320">
             <a:spAutoFit/>
           </a:bodyPr>
@@ -22812,22 +22652,620 @@
           <a:p>
             <a:pPr algn="ctr"/>
             <a:r>
-              <a:rPr lang="en-US" sz="1800" b="0" strike="noStrike" spc="-1">
+              <a:rPr lang="en-US" sz="1800" b="0" strike="noStrike" spc="-1" dirty="0">
                 <a:solidFill>
                   <a:srgbClr val="000000"/>
                 </a:solidFill>
                 <a:latin typeface="Arial"/>
               </a:rPr>
-              <a:t>Docker Push</a:t>
-            </a:r>
-          </a:p>
+              <a:t>Azure Storage</a:t>
+            </a:r>
+            <a:br>
+              <a:rPr dirty="0"/>
+            </a:br>
+            <a:r>
+              <a:rPr lang="en-US" sz="1800" b="0" strike="noStrike" spc="-1" dirty="0">
+                <a:solidFill>
+                  <a:srgbClr val="000000"/>
+                </a:solidFill>
+                <a:latin typeface="Arial"/>
+              </a:rPr>
+              <a:t>Explorer</a:t>
+            </a:r>
+            <a:endParaRPr lang="en-US" sz="1800" b="0" strike="noStrike" spc="-1" dirty="0">
+              <a:solidFill>
+                <a:srgbClr val="000000"/>
+              </a:solidFill>
+              <a:latin typeface="Arial"/>
+              <a:ea typeface="Microsoft YaHei"/>
+            </a:endParaRPr>
+          </a:p>
+        </p:txBody>
+      </p:sp>
+      <p:cxnSp>
+        <p:nvCxnSpPr>
+          <p:cNvPr id="17" name="Straight Connector 16">
+            <a:extLst>
+              <a:ext uri="{FF2B5EF4-FFF2-40B4-BE49-F238E27FC236}">
+                <a16:creationId xmlns:a16="http://schemas.microsoft.com/office/drawing/2014/main" id="{0467CD5A-F21E-F490-7CD9-0C9BB72DA0F3}"/>
+              </a:ext>
+            </a:extLst>
+          </p:cNvPr>
+          <p:cNvCxnSpPr>
+            <a:cxnSpLocks/>
+          </p:cNvCxnSpPr>
+          <p:nvPr/>
+        </p:nvCxnSpPr>
+        <p:spPr>
+          <a:xfrm>
+            <a:off x="4564198" y="3392053"/>
+            <a:ext cx="563345" cy="10398"/>
+          </a:xfrm>
+          <a:prstGeom prst="line">
+            <a:avLst/>
+          </a:prstGeom>
+          <a:noFill/>
+          <a:ln w="82440">
+            <a:headEnd type="triangle" w="sm" len="med"/>
+            <a:tailEnd type="none" w="sm" len="med"/>
+          </a:ln>
+        </p:spPr>
+        <p:style>
+          <a:lnRef idx="1">
+            <a:schemeClr val="accent1"/>
+          </a:lnRef>
+          <a:fillRef idx="0">
+            <a:schemeClr val="accent1"/>
+          </a:fillRef>
+          <a:effectRef idx="0">
+            <a:schemeClr val="accent1"/>
+          </a:effectRef>
+          <a:fontRef idx="minor"/>
+        </p:style>
+      </p:cxnSp>
+      <p:grpSp>
+        <p:nvGrpSpPr>
+          <p:cNvPr id="42" name="Group 41">
+            <a:extLst>
+              <a:ext uri="{FF2B5EF4-FFF2-40B4-BE49-F238E27FC236}">
+                <a16:creationId xmlns:a16="http://schemas.microsoft.com/office/drawing/2014/main" id="{2EA8433D-36CE-86A6-01B3-95CECCEDEED9}"/>
+              </a:ext>
+            </a:extLst>
+          </p:cNvPr>
+          <p:cNvGrpSpPr/>
+          <p:nvPr/>
+        </p:nvGrpSpPr>
+        <p:grpSpPr>
+          <a:xfrm>
+            <a:off x="4952095" y="2857061"/>
+            <a:ext cx="1257451" cy="1091633"/>
+            <a:chOff x="3651835" y="-1439753"/>
+            <a:chExt cx="1257451" cy="1091633"/>
+          </a:xfrm>
+        </p:grpSpPr>
+        <p:pic>
+          <p:nvPicPr>
+            <p:cNvPr id="41" name="Picture 40">
+              <a:extLst>
+                <a:ext uri="{FF2B5EF4-FFF2-40B4-BE49-F238E27FC236}">
+                  <a16:creationId xmlns:a16="http://schemas.microsoft.com/office/drawing/2014/main" id="{BF462C7B-14A4-BB9E-36CD-6801BC0F4D6C}"/>
+                </a:ext>
+              </a:extLst>
+            </p:cNvPr>
+            <p:cNvPicPr>
+              <a:picLocks noChangeAspect="1"/>
+            </p:cNvPicPr>
+            <p:nvPr/>
+          </p:nvPicPr>
+          <p:blipFill>
+            <a:blip r:embed="rId5">
+              <a:extLst>
+                <a:ext uri="{BEBA8EAE-BF5A-486C-A8C5-ECC9F3942E4B}">
+                  <a14:imgProps xmlns:a14="http://schemas.microsoft.com/office/drawing/2010/main">
+                    <a14:imgLayer r:embed="rId6">
+                      <a14:imgEffect>
+                        <a14:colorTemperature colorTemp="4700"/>
+                      </a14:imgEffect>
+                    </a14:imgLayer>
+                  </a14:imgProps>
+                </a:ext>
+              </a:extLst>
+            </a:blip>
+            <a:stretch>
+              <a:fillRect/>
+            </a:stretch>
+          </p:blipFill>
+          <p:spPr>
+            <a:xfrm>
+              <a:off x="3651835" y="-1439753"/>
+              <a:ext cx="1257451" cy="1091633"/>
+            </a:xfrm>
+            <a:prstGeom prst="rect">
+              <a:avLst/>
+            </a:prstGeom>
+            <a:effectLst>
+              <a:softEdge rad="114300"/>
+            </a:effectLst>
+          </p:spPr>
+        </p:pic>
+        <p:sp>
+          <p:nvSpPr>
+            <p:cNvPr id="414" name="CustomShape 50"/>
+            <p:cNvSpPr/>
+            <p:nvPr/>
+          </p:nvSpPr>
+          <p:spPr>
+            <a:xfrm>
+              <a:off x="3894228" y="-1089159"/>
+              <a:ext cx="842282" cy="276999"/>
+            </a:xfrm>
+            <a:prstGeom prst="rect">
+              <a:avLst/>
+            </a:prstGeom>
+            <a:noFill/>
+            <a:ln>
+              <a:noFill/>
+            </a:ln>
+            <a:effectLst>
+              <a:glow rad="228600">
+                <a:schemeClr val="accent1">
+                  <a:satMod val="175000"/>
+                  <a:alpha val="80000"/>
+                </a:schemeClr>
+              </a:glow>
+            </a:effectLst>
+          </p:spPr>
+          <p:style>
+            <a:lnRef idx="0">
+              <a:scrgbClr r="0" g="0" b="0"/>
+            </a:lnRef>
+            <a:fillRef idx="0">
+              <a:scrgbClr r="0" g="0" b="0"/>
+            </a:fillRef>
+            <a:effectRef idx="0">
+              <a:scrgbClr r="0" g="0" b="0"/>
+            </a:effectRef>
+            <a:fontRef idx="minor"/>
+          </p:style>
+          <p:txBody>
+            <a:bodyPr wrap="none" lIns="0" tIns="0" rIns="0" bIns="0">
+              <a:spAutoFit/>
+            </a:bodyPr>
+            <a:lstStyle/>
+            <a:p>
+              <a:pPr algn="ctr">
+                <a:lnSpc>
+                  <a:spcPct val="100000"/>
+                </a:lnSpc>
+              </a:pPr>
+              <a:r>
+                <a:rPr lang="en-US" b="1" spc="-1" dirty="0">
+                  <a:solidFill>
+                    <a:srgbClr val="333333"/>
+                  </a:solidFill>
+                  <a:effectLst>
+                    <a:glow rad="152400">
+                      <a:schemeClr val="bg1"/>
+                    </a:glow>
+                  </a:effectLst>
+                  <a:latin typeface="Calibri"/>
+                </a:rPr>
+                <a:t>M</a:t>
+              </a:r>
+              <a:r>
+                <a:rPr lang="en-US" sz="1800" b="1" strike="noStrike" spc="-1" dirty="0">
+                  <a:solidFill>
+                    <a:srgbClr val="333333"/>
+                  </a:solidFill>
+                  <a:effectLst>
+                    <a:glow rad="152400">
+                      <a:schemeClr val="bg1"/>
+                    </a:glow>
+                  </a:effectLst>
+                  <a:latin typeface="Calibri"/>
+                </a:rPr>
+                <a:t>ariaDB</a:t>
+              </a:r>
+              <a:endParaRPr lang="en-US" sz="1800" b="1" strike="noStrike" spc="-1" dirty="0">
+                <a:solidFill>
+                  <a:srgbClr val="333333"/>
+                </a:solidFill>
+                <a:effectLst>
+                  <a:glow rad="152400">
+                    <a:schemeClr val="bg1"/>
+                  </a:glow>
+                </a:effectLst>
+                <a:latin typeface="Calibri"/>
+                <a:ea typeface="Microsoft YaHei"/>
+              </a:endParaRPr>
+            </a:p>
+          </p:txBody>
+        </p:sp>
+      </p:grpSp>
+      <p:cxnSp>
+        <p:nvCxnSpPr>
+          <p:cNvPr id="24" name="Straight Connector 23">
+            <a:extLst>
+              <a:ext uri="{FF2B5EF4-FFF2-40B4-BE49-F238E27FC236}">
+                <a16:creationId xmlns:a16="http://schemas.microsoft.com/office/drawing/2014/main" id="{A22FA172-EF4C-636F-B2E1-DE5420406648}"/>
+              </a:ext>
+            </a:extLst>
+          </p:cNvPr>
+          <p:cNvCxnSpPr>
+            <a:cxnSpLocks/>
+          </p:cNvCxnSpPr>
+          <p:nvPr/>
+        </p:nvCxnSpPr>
+        <p:spPr>
+          <a:xfrm flipH="1" flipV="1">
+            <a:off x="6120841" y="3368529"/>
+            <a:ext cx="616839" cy="313"/>
+          </a:xfrm>
+          <a:prstGeom prst="line">
+            <a:avLst/>
+          </a:prstGeom>
+          <a:noFill/>
+          <a:ln w="82440">
+            <a:headEnd type="triangle" w="sm" len="med"/>
+            <a:tailEnd type="none" w="sm" len="med"/>
+          </a:ln>
+        </p:spPr>
+        <p:style>
+          <a:lnRef idx="1">
+            <a:schemeClr val="accent1"/>
+          </a:lnRef>
+          <a:fillRef idx="0">
+            <a:schemeClr val="accent1"/>
+          </a:fillRef>
+          <a:effectRef idx="0">
+            <a:schemeClr val="accent1"/>
+          </a:effectRef>
+          <a:fontRef idx="minor"/>
+        </p:style>
+      </p:cxnSp>
+      <p:pic>
+        <p:nvPicPr>
+          <p:cNvPr id="1028" name="Picture 4" descr="InterSystems and Azure | InterSystems">
+            <a:extLst>
+              <a:ext uri="{FF2B5EF4-FFF2-40B4-BE49-F238E27FC236}">
+                <a16:creationId xmlns:a16="http://schemas.microsoft.com/office/drawing/2014/main" id="{63B184DA-BCED-308C-C633-055539CD60D1}"/>
+              </a:ext>
+            </a:extLst>
+          </p:cNvPr>
+          <p:cNvPicPr>
+            <a:picLocks noChangeAspect="1" noChangeArrowheads="1"/>
+          </p:cNvPicPr>
+          <p:nvPr/>
+        </p:nvPicPr>
+        <p:blipFill>
+          <a:blip r:embed="rId7">
+            <a:clrChange>
+              <a:clrFrom>
+                <a:srgbClr val="FEFEFE"/>
+              </a:clrFrom>
+              <a:clrTo>
+                <a:srgbClr val="FEFEFE">
+                  <a:alpha val="0"/>
+                </a:srgbClr>
+              </a:clrTo>
+            </a:clrChange>
+            <a:extLst>
+              <a:ext uri="{28A0092B-C50C-407E-A947-70E740481C1C}">
+                <a14:useLocalDpi xmlns:a14="http://schemas.microsoft.com/office/drawing/2010/main" val="0"/>
+              </a:ext>
+            </a:extLst>
+          </a:blip>
+          <a:srcRect/>
+          <a:stretch>
+            <a:fillRect/>
+          </a:stretch>
+        </p:blipFill>
+        <p:spPr bwMode="auto">
+          <a:xfrm>
+            <a:off x="361465" y="1734059"/>
+            <a:ext cx="1712341" cy="963192"/>
+          </a:xfrm>
+          <a:prstGeom prst="rect">
+            <a:avLst/>
+          </a:prstGeom>
+          <a:noFill/>
+          <a:extLst>
+            <a:ext uri="{909E8E84-426E-40DD-AFC4-6F175D3DCCD1}">
+              <a14:hiddenFill xmlns:a14="http://schemas.microsoft.com/office/drawing/2010/main">
+                <a:solidFill>
+                  <a:srgbClr val="FFFFFF"/>
+                </a:solidFill>
+              </a14:hiddenFill>
+            </a:ext>
+          </a:extLst>
+        </p:spPr>
+      </p:pic>
+      <p:cxnSp>
+        <p:nvCxnSpPr>
+          <p:cNvPr id="27" name="Straight Connector 26">
+            <a:extLst>
+              <a:ext uri="{FF2B5EF4-FFF2-40B4-BE49-F238E27FC236}">
+                <a16:creationId xmlns:a16="http://schemas.microsoft.com/office/drawing/2014/main" id="{DCBFB765-981D-6D58-2AEF-1282AC50F377}"/>
+              </a:ext>
+            </a:extLst>
+          </p:cNvPr>
+          <p:cNvCxnSpPr>
+            <a:cxnSpLocks/>
+          </p:cNvCxnSpPr>
+          <p:nvPr/>
+        </p:nvCxnSpPr>
+        <p:spPr>
+          <a:xfrm>
+            <a:off x="1897259" y="1429938"/>
+            <a:ext cx="1468595" cy="1202664"/>
+          </a:xfrm>
+          <a:prstGeom prst="line">
+            <a:avLst/>
+          </a:prstGeom>
+          <a:noFill/>
+          <a:ln w="82440">
+            <a:headEnd type="triangle" w="sm" len="med"/>
+          </a:ln>
+        </p:spPr>
+        <p:style>
+          <a:lnRef idx="1">
+            <a:schemeClr val="accent1"/>
+          </a:lnRef>
+          <a:fillRef idx="0">
+            <a:schemeClr val="accent1"/>
+          </a:fillRef>
+          <a:effectRef idx="0">
+            <a:schemeClr val="accent1"/>
+          </a:effectRef>
+          <a:fontRef idx="minor"/>
+        </p:style>
+      </p:cxnSp>
+      <p:cxnSp>
+        <p:nvCxnSpPr>
+          <p:cNvPr id="30" name="Straight Connector 29">
+            <a:extLst>
+              <a:ext uri="{FF2B5EF4-FFF2-40B4-BE49-F238E27FC236}">
+                <a16:creationId xmlns:a16="http://schemas.microsoft.com/office/drawing/2014/main" id="{451AC444-D267-5AED-DAD7-3FF303758245}"/>
+              </a:ext>
+            </a:extLst>
+          </p:cNvPr>
+          <p:cNvCxnSpPr>
+            <a:cxnSpLocks/>
+          </p:cNvCxnSpPr>
+          <p:nvPr/>
+        </p:nvCxnSpPr>
+        <p:spPr>
+          <a:xfrm flipH="1" flipV="1">
+            <a:off x="3307643" y="1475710"/>
+            <a:ext cx="366201" cy="1250723"/>
+          </a:xfrm>
+          <a:prstGeom prst="line">
+            <a:avLst/>
+          </a:prstGeom>
+          <a:noFill/>
+          <a:ln w="82440">
+            <a:headEnd type="triangle" w="sm" len="med"/>
+            <a:tailEnd type="triangle" w="sm" len="med"/>
+          </a:ln>
+        </p:spPr>
+        <p:style>
+          <a:lnRef idx="1">
+            <a:schemeClr val="accent1"/>
+          </a:lnRef>
+          <a:fillRef idx="0">
+            <a:schemeClr val="accent1"/>
+          </a:fillRef>
+          <a:effectRef idx="0">
+            <a:schemeClr val="accent1"/>
+          </a:effectRef>
+          <a:fontRef idx="minor"/>
+        </p:style>
+      </p:cxnSp>
+      <p:cxnSp>
+        <p:nvCxnSpPr>
+          <p:cNvPr id="35" name="Straight Connector 34">
+            <a:extLst>
+              <a:ext uri="{FF2B5EF4-FFF2-40B4-BE49-F238E27FC236}">
+                <a16:creationId xmlns:a16="http://schemas.microsoft.com/office/drawing/2014/main" id="{343952A7-396C-28C7-F6BA-02F16C2D389D}"/>
+              </a:ext>
+            </a:extLst>
+          </p:cNvPr>
+          <p:cNvCxnSpPr>
+            <a:cxnSpLocks/>
+          </p:cNvCxnSpPr>
+          <p:nvPr/>
+        </p:nvCxnSpPr>
+        <p:spPr>
+          <a:xfrm flipV="1">
+            <a:off x="4105520" y="1492200"/>
+            <a:ext cx="432346" cy="1248120"/>
+          </a:xfrm>
+          <a:prstGeom prst="line">
+            <a:avLst/>
+          </a:prstGeom>
+          <a:noFill/>
+          <a:ln w="82440">
+            <a:headEnd type="triangle" w="sm" len="med"/>
+            <a:tailEnd type="triangle" w="sm" len="med"/>
+          </a:ln>
+        </p:spPr>
+        <p:style>
+          <a:lnRef idx="1">
+            <a:schemeClr val="accent1"/>
+          </a:lnRef>
+          <a:fillRef idx="0">
+            <a:schemeClr val="accent1"/>
+          </a:fillRef>
+          <a:effectRef idx="0">
+            <a:schemeClr val="accent1"/>
+          </a:effectRef>
+          <a:fontRef idx="minor"/>
+        </p:style>
+      </p:cxnSp>
+      <p:sp>
+        <p:nvSpPr>
+          <p:cNvPr id="39" name="CustomShape 23">
+            <a:extLst>
+              <a:ext uri="{FF2B5EF4-FFF2-40B4-BE49-F238E27FC236}">
+                <a16:creationId xmlns:a16="http://schemas.microsoft.com/office/drawing/2014/main" id="{2C46DAE3-6082-DFC9-A47F-39729241AFF5}"/>
+              </a:ext>
+            </a:extLst>
+          </p:cNvPr>
+          <p:cNvSpPr/>
+          <p:nvPr/>
+        </p:nvSpPr>
+        <p:spPr>
+          <a:xfrm>
+            <a:off x="4081451" y="854105"/>
+            <a:ext cx="861175" cy="644877"/>
+          </a:xfrm>
+          <a:prstGeom prst="rect">
+            <a:avLst/>
+          </a:prstGeom>
+          <a:noFill/>
+          <a:ln>
+            <a:noFill/>
+          </a:ln>
+        </p:spPr>
+        <p:style>
+          <a:lnRef idx="0">
+            <a:scrgbClr r="0" g="0" b="0"/>
+          </a:lnRef>
+          <a:fillRef idx="0">
+            <a:scrgbClr r="0" g="0" b="0"/>
+          </a:fillRef>
+          <a:effectRef idx="0">
+            <a:scrgbClr r="0" g="0" b="0"/>
+          </a:effectRef>
+          <a:fontRef idx="minor"/>
+        </p:style>
+        <p:txBody>
+          <a:bodyPr wrap="none" lIns="90000" tIns="45000" rIns="90000" bIns="45000">
+            <a:spAutoFit/>
+          </a:bodyPr>
+          <a:lstStyle/>
+          <a:p>
+            <a:pPr algn="ctr">
+              <a:lnSpc>
+                <a:spcPct val="100000"/>
+              </a:lnSpc>
+            </a:pPr>
+            <a:r>
+              <a:rPr lang="en-US" b="1" spc="-1" dirty="0">
+                <a:solidFill>
+                  <a:srgbClr val="000000"/>
+                </a:solidFill>
+                <a:latin typeface="Calibri"/>
+              </a:rPr>
+              <a:t>Omeka</a:t>
+            </a:r>
+            <a:br>
+              <a:rPr lang="en-US" b="1" spc="-1" dirty="0">
+                <a:solidFill>
+                  <a:srgbClr val="000000"/>
+                </a:solidFill>
+                <a:latin typeface="Calibri"/>
+              </a:rPr>
+            </a:br>
+            <a:r>
+              <a:rPr lang="en-US" b="1" spc="-1" dirty="0">
+                <a:solidFill>
+                  <a:srgbClr val="000000"/>
+                </a:solidFill>
+                <a:latin typeface="Calibri"/>
+              </a:rPr>
+              <a:t>Admin</a:t>
+            </a:r>
+            <a:endParaRPr lang="en-US" sz="1800" b="1" strike="noStrike" spc="-1" dirty="0">
+              <a:solidFill>
+                <a:srgbClr val="000000"/>
+              </a:solidFill>
+              <a:latin typeface="Calibri"/>
+            </a:endParaRPr>
+          </a:p>
+        </p:txBody>
+      </p:sp>
+      <p:sp>
+        <p:nvSpPr>
+          <p:cNvPr id="360" name="CustomShape 4"/>
+          <p:cNvSpPr/>
+          <p:nvPr/>
+        </p:nvSpPr>
+        <p:spPr>
+          <a:xfrm>
+            <a:off x="2830955" y="1782000"/>
+            <a:ext cx="1569899" cy="653601"/>
+          </a:xfrm>
+          <a:prstGeom prst="rect">
+            <a:avLst/>
+          </a:prstGeom>
+          <a:solidFill>
+            <a:srgbClr val="DEDCE6"/>
+          </a:solidFill>
+          <a:ln w="9000">
+            <a:solidFill>
+              <a:srgbClr val="FFD74C"/>
+            </a:solidFill>
+            <a:round/>
+          </a:ln>
+        </p:spPr>
+        <p:style>
+          <a:lnRef idx="0">
+            <a:scrgbClr r="0" g="0" b="0"/>
+          </a:lnRef>
+          <a:fillRef idx="0">
+            <a:scrgbClr r="0" g="0" b="0"/>
+          </a:fillRef>
+          <a:effectRef idx="0">
+            <a:scrgbClr r="0" g="0" b="0"/>
+          </a:effectRef>
+          <a:fontRef idx="minor"/>
+        </p:style>
+        <p:txBody>
+          <a:bodyPr wrap="none" lIns="94320" tIns="49320" rIns="94320" bIns="49320">
+            <a:spAutoFit/>
+          </a:bodyPr>
+          <a:lstStyle/>
           <a:p>
             <a:pPr algn="ctr"/>
-            <a:endParaRPr lang="en-US" sz="1800" b="0" strike="noStrike" spc="-1">
+            <a:r>
+              <a:rPr lang="en-US" sz="1800" b="0" strike="noStrike" spc="-1" dirty="0">
+                <a:solidFill>
+                  <a:srgbClr val="000000"/>
+                </a:solidFill>
+                <a:latin typeface="Arial"/>
+              </a:rPr>
+              <a:t>Web Browser</a:t>
+            </a:r>
+            <a:endParaRPr lang="en-US" sz="1800" b="0" strike="noStrike" spc="-1" dirty="0">
               <a:solidFill>
                 <a:srgbClr val="000000"/>
               </a:solidFill>
               <a:latin typeface="Arial"/>
+              <a:ea typeface="Microsoft YaHei"/>
+            </a:endParaRPr>
+          </a:p>
+          <a:p>
+            <a:pPr algn="ctr">
+              <a:lnSpc>
+                <a:spcPct val="100000"/>
+              </a:lnSpc>
+            </a:pPr>
+            <a:r>
+              <a:rPr lang="en-US" sz="1800" b="0" strike="noStrike" spc="-1" dirty="0">
+                <a:solidFill>
+                  <a:srgbClr val="000000"/>
+                </a:solidFill>
+                <a:latin typeface="Arial"/>
+              </a:rPr>
+              <a:t>Web Server</a:t>
+            </a:r>
+            <a:endParaRPr lang="en-US" sz="1800" b="0" strike="noStrike" spc="-1" dirty="0">
+              <a:solidFill>
+                <a:srgbClr val="000000"/>
+              </a:solidFill>
+              <a:latin typeface="Arial"/>
+              <a:ea typeface="Microsoft YaHei"/>
             </a:endParaRPr>
           </a:p>
         </p:txBody>
@@ -24013,7 +24451,7 @@
                 </a:solidFill>
                 <a:latin typeface="Calibri"/>
               </a:rPr>
-              <a:t>9/1/2023</a:t>
+              <a:t>1/3/2024</a:t>
             </a:fld>
             <a:endParaRPr lang="en-US" sz="1200" b="0" strike="noStrike" spc="-1">
               <a:latin typeface="Times New Roman"/>
@@ -24573,7 +25011,7 @@
                 </a:solidFill>
                 <a:latin typeface="Calibri"/>
               </a:rPr>
-              <a:t>9/1/2023</a:t>
+              <a:t>1/3/2024</a:t>
             </a:fld>
             <a:endParaRPr lang="en-US" sz="1200" b="0" strike="noStrike" spc="-1">
               <a:latin typeface="Times New Roman"/>
@@ -25360,7 +25798,7 @@
                 </a:solidFill>
                 <a:latin typeface="Calibri"/>
               </a:rPr>
-              <a:t>9/1/2023</a:t>
+              <a:t>1/3/2024</a:t>
             </a:fld>
             <a:endParaRPr lang="en-US" sz="1200" b="0" strike="noStrike" spc="-1">
               <a:latin typeface="Times New Roman"/>
@@ -25792,7 +26230,7 @@
                 </a:solidFill>
                 <a:latin typeface="Calibri"/>
               </a:rPr>
-              <a:t>9/1/2023</a:t>
+              <a:t>1/3/2024</a:t>
             </a:fld>
             <a:endParaRPr lang="en-US" sz="1200" b="0" strike="noStrike" spc="-1">
               <a:latin typeface="Times New Roman"/>
@@ -26150,7 +26588,7 @@
                 </a:solidFill>
                 <a:latin typeface="Calibri"/>
               </a:rPr>
-              <a:t>9/1/2023</a:t>
+              <a:t>1/3/2024</a:t>
             </a:fld>
             <a:endParaRPr lang="en-US" sz="1200" b="0" strike="noStrike" spc="-1">
               <a:latin typeface="Times New Roman"/>
@@ -28011,7 +28449,7 @@
                 </a:solidFill>
                 <a:latin typeface="Calibri"/>
               </a:rPr>
-              <a:t>9/1/2023</a:t>
+              <a:t>1/3/2024</a:t>
             </a:fld>
             <a:endParaRPr lang="en-US" sz="1200" b="0" strike="noStrike" spc="-1">
               <a:latin typeface="Times New Roman"/>
@@ -28487,7 +28925,7 @@
                 </a:solidFill>
                 <a:latin typeface="Calibri"/>
               </a:rPr>
-              <a:t>9/1/2023</a:t>
+              <a:t>1/3/2024</a:t>
             </a:fld>
             <a:endParaRPr lang="en-US" sz="1200" b="0" strike="noStrike" spc="-1">
               <a:latin typeface="Times New Roman"/>
@@ -31951,7 +32389,7 @@
                 </a:solidFill>
                 <a:latin typeface="Calibri"/>
               </a:rPr>
-              <a:t>9/1/2023</a:t>
+              <a:t>1/3/2024</a:t>
             </a:fld>
             <a:endParaRPr lang="en-US" sz="1200" b="0" strike="noStrike" spc="-1">
               <a:latin typeface="Times New Roman"/>
@@ -32425,7 +32863,7 @@
                 </a:solidFill>
                 <a:latin typeface="Calibri"/>
               </a:rPr>
-              <a:t>9/1/2023</a:t>
+              <a:t>1/3/2024</a:t>
             </a:fld>
             <a:endParaRPr lang="en-US" sz="1200" b="0" strike="noStrike" spc="-1">
               <a:latin typeface="Times New Roman"/>

</xml_diff>

<commit_message>
new file:   docker/images/omeka_in_azure.jpg 	modified:   docker/index.htm 	modified:   slideshow/CDashSlideshow_20230109.pptx 	new file:   stewardship/index.htm
</commit_message>
<xml_diff>
--- a/slideshow/CDashSlideshow_20230109.pptx
+++ b/slideshow/CDashSlideshow_20230109.pptx
@@ -19383,7 +19383,9 @@
               </a:schemeClr>
             </a:solidFill>
             <a:ln>
-              <a:noFill/>
+              <a:solidFill>
+                <a:srgbClr val="FFD74C"/>
+              </a:solidFill>
             </a:ln>
           </p:spPr>
           <p:style>
@@ -19431,7 +19433,9 @@
               </a:schemeClr>
             </a:solidFill>
             <a:ln>
-              <a:noFill/>
+              <a:solidFill>
+                <a:srgbClr val="FFD74C"/>
+              </a:solidFill>
             </a:ln>
           </p:spPr>
           <p:style>
@@ -19474,6 +19478,7 @@
               <a:schemeClr val="accent1">
                 <a:lumMod val="20000"/>
                 <a:lumOff val="80000"/>
+                <a:alpha val="78000"/>
               </a:schemeClr>
             </a:solidFill>
             <a:ln w="69840">
@@ -19835,39 +19840,23 @@
                   <a:effectLst>
                     <a:glow rad="228600">
                       <a:schemeClr val="bg1">
-                        <a:alpha val="79000"/>
+                        <a:alpha val="91000"/>
                       </a:schemeClr>
                     </a:glow>
                   </a:effectLst>
                   <a:latin typeface="Calibri"/>
                 </a:rPr>
-                <a:t>CHCO</a:t>
+                <a:t>CHCOmeka</a:t>
               </a:r>
               <a:r>
-                <a:rPr lang="en-US" sz="1800" b="1" strike="noStrike" spc="-1" dirty="0" err="1">
+                <a:rPr lang="en-US" b="1" spc="-1" dirty="0">
                   <a:solidFill>
                     <a:srgbClr val="333333"/>
                   </a:solidFill>
                   <a:effectLst>
                     <a:glow rad="228600">
                       <a:schemeClr val="bg1">
-                        <a:alpha val="79000"/>
-                      </a:schemeClr>
-                    </a:glow>
-                  </a:effectLst>
-                  <a:latin typeface="Calibri"/>
-                </a:rPr>
-                <a:t>meka</a:t>
-              </a:r>
-              <a:r>
-                <a:rPr lang="en-US" sz="1800" b="1" strike="noStrike" spc="-1" dirty="0">
-                  <a:solidFill>
-                    <a:srgbClr val="333333"/>
-                  </a:solidFill>
-                  <a:effectLst>
-                    <a:glow rad="228600">
-                      <a:schemeClr val="bg1">
-                        <a:alpha val="79000"/>
+                        <a:alpha val="91000"/>
                       </a:schemeClr>
                     </a:glow>
                   </a:effectLst>
@@ -19875,19 +19864,6 @@
                 </a:rPr>
                 <a:t> App</a:t>
               </a:r>
-              <a:endParaRPr lang="en-US" sz="1800" b="0" strike="noStrike" spc="-1" dirty="0">
-                <a:solidFill>
-                  <a:srgbClr val="333333"/>
-                </a:solidFill>
-                <a:effectLst>
-                  <a:glow rad="228600">
-                    <a:schemeClr val="bg1">
-                      <a:alpha val="79000"/>
-                    </a:schemeClr>
-                  </a:glow>
-                </a:effectLst>
-                <a:latin typeface="Arial"/>
-              </a:endParaRPr>
             </a:p>
           </p:txBody>
         </p:sp>
@@ -21409,59 +21385,6 @@
       </p:sp>
       <p:sp>
         <p:nvSpPr>
-          <p:cNvPr id="402" name="CustomShape 38"/>
-          <p:cNvSpPr/>
-          <p:nvPr/>
-        </p:nvSpPr>
-        <p:spPr>
-          <a:xfrm>
-            <a:off x="7167185" y="4765657"/>
-            <a:ext cx="360" cy="646920"/>
-          </a:xfrm>
-          <a:custGeom>
-            <a:avLst/>
-            <a:gdLst/>
-            <a:ahLst/>
-            <a:cxnLst/>
-            <a:rect l="l" t="t" r="r" b="b"/>
-            <a:pathLst>
-              <a:path w="21600" h="21600">
-                <a:moveTo>
-                  <a:pt x="0" y="0"/>
-                </a:moveTo>
-                <a:lnTo>
-                  <a:pt x="21600" y="21600"/>
-                </a:lnTo>
-              </a:path>
-            </a:pathLst>
-          </a:custGeom>
-          <a:noFill/>
-          <a:ln w="82440">
-            <a:tailEnd type="triangle" w="sm" len="med"/>
-          </a:ln>
-        </p:spPr>
-        <p:style>
-          <a:lnRef idx="1">
-            <a:schemeClr val="accent1"/>
-          </a:lnRef>
-          <a:fillRef idx="0">
-            <a:schemeClr val="accent1"/>
-          </a:fillRef>
-          <a:effectRef idx="0">
-            <a:schemeClr val="accent1"/>
-          </a:effectRef>
-          <a:fontRef idx="minor"/>
-        </p:style>
-        <p:txBody>
-          <a:bodyPr/>
-          <a:lstStyle/>
-          <a:p>
-            <a:endParaRPr lang="en-US"/>
-          </a:p>
-        </p:txBody>
-      </p:sp>
-      <p:sp>
-        <p:nvSpPr>
           <p:cNvPr id="403" name="CustomShape 39"/>
           <p:cNvSpPr/>
           <p:nvPr/>
@@ -21600,66 +21523,13 @@
       </p:sp>
       <p:sp>
         <p:nvSpPr>
-          <p:cNvPr id="405" name="CustomShape 41"/>
-          <p:cNvSpPr/>
-          <p:nvPr/>
-        </p:nvSpPr>
-        <p:spPr>
-          <a:xfrm flipV="1">
-            <a:off x="7139592" y="3899880"/>
-            <a:ext cx="360" cy="686880"/>
-          </a:xfrm>
-          <a:custGeom>
-            <a:avLst/>
-            <a:gdLst/>
-            <a:ahLst/>
-            <a:cxnLst/>
-            <a:rect l="l" t="t" r="r" b="b"/>
-            <a:pathLst>
-              <a:path w="21600" h="21600">
-                <a:moveTo>
-                  <a:pt x="0" y="0"/>
-                </a:moveTo>
-                <a:lnTo>
-                  <a:pt x="21600" y="21600"/>
-                </a:lnTo>
-              </a:path>
-            </a:pathLst>
-          </a:custGeom>
-          <a:noFill/>
-          <a:ln w="82440">
-            <a:tailEnd type="triangle" w="sm" len="med"/>
-          </a:ln>
-        </p:spPr>
-        <p:style>
-          <a:lnRef idx="1">
-            <a:schemeClr val="accent1"/>
-          </a:lnRef>
-          <a:fillRef idx="0">
-            <a:schemeClr val="accent1"/>
-          </a:fillRef>
-          <a:effectRef idx="0">
-            <a:schemeClr val="accent1"/>
-          </a:effectRef>
-          <a:fontRef idx="minor"/>
-        </p:style>
-        <p:txBody>
-          <a:bodyPr/>
-          <a:lstStyle/>
-          <a:p>
-            <a:endParaRPr lang="en-US"/>
-          </a:p>
-        </p:txBody>
-      </p:sp>
-      <p:sp>
-        <p:nvSpPr>
           <p:cNvPr id="407" name="CustomShape 43"/>
           <p:cNvSpPr/>
           <p:nvPr/>
         </p:nvSpPr>
         <p:spPr>
           <a:xfrm>
-            <a:off x="6729352" y="5327191"/>
+            <a:off x="7693829" y="5247176"/>
             <a:ext cx="887079" cy="644877"/>
           </a:xfrm>
           <a:prstGeom prst="rect">
@@ -21880,222 +21750,6 @@
               <a:latin typeface="Arial"/>
               <a:ea typeface="Microsoft YaHei"/>
             </a:endParaRPr>
-          </a:p>
-        </p:txBody>
-      </p:sp>
-      <p:sp>
-        <p:nvSpPr>
-          <p:cNvPr id="415" name="TextShape 51"/>
-          <p:cNvSpPr txBox="1"/>
-          <p:nvPr/>
-        </p:nvSpPr>
-        <p:spPr>
-          <a:xfrm>
-            <a:off x="6019272" y="6390360"/>
-            <a:ext cx="1247040" cy="364680"/>
-          </a:xfrm>
-          <a:prstGeom prst="rect">
-            <a:avLst/>
-          </a:prstGeom>
-          <a:noFill/>
-          <a:ln>
-            <a:noFill/>
-          </a:ln>
-        </p:spPr>
-        <p:txBody>
-          <a:bodyPr anchor="ctr">
-            <a:noAutofit/>
-          </a:bodyPr>
-          <a:lstStyle/>
-          <a:p>
-            <a:pPr>
-              <a:lnSpc>
-                <a:spcPct val="100000"/>
-              </a:lnSpc>
-            </a:pPr>
-            <a:fld id="{03AD6084-321B-4C1B-8ED5-E26BE9B8EDC4}" type="datetime1">
-              <a:rPr lang="en-US" sz="1200" b="0" strike="noStrike" spc="-1">
-                <a:solidFill>
-                  <a:srgbClr val="8B8B8B"/>
-                </a:solidFill>
-                <a:latin typeface="Calibri"/>
-              </a:rPr>
-              <a:t>1/3/2024</a:t>
-            </a:fld>
-            <a:endParaRPr lang="en-US" sz="1200" b="0" strike="noStrike" spc="-1">
-              <a:latin typeface="Times New Roman"/>
-            </a:endParaRPr>
-          </a:p>
-        </p:txBody>
-      </p:sp>
-      <p:sp>
-        <p:nvSpPr>
-          <p:cNvPr id="416" name="TextShape 52"/>
-          <p:cNvSpPr txBox="1"/>
-          <p:nvPr/>
-        </p:nvSpPr>
-        <p:spPr>
-          <a:xfrm>
-            <a:off x="833112" y="6390360"/>
-            <a:ext cx="2742840" cy="364680"/>
-          </a:xfrm>
-          <a:prstGeom prst="rect">
-            <a:avLst/>
-          </a:prstGeom>
-          <a:noFill/>
-          <a:ln>
-            <a:noFill/>
-          </a:ln>
-        </p:spPr>
-        <p:txBody>
-          <a:bodyPr anchor="ctr">
-            <a:noAutofit/>
-          </a:bodyPr>
-          <a:lstStyle/>
-          <a:p>
-            <a:pPr>
-              <a:lnSpc>
-                <a:spcPct val="100000"/>
-              </a:lnSpc>
-            </a:pPr>
-            <a:fld id="{D00192D6-550B-4022-A116-B4A4ACEE4BDA}" type="slidenum">
-              <a:rPr lang="en-US" sz="1200" b="0" strike="noStrike" spc="-1">
-                <a:solidFill>
-                  <a:srgbClr val="8B8B8B"/>
-                </a:solidFill>
-                <a:latin typeface="Calibri"/>
-              </a:rPr>
-              <a:t>25</a:t>
-            </a:fld>
-            <a:endParaRPr lang="en-US" sz="1200" b="0" strike="noStrike" spc="-1">
-              <a:latin typeface="Times New Roman"/>
-            </a:endParaRPr>
-          </a:p>
-        </p:txBody>
-      </p:sp>
-      <p:sp>
-        <p:nvSpPr>
-          <p:cNvPr id="417" name="CustomShape 53"/>
-          <p:cNvSpPr/>
-          <p:nvPr/>
-        </p:nvSpPr>
-        <p:spPr>
-          <a:xfrm>
-            <a:off x="6316272" y="4389120"/>
-            <a:ext cx="1646640" cy="646920"/>
-          </a:xfrm>
-          <a:prstGeom prst="rect">
-            <a:avLst/>
-          </a:prstGeom>
-          <a:solidFill>
-            <a:srgbClr val="DEDCE6"/>
-          </a:solidFill>
-          <a:ln w="9000">
-            <a:solidFill>
-              <a:srgbClr val="FFD74C"/>
-            </a:solidFill>
-            <a:round/>
-          </a:ln>
-        </p:spPr>
-        <p:style>
-          <a:lnRef idx="0">
-            <a:scrgbClr r="0" g="0" b="0"/>
-          </a:lnRef>
-          <a:fillRef idx="0">
-            <a:scrgbClr r="0" g="0" b="0"/>
-          </a:fillRef>
-          <a:effectRef idx="0">
-            <a:scrgbClr r="0" g="0" b="0"/>
-          </a:effectRef>
-          <a:fontRef idx="minor"/>
-        </p:style>
-        <p:txBody>
-          <a:bodyPr wrap="none" lIns="94320" tIns="49320" rIns="94320" bIns="49320">
-            <a:spAutoFit/>
-          </a:bodyPr>
-          <a:lstStyle/>
-          <a:p>
-            <a:pPr algn="ctr"/>
-            <a:r>
-              <a:rPr lang="en-US" sz="1800" b="0" strike="noStrike" spc="-1">
-                <a:solidFill>
-                  <a:srgbClr val="000000"/>
-                </a:solidFill>
-                <a:latin typeface="Arial"/>
-              </a:rPr>
-              <a:t>Azure Storage</a:t>
-            </a:r>
-            <a:br/>
-            <a:r>
-              <a:rPr lang="en-US" sz="1800" b="0" strike="noStrike" spc="-1">
-                <a:solidFill>
-                  <a:srgbClr val="000000"/>
-                </a:solidFill>
-                <a:latin typeface="Arial"/>
-              </a:rPr>
-              <a:t>Explorer</a:t>
-            </a:r>
-            <a:endParaRPr lang="en-US" sz="1800" b="0" strike="noStrike" spc="-1">
-              <a:solidFill>
-                <a:srgbClr val="000000"/>
-              </a:solidFill>
-              <a:latin typeface="Arial"/>
-              <a:ea typeface="Microsoft YaHei"/>
-            </a:endParaRPr>
-          </a:p>
-        </p:txBody>
-      </p:sp>
-      <p:sp>
-        <p:nvSpPr>
-          <p:cNvPr id="418" name="CustomShape 54"/>
-          <p:cNvSpPr/>
-          <p:nvPr/>
-        </p:nvSpPr>
-        <p:spPr>
-          <a:xfrm flipV="1">
-            <a:off x="7803792" y="4708080"/>
-            <a:ext cx="1645920" cy="15120"/>
-          </a:xfrm>
-          <a:custGeom>
-            <a:avLst/>
-            <a:gdLst/>
-            <a:ahLst/>
-            <a:cxnLst/>
-            <a:rect l="l" t="t" r="r" b="b"/>
-            <a:pathLst>
-              <a:path w="21600" h="21600">
-                <a:moveTo>
-                  <a:pt x="0" y="0"/>
-                </a:moveTo>
-                <a:lnTo>
-                  <a:pt x="21600" y="21600"/>
-                </a:lnTo>
-              </a:path>
-            </a:pathLst>
-          </a:custGeom>
-          <a:noFill/>
-          <a:ln w="82440">
-            <a:headEnd type="triangle" w="sm" len="med"/>
-            <a:tailEnd type="triangle" w="sm" len="med"/>
-          </a:ln>
-        </p:spPr>
-        <p:style>
-          <a:lnRef idx="1">
-            <a:schemeClr val="accent1"/>
-          </a:lnRef>
-          <a:fillRef idx="0">
-            <a:schemeClr val="accent1"/>
-          </a:fillRef>
-          <a:effectRef idx="0">
-            <a:schemeClr val="accent1"/>
-          </a:effectRef>
-          <a:fontRef idx="minor"/>
-        </p:style>
-        <p:txBody>
-          <a:bodyPr/>
-          <a:lstStyle/>
-          <a:p>
-            <a:endParaRPr lang="en-US"/>
           </a:p>
         </p:txBody>
       </p:sp>
@@ -22937,7 +22591,7 @@
           </p:cNvPicPr>
           <p:nvPr/>
         </p:nvPicPr>
-        <p:blipFill>
+        <p:blipFill rotWithShape="1">
           <a:blip r:embed="rId7">
             <a:clrChange>
               <a:clrFrom>
@@ -22955,29 +22609,26 @@
               </a:ext>
             </a:extLst>
           </a:blip>
-          <a:srcRect/>
-          <a:stretch>
-            <a:fillRect/>
-          </a:stretch>
+          <a:srcRect t="18843" b="2535"/>
+          <a:stretch/>
         </p:blipFill>
         <p:spPr bwMode="auto">
           <a:xfrm>
-            <a:off x="361465" y="1734059"/>
-            <a:ext cx="1712341" cy="963192"/>
-          </a:xfrm>
-          <a:prstGeom prst="rect">
-            <a:avLst/>
-          </a:prstGeom>
-          <a:noFill/>
-          <a:extLst>
-            <a:ext uri="{909E8E84-426E-40DD-AFC4-6F175D3DCCD1}">
-              <a14:hiddenFill xmlns:a14="http://schemas.microsoft.com/office/drawing/2010/main">
-                <a:solidFill>
-                  <a:srgbClr val="FFFFFF"/>
-                </a:solidFill>
-              </a14:hiddenFill>
-            </a:ext>
-          </a:extLst>
+            <a:off x="618137" y="1979728"/>
+            <a:ext cx="1712341" cy="757273"/>
+          </a:xfrm>
+          <a:prstGeom prst="rect">
+            <a:avLst/>
+          </a:prstGeom>
+          <a:solidFill>
+            <a:schemeClr val="bg1">
+              <a:lumMod val="85000"/>
+              <a:alpha val="70000"/>
+            </a:schemeClr>
+          </a:solidFill>
+          <a:effectLst>
+            <a:softEdge rad="50800"/>
+          </a:effectLst>
         </p:spPr>
       </p:pic>
       <p:cxnSp>
@@ -23270,6 +22921,267 @@
           </a:p>
         </p:txBody>
       </p:sp>
+      <p:sp>
+        <p:nvSpPr>
+          <p:cNvPr id="45" name="CustomShape 25">
+            <a:extLst>
+              <a:ext uri="{FF2B5EF4-FFF2-40B4-BE49-F238E27FC236}">
+                <a16:creationId xmlns:a16="http://schemas.microsoft.com/office/drawing/2014/main" id="{2716F078-679C-FA57-203D-A8290FF6FA86}"/>
+              </a:ext>
+            </a:extLst>
+          </p:cNvPr>
+          <p:cNvSpPr/>
+          <p:nvPr/>
+        </p:nvSpPr>
+        <p:spPr>
+          <a:xfrm>
+            <a:off x="509760" y="2412246"/>
+            <a:ext cx="2023203" cy="367878"/>
+          </a:xfrm>
+          <a:prstGeom prst="rect">
+            <a:avLst/>
+          </a:prstGeom>
+          <a:noFill/>
+          <a:ln>
+            <a:noFill/>
+          </a:ln>
+        </p:spPr>
+        <p:style>
+          <a:lnRef idx="0">
+            <a:scrgbClr r="0" g="0" b="0"/>
+          </a:lnRef>
+          <a:fillRef idx="0">
+            <a:scrgbClr r="0" g="0" b="0"/>
+          </a:fillRef>
+          <a:effectRef idx="0">
+            <a:scrgbClr r="0" g="0" b="0"/>
+          </a:effectRef>
+          <a:fontRef idx="minor"/>
+        </p:style>
+        <p:txBody>
+          <a:bodyPr wrap="square" lIns="90000" tIns="45000" rIns="90000" bIns="45000">
+            <a:spAutoFit/>
+          </a:bodyPr>
+          <a:lstStyle/>
+          <a:p>
+            <a:pPr algn="ctr">
+              <a:lnSpc>
+                <a:spcPct val="100000"/>
+              </a:lnSpc>
+            </a:pPr>
+            <a:r>
+              <a:rPr lang="en-US" b="1" spc="-1" dirty="0">
+                <a:solidFill>
+                  <a:srgbClr val="333333"/>
+                </a:solidFill>
+                <a:effectLst>
+                  <a:glow rad="228600">
+                    <a:schemeClr val="bg1">
+                      <a:alpha val="91000"/>
+                    </a:schemeClr>
+                  </a:glow>
+                </a:effectLst>
+                <a:latin typeface="Calibri"/>
+              </a:rPr>
+              <a:t>Cloud Host</a:t>
+            </a:r>
+          </a:p>
+        </p:txBody>
+      </p:sp>
+      <p:cxnSp>
+        <p:nvCxnSpPr>
+          <p:cNvPr id="46" name="Straight Connector 45">
+            <a:extLst>
+              <a:ext uri="{FF2B5EF4-FFF2-40B4-BE49-F238E27FC236}">
+                <a16:creationId xmlns:a16="http://schemas.microsoft.com/office/drawing/2014/main" id="{A660F88A-4866-B362-B10E-C1036E7180A7}"/>
+              </a:ext>
+            </a:extLst>
+          </p:cNvPr>
+          <p:cNvCxnSpPr>
+            <a:cxnSpLocks/>
+          </p:cNvCxnSpPr>
+          <p:nvPr/>
+        </p:nvCxnSpPr>
+        <p:spPr>
+          <a:xfrm>
+            <a:off x="8214856" y="4702726"/>
+            <a:ext cx="0" cy="574923"/>
+          </a:xfrm>
+          <a:prstGeom prst="line">
+            <a:avLst/>
+          </a:prstGeom>
+          <a:noFill/>
+          <a:ln w="82440">
+            <a:headEnd type="triangle" w="sm" len="med"/>
+          </a:ln>
+        </p:spPr>
+        <p:style>
+          <a:lnRef idx="1">
+            <a:schemeClr val="accent1"/>
+          </a:lnRef>
+          <a:fillRef idx="0">
+            <a:schemeClr val="accent1"/>
+          </a:fillRef>
+          <a:effectRef idx="0">
+            <a:schemeClr val="accent1"/>
+          </a:effectRef>
+          <a:fontRef idx="minor"/>
+        </p:style>
+      </p:cxnSp>
+      <p:cxnSp>
+        <p:nvCxnSpPr>
+          <p:cNvPr id="52" name="Straight Connector 51">
+            <a:extLst>
+              <a:ext uri="{FF2B5EF4-FFF2-40B4-BE49-F238E27FC236}">
+                <a16:creationId xmlns:a16="http://schemas.microsoft.com/office/drawing/2014/main" id="{558F5DD7-2865-7A01-B8AA-FC8F4E42C7C1}"/>
+              </a:ext>
+            </a:extLst>
+          </p:cNvPr>
+          <p:cNvCxnSpPr>
+            <a:cxnSpLocks/>
+          </p:cNvCxnSpPr>
+          <p:nvPr/>
+        </p:nvCxnSpPr>
+        <p:spPr>
+          <a:xfrm>
+            <a:off x="8214856" y="3962201"/>
+            <a:ext cx="0" cy="466222"/>
+          </a:xfrm>
+          <a:prstGeom prst="line">
+            <a:avLst/>
+          </a:prstGeom>
+          <a:noFill/>
+          <a:ln w="82440">
+            <a:headEnd type="triangle" w="sm" len="med"/>
+          </a:ln>
+        </p:spPr>
+        <p:style>
+          <a:lnRef idx="1">
+            <a:schemeClr val="accent1"/>
+          </a:lnRef>
+          <a:fillRef idx="0">
+            <a:schemeClr val="accent1"/>
+          </a:fillRef>
+          <a:effectRef idx="0">
+            <a:schemeClr val="accent1"/>
+          </a:effectRef>
+          <a:fontRef idx="minor"/>
+        </p:style>
+      </p:cxnSp>
+      <p:cxnSp>
+        <p:nvCxnSpPr>
+          <p:cNvPr id="55" name="Straight Connector 54">
+            <a:extLst>
+              <a:ext uri="{FF2B5EF4-FFF2-40B4-BE49-F238E27FC236}">
+                <a16:creationId xmlns:a16="http://schemas.microsoft.com/office/drawing/2014/main" id="{25FE9F3A-A24D-5427-65B5-F527C96B5D97}"/>
+              </a:ext>
+            </a:extLst>
+          </p:cNvPr>
+          <p:cNvCxnSpPr>
+            <a:cxnSpLocks/>
+          </p:cNvCxnSpPr>
+          <p:nvPr/>
+        </p:nvCxnSpPr>
+        <p:spPr>
+          <a:xfrm flipH="1">
+            <a:off x="8728200" y="4696127"/>
+            <a:ext cx="698394" cy="0"/>
+          </a:xfrm>
+          <a:prstGeom prst="line">
+            <a:avLst/>
+          </a:prstGeom>
+          <a:noFill/>
+          <a:ln w="82440">
+            <a:headEnd type="triangle" w="sm" len="med"/>
+          </a:ln>
+        </p:spPr>
+        <p:style>
+          <a:lnRef idx="1">
+            <a:schemeClr val="accent1"/>
+          </a:lnRef>
+          <a:fillRef idx="0">
+            <a:schemeClr val="accent1"/>
+          </a:fillRef>
+          <a:effectRef idx="0">
+            <a:schemeClr val="accent1"/>
+          </a:effectRef>
+          <a:fontRef idx="minor"/>
+        </p:style>
+      </p:cxnSp>
+      <p:sp>
+        <p:nvSpPr>
+          <p:cNvPr id="417" name="CustomShape 53"/>
+          <p:cNvSpPr/>
+          <p:nvPr/>
+        </p:nvSpPr>
+        <p:spPr>
+          <a:xfrm>
+            <a:off x="7246713" y="4389120"/>
+            <a:ext cx="1646640" cy="646920"/>
+          </a:xfrm>
+          <a:prstGeom prst="rect">
+            <a:avLst/>
+          </a:prstGeom>
+          <a:solidFill>
+            <a:srgbClr val="DEDCE6"/>
+          </a:solidFill>
+          <a:ln w="9000">
+            <a:solidFill>
+              <a:srgbClr val="FFD74C"/>
+            </a:solidFill>
+            <a:round/>
+          </a:ln>
+        </p:spPr>
+        <p:style>
+          <a:lnRef idx="0">
+            <a:scrgbClr r="0" g="0" b="0"/>
+          </a:lnRef>
+          <a:fillRef idx="0">
+            <a:scrgbClr r="0" g="0" b="0"/>
+          </a:fillRef>
+          <a:effectRef idx="0">
+            <a:scrgbClr r="0" g="0" b="0"/>
+          </a:effectRef>
+          <a:fontRef idx="minor"/>
+        </p:style>
+        <p:txBody>
+          <a:bodyPr wrap="none" lIns="94320" tIns="49320" rIns="94320" bIns="49320">
+            <a:spAutoFit/>
+          </a:bodyPr>
+          <a:lstStyle/>
+          <a:p>
+            <a:pPr algn="ctr"/>
+            <a:r>
+              <a:rPr lang="en-US" sz="1800" b="0" strike="noStrike" spc="-1" dirty="0">
+                <a:solidFill>
+                  <a:srgbClr val="000000"/>
+                </a:solidFill>
+                <a:latin typeface="Arial"/>
+              </a:rPr>
+              <a:t>Azure Storage</a:t>
+            </a:r>
+            <a:br>
+              <a:rPr dirty="0"/>
+            </a:br>
+            <a:r>
+              <a:rPr lang="en-US" sz="1800" b="0" strike="noStrike" spc="-1" dirty="0">
+                <a:solidFill>
+                  <a:srgbClr val="000000"/>
+                </a:solidFill>
+                <a:latin typeface="Arial"/>
+              </a:rPr>
+              <a:t>Explorer</a:t>
+            </a:r>
+            <a:endParaRPr lang="en-US" sz="1800" b="0" strike="noStrike" spc="-1" dirty="0">
+              <a:solidFill>
+                <a:srgbClr val="000000"/>
+              </a:solidFill>
+              <a:latin typeface="Arial"/>
+              <a:ea typeface="Microsoft YaHei"/>
+            </a:endParaRPr>
+          </a:p>
+        </p:txBody>
+      </p:sp>
     </p:spTree>
   </p:cSld>
   <p:clrMapOvr>
@@ -23364,7 +23276,7 @@
         <p:spPr>
           <a:xfrm>
             <a:off x="370800" y="835920"/>
-            <a:ext cx="3709080" cy="5958360"/>
+            <a:ext cx="3709080" cy="6292577"/>
           </a:xfrm>
           <a:prstGeom prst="rect">
             <a:avLst/>
@@ -23450,7 +23362,7 @@
                 </a:solidFill>
                 <a:latin typeface="Agency FB"/>
               </a:rPr>
-              <a:t>Is responsible for the long term viability of the Omeka installation.</a:t>
+              <a:t>Is responsible for the long term viability of the Omeka installation and all associated assets.</a:t>
             </a:r>
             <a:endParaRPr lang="en-US" sz="1800" b="0" strike="noStrike" spc="-1" dirty="0">
               <a:solidFill>

</xml_diff>

<commit_message>
modified:   docker/index.htm 	modified:   resources/cdash_includes.js 	modified:   slideshow/CDashSlideshow_20230109.pptx 	modified:   stewardship/index.htm 	assets/ 	slideshow/CDashSlideshow_20240109.pptx 	slideshow/~$CDashSlideshow_20240109.pptx
</commit_message>
<xml_diff>
--- a/slideshow/CDashSlideshow_20230109.pptx
+++ b/slideshow/CDashSlideshow_20230109.pptx
@@ -4812,7 +4812,7 @@
                 </a:solidFill>
                 <a:latin typeface="Calibri"/>
               </a:rPr>
-              <a:t>1/3/2024</a:t>
+              <a:t>1/5/2024</a:t>
             </a:fld>
             <a:endParaRPr lang="en-US" sz="1200" b="0" strike="noStrike" spc="-1">
               <a:latin typeface="Times New Roman"/>
@@ -5684,7 +5684,7 @@
                 </a:solidFill>
                 <a:latin typeface="Calibri"/>
               </a:rPr>
-              <a:t>1/3/2024</a:t>
+              <a:t>1/5/2024</a:t>
             </a:fld>
             <a:endParaRPr lang="en-US" sz="1200" b="0" strike="noStrike" spc="-1">
               <a:latin typeface="Times New Roman"/>
@@ -6182,7 +6182,7 @@
                 </a:solidFill>
                 <a:latin typeface="Calibri"/>
               </a:rPr>
-              <a:t>1/3/2024</a:t>
+              <a:t>1/5/2024</a:t>
             </a:fld>
             <a:endParaRPr lang="en-US" sz="1200" b="0" strike="noStrike" spc="-1">
               <a:latin typeface="Times New Roman"/>
@@ -7205,7 +7205,7 @@
                 </a:solidFill>
                 <a:latin typeface="Calibri"/>
               </a:rPr>
-              <a:t>1/3/2024</a:t>
+              <a:t>1/5/2024</a:t>
             </a:fld>
             <a:endParaRPr lang="en-US" sz="1200" b="0" strike="noStrike" spc="-1">
               <a:latin typeface="Times New Roman"/>
@@ -10532,7 +10532,7 @@
                 </a:solidFill>
                 <a:latin typeface="Calibri"/>
               </a:rPr>
-              <a:t>1/3/2024</a:t>
+              <a:t>1/5/2024</a:t>
             </a:fld>
             <a:endParaRPr lang="en-US" sz="1200" b="0" strike="noStrike" spc="-1">
               <a:latin typeface="Times New Roman"/>
@@ -13255,7 +13255,7 @@
                 </a:solidFill>
                 <a:latin typeface="Calibri"/>
               </a:rPr>
-              <a:t>1/3/2024</a:t>
+              <a:t>1/5/2024</a:t>
             </a:fld>
             <a:endParaRPr lang="en-US" sz="1200" b="0" strike="noStrike" spc="-1">
               <a:latin typeface="Times New Roman"/>
@@ -14494,7 +14494,7 @@
                 </a:solidFill>
                 <a:latin typeface="Calibri"/>
               </a:rPr>
-              <a:t>1/3/2024</a:t>
+              <a:t>1/5/2024</a:t>
             </a:fld>
             <a:endParaRPr lang="en-US" sz="1200" b="0" strike="noStrike" spc="-1">
               <a:latin typeface="Times New Roman"/>
@@ -15361,7 +15361,7 @@
                 </a:solidFill>
                 <a:latin typeface="Calibri"/>
               </a:rPr>
-              <a:t>1/3/2024</a:t>
+              <a:t>1/5/2024</a:t>
             </a:fld>
             <a:endParaRPr lang="en-US" sz="1200" b="0" strike="noStrike" spc="-1">
               <a:latin typeface="Times New Roman"/>
@@ -17172,7 +17172,7 @@
                 </a:solidFill>
                 <a:latin typeface="Calibri"/>
               </a:rPr>
-              <a:t>1/3/2024</a:t>
+              <a:t>1/5/2024</a:t>
             </a:fld>
             <a:endParaRPr lang="en-US" sz="1200" b="0" strike="noStrike" spc="-1">
               <a:latin typeface="Times New Roman"/>
@@ -19125,7 +19125,7 @@
                 </a:solidFill>
                 <a:latin typeface="Calibri"/>
               </a:rPr>
-              <a:t>1/3/2024</a:t>
+              <a:t>1/5/2024</a:t>
             </a:fld>
             <a:endParaRPr lang="en-US" sz="1200" b="0" strike="noStrike" spc="-1">
               <a:latin typeface="Times New Roman"/>
@@ -19354,10 +19354,10 @@
         </p:nvGrpSpPr>
         <p:grpSpPr>
           <a:xfrm>
-            <a:off x="-13367" y="718560"/>
-            <a:ext cx="12303419" cy="5839200"/>
-            <a:chOff x="-13367" y="718560"/>
-            <a:chExt cx="12303419" cy="5839200"/>
+            <a:off x="-12311" y="718560"/>
+            <a:ext cx="12004991" cy="5839200"/>
+            <a:chOff x="-12311" y="718560"/>
+            <a:chExt cx="12004991" cy="5839200"/>
           </a:xfrm>
         </p:grpSpPr>
         <p:sp>
@@ -19468,8 +19468,8 @@
           </p:nvSpPr>
           <p:spPr>
             <a:xfrm rot="306055">
-              <a:off x="-13367" y="1987623"/>
-              <a:ext cx="12303419" cy="3008160"/>
+              <a:off x="-12311" y="1963919"/>
+              <a:ext cx="11770207" cy="3008160"/>
             </a:xfrm>
             <a:prstGeom prst="cloud">
               <a:avLst/>
@@ -20907,7 +20907,7 @@
         </p:nvSpPr>
         <p:spPr>
           <a:xfrm>
-            <a:off x="886646" y="5284878"/>
+            <a:off x="897558" y="5337644"/>
             <a:ext cx="1522959" cy="367878"/>
           </a:xfrm>
           <a:prstGeom prst="rect">
@@ -20967,8 +20967,8 @@
         </p:nvSpPr>
         <p:spPr>
           <a:xfrm>
-            <a:off x="2554149" y="5258601"/>
-            <a:ext cx="1834967" cy="921876"/>
+            <a:off x="2568246" y="5330481"/>
+            <a:ext cx="1785658" cy="644877"/>
           </a:xfrm>
           <a:prstGeom prst="rect">
             <a:avLst/>
@@ -21001,41 +21001,6 @@
                 <a:spcPct val="100000"/>
               </a:lnSpc>
             </a:pPr>
-            <a:r>
-              <a:rPr lang="en-US" sz="1800" b="1" strike="noStrike" spc="-1" dirty="0">
-                <a:solidFill>
-                  <a:srgbClr val="000000"/>
-                </a:solidFill>
-                <a:latin typeface="Calibri"/>
-              </a:rPr>
-              <a:t>Passwords</a:t>
-            </a:r>
-            <a:r>
-              <a:rPr lang="en-US" spc="-1" dirty="0">
-                <a:solidFill>
-                  <a:srgbClr val="000000"/>
-                </a:solidFill>
-                <a:latin typeface="Arial"/>
-              </a:rPr>
-              <a:t>, </a:t>
-            </a:r>
-            <a:r>
-              <a:rPr lang="en-US" b="1" spc="-1" dirty="0">
-                <a:solidFill>
-                  <a:srgbClr val="000000"/>
-                </a:solidFill>
-                <a:latin typeface="Calibri"/>
-              </a:rPr>
-              <a:t>Docs</a:t>
-            </a:r>
-            <a:br>
-              <a:rPr lang="en-US" b="1" spc="-1" dirty="0">
-                <a:solidFill>
-                  <a:srgbClr val="000000"/>
-                </a:solidFill>
-                <a:latin typeface="Calibri"/>
-              </a:rPr>
-            </a:br>
             <a:r>
               <a:rPr lang="en-US" b="1" spc="-1" dirty="0">
                 <a:solidFill>
@@ -22391,7 +22356,7 @@
         </p:nvGrpSpPr>
         <p:grpSpPr>
           <a:xfrm>
-            <a:off x="4952095" y="2857061"/>
+            <a:off x="4949474" y="2843743"/>
             <a:ext cx="1257451" cy="1091633"/>
             <a:chOff x="3651835" y="-1439753"/>
             <a:chExt cx="1257451" cy="1091633"/>
@@ -24363,7 +24328,7 @@
                 </a:solidFill>
                 <a:latin typeface="Calibri"/>
               </a:rPr>
-              <a:t>1/3/2024</a:t>
+              <a:t>1/5/2024</a:t>
             </a:fld>
             <a:endParaRPr lang="en-US" sz="1200" b="0" strike="noStrike" spc="-1">
               <a:latin typeface="Times New Roman"/>
@@ -24923,7 +24888,7 @@
                 </a:solidFill>
                 <a:latin typeface="Calibri"/>
               </a:rPr>
-              <a:t>1/3/2024</a:t>
+              <a:t>1/5/2024</a:t>
             </a:fld>
             <a:endParaRPr lang="en-US" sz="1200" b="0" strike="noStrike" spc="-1">
               <a:latin typeface="Times New Roman"/>
@@ -25710,7 +25675,7 @@
                 </a:solidFill>
                 <a:latin typeface="Calibri"/>
               </a:rPr>
-              <a:t>1/3/2024</a:t>
+              <a:t>1/5/2024</a:t>
             </a:fld>
             <a:endParaRPr lang="en-US" sz="1200" b="0" strike="noStrike" spc="-1">
               <a:latin typeface="Times New Roman"/>
@@ -26142,7 +26107,7 @@
                 </a:solidFill>
                 <a:latin typeface="Calibri"/>
               </a:rPr>
-              <a:t>1/3/2024</a:t>
+              <a:t>1/5/2024</a:t>
             </a:fld>
             <a:endParaRPr lang="en-US" sz="1200" b="0" strike="noStrike" spc="-1">
               <a:latin typeface="Times New Roman"/>
@@ -26500,7 +26465,7 @@
                 </a:solidFill>
                 <a:latin typeface="Calibri"/>
               </a:rPr>
-              <a:t>1/3/2024</a:t>
+              <a:t>1/5/2024</a:t>
             </a:fld>
             <a:endParaRPr lang="en-US" sz="1200" b="0" strike="noStrike" spc="-1">
               <a:latin typeface="Times New Roman"/>
@@ -28361,7 +28326,7 @@
                 </a:solidFill>
                 <a:latin typeface="Calibri"/>
               </a:rPr>
-              <a:t>1/3/2024</a:t>
+              <a:t>1/5/2024</a:t>
             </a:fld>
             <a:endParaRPr lang="en-US" sz="1200" b="0" strike="noStrike" spc="-1">
               <a:latin typeface="Times New Roman"/>
@@ -28837,7 +28802,7 @@
                 </a:solidFill>
                 <a:latin typeface="Calibri"/>
               </a:rPr>
-              <a:t>1/3/2024</a:t>
+              <a:t>1/5/2024</a:t>
             </a:fld>
             <a:endParaRPr lang="en-US" sz="1200" b="0" strike="noStrike" spc="-1">
               <a:latin typeface="Times New Roman"/>
@@ -32301,7 +32266,7 @@
                 </a:solidFill>
                 <a:latin typeface="Calibri"/>
               </a:rPr>
-              <a:t>1/3/2024</a:t>
+              <a:t>1/5/2024</a:t>
             </a:fld>
             <a:endParaRPr lang="en-US" sz="1200" b="0" strike="noStrike" spc="-1">
               <a:latin typeface="Times New Roman"/>
@@ -32775,7 +32740,7 @@
                 </a:solidFill>
                 <a:latin typeface="Calibri"/>
               </a:rPr>
-              <a:t>1/3/2024</a:t>
+              <a:t>1/5/2024</a:t>
             </a:fld>
             <a:endParaRPr lang="en-US" sz="1200" b="0" strike="noStrike" spc="-1">
               <a:latin typeface="Times New Roman"/>

</xml_diff>